<commit_message>
refactor: clean presentation UI with Tailwind CSS, remove academic rubrics, executive styling
</commit_message>
<xml_diff>
--- a/HorizonU_Uniform_UniStock_SCM_Presentasi_Technospark.pptx
+++ b/HorizonU_Uniform_UniStock_SCM_Presentasi_Technospark.pptx
@@ -509,7 +509,7 @@
           <a:lstStyle/>
           <a:p>
             <a:r>
-              <a:t>NASKAH BACA PRESENTER SLIDE 1 (Target Waktu: 01:10 Menit):</a:t>
+              <a:t>NASKAH BACA PRESENTER SLIDE 1 (Target: 01:10 Menit):</a:t>
             </a:r>
           </a:p>
           <a:p>
@@ -596,7 +596,7 @@
           <a:lstStyle/>
           <a:p>
             <a:r>
-              <a:t>NASKAH BACA PRESENTER SLIDE 2 (Target Waktu: 01:15 Menit):</a:t>
+              <a:t>NASKAH BACA PRESENTER SLIDE 2 (Target: 01:15 Menit):</a:t>
             </a:r>
           </a:p>
           <a:p>
@@ -698,7 +698,7 @@
           <a:lstStyle/>
           <a:p>
             <a:r>
-              <a:t>NASKAH BACA PRESENTER SLIDE 3 (Target Waktu: 01:30 Menit):</a:t>
+              <a:t>NASKAH BACA PRESENTER SLIDE 3 (Target: 01:30 Menit):</a:t>
             </a:r>
           </a:p>
           <a:p>
@@ -797,7 +797,7 @@
           <a:lstStyle/>
           <a:p>
             <a:r>
-              <a:t>NASKAH BACA PRESENTER SLIDE 4 (Target Waktu: 01:15 Menit):</a:t>
+              <a:t>NASKAH BACA PRESENTER SLIDE 4 (Target: 01:15 Menit):</a:t>
             </a:r>
           </a:p>
           <a:p>
@@ -899,7 +899,7 @@
           <a:lstStyle/>
           <a:p>
             <a:r>
-              <a:t>NASKAH BACA PRESENTER SLIDE 5 (Target Waktu: 01:30 Menit):</a:t>
+              <a:t>NASKAH BACA PRESENTER SLIDE 5 (Target: 01:30 Menit):</a:t>
             </a:r>
           </a:p>
           <a:p>
@@ -998,7 +998,7 @@
           <a:lstStyle/>
           <a:p>
             <a:r>
-              <a:t>NASKAH BACA PRESENTER SLIDE 6 (Target Waktu: 01:25 Menit):</a:t>
+              <a:t>NASKAH BACA PRESENTER SLIDE 6 (Target: 01:25 Menit):</a:t>
             </a:r>
           </a:p>
           <a:p>
@@ -1103,7 +1103,7 @@
           <a:lstStyle/>
           <a:p>
             <a:r>
-              <a:t>NASKAH BACA PRESENTER SLIDE 7 (Target Waktu: 01:15 Menit):</a:t>
+              <a:t>NASKAH BACA PRESENTER SLIDE 7 (Target: 01:15 Menit):</a:t>
             </a:r>
           </a:p>
           <a:p>
@@ -1205,7 +1205,7 @@
           <a:lstStyle/>
           <a:p>
             <a:r>
-              <a:t>NASKAH BACA PRESENTER SLIDE 8 (Target Waktu: 00:55 Menit):</a:t>
+              <a:t>NASKAH BACA PRESENTER SLIDE 8 (Target: 00:55 Menit):</a:t>
             </a:r>
           </a:p>
           <a:p>
@@ -4260,8 +4260,8 @@
         </p:nvSpPr>
         <p:spPr>
           <a:xfrm>
-            <a:off x="731520" y="365760"/>
-            <a:ext cx="73152" cy="777240"/>
+            <a:off x="731520" y="384048"/>
+            <a:ext cx="54864" cy="713232"/>
           </a:xfrm>
           <a:prstGeom prst="rect">
             <a:avLst/>
@@ -4303,7 +4303,79 @@
         </p:nvSpPr>
         <p:spPr>
           <a:xfrm>
-            <a:off x="914400" y="320040"/>
+            <a:off x="868680" y="347472"/>
+            <a:ext cx="10515600" cy="219456"/>
+          </a:xfrm>
+          <a:prstGeom prst="rect">
+            <a:avLst/>
+          </a:prstGeom>
+          <a:noFill/>
+        </p:spPr>
+        <p:txBody>
+          <a:bodyPr wrap="square">
+            <a:spAutoFit/>
+          </a:bodyPr>
+          <a:lstStyle/>
+          <a:p>
+            <a:pPr>
+              <a:defRPr sz="950" b="1">
+                <a:solidFill>
+                  <a:srgbClr val="980517"/>
+                </a:solidFill>
+                <a:latin typeface="Arial"/>
+              </a:defRPr>
+            </a:pPr>
+            <a:r>
+              <a:t>UNIVERSITAS HORIZON INDONESIA • DEPARTEMEN KEUANGAN</a:t>
+            </a:r>
+          </a:p>
+        </p:txBody>
+      </p:sp>
+      <p:sp>
+        <p:nvSpPr>
+          <p:cNvPr id="4" name="TextBox 3"/>
+          <p:cNvSpPr txBox="1"/>
+          <p:nvPr/>
+        </p:nvSpPr>
+        <p:spPr>
+          <a:xfrm>
+            <a:off x="868680" y="548640"/>
+            <a:ext cx="10515600" cy="384048"/>
+          </a:xfrm>
+          <a:prstGeom prst="rect">
+            <a:avLst/>
+          </a:prstGeom>
+          <a:noFill/>
+        </p:spPr>
+        <p:txBody>
+          <a:bodyPr wrap="square">
+            <a:spAutoFit/>
+          </a:bodyPr>
+          <a:lstStyle/>
+          <a:p>
+            <a:pPr>
+              <a:defRPr sz="1900" b="1">
+                <a:solidFill>
+                  <a:srgbClr val="0F172A"/>
+                </a:solidFill>
+                <a:latin typeface="Arial"/>
+              </a:defRPr>
+            </a:pPr>
+            <a:r>
+              <a:t>HorizonU Uniform: Transformasi Rantai Pasok Seragam Mahasiswa</a:t>
+            </a:r>
+          </a:p>
+        </p:txBody>
+      </p:sp>
+      <p:sp>
+        <p:nvSpPr>
+          <p:cNvPr id="5" name="TextBox 4"/>
+          <p:cNvSpPr txBox="1"/>
+          <p:nvPr/>
+        </p:nvSpPr>
+        <p:spPr>
+          <a:xfrm>
+            <a:off x="868680" y="932688"/>
             <a:ext cx="10515600" cy="256032"/>
           </a:xfrm>
           <a:prstGeom prst="rect">
@@ -4318,79 +4390,7 @@
           <a:lstStyle/>
           <a:p>
             <a:pPr>
-              <a:defRPr sz="1000" b="1">
-                <a:solidFill>
-                  <a:srgbClr val="980517"/>
-                </a:solidFill>
-                <a:latin typeface="Arial"/>
-              </a:defRPr>
-            </a:pPr>
-            <a:r>
-              <a:t>SLIDE 1 • CASE INTRODUCTION   |   RUBRIK: SUPPLY CHAIN UNDERSTANDING (15%)</a:t>
-            </a:r>
-          </a:p>
-        </p:txBody>
-      </p:sp>
-      <p:sp>
-        <p:nvSpPr>
-          <p:cNvPr id="4" name="TextBox 3"/>
-          <p:cNvSpPr txBox="1"/>
-          <p:nvPr/>
-        </p:nvSpPr>
-        <p:spPr>
-          <a:xfrm>
-            <a:off x="914400" y="548640"/>
-            <a:ext cx="10515600" cy="411480"/>
-          </a:xfrm>
-          <a:prstGeom prst="rect">
-            <a:avLst/>
-          </a:prstGeom>
-          <a:noFill/>
-        </p:spPr>
-        <p:txBody>
-          <a:bodyPr wrap="square">
-            <a:spAutoFit/>
-          </a:bodyPr>
-          <a:lstStyle/>
-          <a:p>
-            <a:pPr>
-              <a:defRPr sz="2000" b="1">
-                <a:solidFill>
-                  <a:srgbClr val="0F172A"/>
-                </a:solidFill>
-                <a:latin typeface="Arial"/>
-              </a:defRPr>
-            </a:pPr>
-            <a:r>
-              <a:t>HORIZONU UNIFORM (UNISTOCK SCM) — TRANSFORMASI LOGISTIK KAMPUS</a:t>
-            </a:r>
-          </a:p>
-        </p:txBody>
-      </p:sp>
-      <p:sp>
-        <p:nvSpPr>
-          <p:cNvPr id="5" name="TextBox 4"/>
-          <p:cNvSpPr txBox="1"/>
-          <p:nvPr/>
-        </p:nvSpPr>
-        <p:spPr>
-          <a:xfrm>
-            <a:off x="914400" y="960120"/>
-            <a:ext cx="10515600" cy="274320"/>
-          </a:xfrm>
-          <a:prstGeom prst="rect">
-            <a:avLst/>
-          </a:prstGeom>
-          <a:noFill/>
-        </p:spPr>
-        <p:txBody>
-          <a:bodyPr wrap="square">
-            <a:spAutoFit/>
-          </a:bodyPr>
-          <a:lstStyle/>
-          <a:p>
-            <a:pPr>
-              <a:defRPr sz="1150">
+              <a:defRPr sz="1100">
                 <a:solidFill>
                   <a:srgbClr val="475569"/>
                 </a:solidFill>
@@ -4398,7 +4398,7 @@
               </a:defRPr>
             </a:pPr>
             <a:r>
-              <a:t>Sistem Persediaan &amp; Distribusi Seragam Terpadu Berbasis Closed-Loop SCM pada Departemen Keuangan Universitas Horizon Indonesia</a:t>
+              <a:t>Modernisasi Pengadaan, Tata Kelola Stok FIFO, dan Distribusi Berbasis Web Terintegrasi</a:t>
             </a:r>
           </a:p>
         </p:txBody>
@@ -4411,8 +4411,8 @@
         </p:nvSpPr>
         <p:spPr>
           <a:xfrm>
-            <a:off x="731520" y="1261872"/>
-            <a:ext cx="10728655" cy="13716"/>
+            <a:off x="731520" y="1243584"/>
+            <a:ext cx="10728655" cy="10972"/>
           </a:xfrm>
           <a:prstGeom prst="rect">
             <a:avLst/>
@@ -4496,15 +4496,15 @@
               </a:defRPr>
             </a:pPr>
             <a:r>
-              <a:t>01 • PROFIL BISNIS &amp; INDUSTRI</a:t>
+              <a:t>PROFIL INSTITUSI &amp; OBJEK</a:t>
             </a:r>
           </a:p>
           <a:p>
             <a:pPr>
               <a:spcAft>
-                <a:spcPts val="600"/>
+                <a:spcPts val="500"/>
               </a:spcAft>
-              <a:defRPr sz="1300" b="1">
+              <a:defRPr sz="1250" b="1">
                 <a:solidFill>
                   <a:srgbClr val="0F172A"/>
                 </a:solidFill>
@@ -4518,7 +4518,7 @@
           <a:p>
             <a:pPr>
               <a:spcAft>
-                <a:spcPts val="400"/>
+                <a:spcPts val="300"/>
               </a:spcAft>
               <a:defRPr sz="1050">
                 <a:solidFill>
@@ -4528,13 +4528,13 @@
               </a:defRPr>
             </a:pPr>
             <a:r>
-              <a:t>•  Departemen Keuangan Universitas Horizon Indonesia mengelola pengadaan, akuntansi, dan pembagian paket seragam bagi ribuan mahasiswa baru.</a:t>
+              <a:t>•  Departemen Keuangan mengelola siklus pengadaan, pencatatan keuangan, dan distribusi perlengkapan maba.</a:t>
             </a:r>
           </a:p>
           <a:p>
             <a:pPr>
               <a:spcAft>
-                <a:spcPts val="400"/>
+                <a:spcPts val="300"/>
               </a:spcAft>
               <a:defRPr sz="1050">
                 <a:solidFill>
@@ -4544,13 +4544,13 @@
               </a:defRPr>
             </a:pPr>
             <a:r>
-              <a:t>•  Komoditas: Jas Almamater, Kemeja Putih, Celana/Rok Bahan, Sepatu Lab &amp; Dinas, serta Medical Kit keperawatan/kebidanan.</a:t>
+              <a:t>•  Komoditas: Jas Almamater, Kemeja Putih, Celana/Rok Bahan, Sepatu Lab &amp; Dinas, serta Medical Kit.</a:t>
             </a:r>
           </a:p>
           <a:p>
             <a:pPr>
               <a:spcAft>
-                <a:spcPts val="400"/>
+                <a:spcPts val="300"/>
               </a:spcAft>
               <a:defRPr sz="1050">
                 <a:solidFill>
@@ -4560,7 +4560,7 @@
               </a:defRPr>
             </a:pPr>
             <a:r>
-              <a:t>•  Karakteristik Operasional: Lonjakan penerimaan barang dari vendor garmen di awal tahun akademik.</a:t>
+              <a:t>•  Karakteristik: Penyaluran langsung ke ribuan mahasiswa baru tanpa perantara ritel komersial.</a:t>
             </a:r>
           </a:p>
           <a:p>
@@ -4576,7 +4576,7 @@
               </a:defRPr>
             </a:pPr>
             <a:r>
-              <a:t>➔  Model Bisnis: Direct Closed-Loop Campus SCM</a:t>
+              <a:t>➔  Model: Direct Closed-Loop Campus SCM</a:t>
             </a:r>
           </a:p>
         </p:txBody>
@@ -4631,15 +4631,15 @@
               </a:defRPr>
             </a:pPr>
             <a:r>
-              <a:t>02 • MASALAH UTAMA AS-IS</a:t>
+              <a:t>KENDALA OPERASIONAL UTAMA</a:t>
             </a:r>
           </a:p>
           <a:p>
             <a:pPr>
               <a:spcAft>
-                <a:spcPts val="600"/>
+                <a:spcPts val="500"/>
               </a:spcAft>
-              <a:defRPr sz="1300" b="1">
+              <a:defRPr sz="1250" b="1">
                 <a:solidFill>
                   <a:srgbClr val="0F172A"/>
                 </a:solidFill>
@@ -4647,13 +4647,13 @@
               </a:defRPr>
             </a:pPr>
             <a:r>
-              <a:t>Kendala Spreadsheet &amp; Loket</a:t>
+              <a:t>Hambatan Spreadsheet &amp; Posko</a:t>
             </a:r>
           </a:p>
           <a:p>
             <a:pPr>
               <a:spcAft>
-                <a:spcPts val="400"/>
+                <a:spcPts val="300"/>
               </a:spcAft>
               <a:defRPr sz="1050">
                 <a:solidFill>
@@ -4663,13 +4663,13 @@
               </a:defRPr>
             </a:pPr>
             <a:r>
-              <a:t>•  Spreadsheet Excel Induk raksasa (~4.5 MB, 19 lembar kerja) sering mengalami lag, tidak merespons, atau crash saat data membesar.</a:t>
+              <a:t>•  Spreadsheet Excel Induk (~4.5 MB, 19 sheet) sering mengalami lag atau crash saat data membesar.</a:t>
             </a:r>
           </a:p>
           <a:p>
             <a:pPr>
               <a:spcAft>
-                <a:spcPts val="400"/>
+                <a:spcPts val="300"/>
               </a:spcAft>
               <a:defRPr sz="1050">
                 <a:solidFill>
@@ -4679,13 +4679,13 @@
               </a:defRPr>
             </a:pPr>
             <a:r>
-              <a:t>•  Antrean pembagian di posko kampus sangat panjang (mencapai 15–20 menit per mahasiswa) akibat verifikasi berkas manual.</a:t>
+              <a:t>•  Antrean di posko kampus sangat lambat (15–20 menit per mahasiswa) akibat verifikasi berkas manual.</a:t>
             </a:r>
           </a:p>
           <a:p>
             <a:pPr>
               <a:spcAft>
-                <a:spcPts val="400"/>
+                <a:spcPts val="300"/>
               </a:spcAft>
               <a:defRPr sz="1050">
                 <a:solidFill>
@@ -4695,7 +4695,7 @@
               </a:defRPr>
             </a:pPr>
             <a:r>
-              <a:t>•  Pemesanan seragam ke pabrik hanya berdasar tebakan historis tanpa profiling ukuran awal, memicu penumpukan dead-stock di gudang.</a:t>
+              <a:t>•  Pemesanan seragam ke pabrik hanya estimasi historis tanpa survey ukuran mandiri, memicu dead-stock.</a:t>
             </a:r>
           </a:p>
           <a:p>
@@ -4711,7 +4711,7 @@
               </a:defRPr>
             </a:pPr>
             <a:r>
-              <a:t>➔  Dampak Finansial: Modal Mengendap &amp; Risiko Klaim Ganda</a:t>
+              <a:t>➔  Dampak: Modal Mengendap &amp; Risiko Klaim Ganda</a:t>
             </a:r>
           </a:p>
         </p:txBody>
@@ -4766,15 +4766,15 @@
               </a:defRPr>
             </a:pPr>
             <a:r>
-              <a:t>03 • PRESENTER &amp; ANALIS</a:t>
+              <a:t>TIM PENGEMBANG</a:t>
             </a:r>
           </a:p>
           <a:p>
             <a:pPr>
               <a:spcAft>
-                <a:spcPts val="600"/>
+                <a:spcPts val="500"/>
               </a:spcAft>
-              <a:defRPr sz="1300" b="1">
+              <a:defRPr sz="1250" b="1">
                 <a:solidFill>
                   <a:srgbClr val="0F172A"/>
                 </a:solidFill>
@@ -4782,13 +4782,13 @@
               </a:defRPr>
             </a:pPr>
             <a:r>
-              <a:t>Tim Pengembang Nirwana</a:t>
+              <a:t>Nirwana Development Team</a:t>
             </a:r>
           </a:p>
           <a:p>
             <a:pPr>
               <a:spcAft>
-                <a:spcPts val="400"/>
+                <a:spcPts val="300"/>
               </a:spcAft>
               <a:defRPr sz="1050">
                 <a:solidFill>
@@ -4804,7 +4804,7 @@
           <a:p>
             <a:pPr>
               <a:spcAft>
-                <a:spcPts val="400"/>
+                <a:spcPts val="300"/>
               </a:spcAft>
               <a:defRPr sz="1050">
                 <a:solidFill>
@@ -4820,7 +4820,7 @@
           <a:p>
             <a:pPr>
               <a:spcAft>
-                <a:spcPts val="400"/>
+                <a:spcPts val="300"/>
               </a:spcAft>
               <a:defRPr sz="1050">
                 <a:solidFill>
@@ -4836,7 +4836,7 @@
           <a:p>
             <a:pPr>
               <a:spcAft>
-                <a:spcPts val="400"/>
+                <a:spcPts val="300"/>
               </a:spcAft>
               <a:defRPr sz="1050">
                 <a:solidFill>
@@ -4852,7 +4852,7 @@
           <a:p>
             <a:pPr>
               <a:spcAft>
-                <a:spcPts val="400"/>
+                <a:spcPts val="300"/>
               </a:spcAft>
               <a:defRPr sz="1050">
                 <a:solidFill>
@@ -4868,7 +4868,7 @@
           <a:p>
             <a:pPr>
               <a:spcAft>
-                <a:spcPts val="400"/>
+                <a:spcPts val="300"/>
               </a:spcAft>
               <a:defRPr sz="1050">
                 <a:solidFill>
@@ -4894,7 +4894,7 @@
               </a:defRPr>
             </a:pPr>
             <a:r>
-              <a:t>➔  URL Sistem Live: unistok.nirwana.biz.id</a:t>
+              <a:t>➔  URL Sistem: unistok.nirwana.biz.id</a:t>
             </a:r>
           </a:p>
         </p:txBody>
@@ -4949,7 +4949,7 @@
               </a:defRPr>
             </a:pPr>
             <a:r>
-              <a:t>FOKUS SOLUSI UNISTOCK: </a:t>
+              <a:t>Misi Solusi HorizonU Uniform: </a:t>
             </a:r>
             <a:r>
               <a:rPr sz="1050">
@@ -4997,8 +4997,8 @@
         </p:nvSpPr>
         <p:spPr>
           <a:xfrm>
-            <a:off x="731520" y="365760"/>
-            <a:ext cx="73152" cy="777240"/>
+            <a:off x="731520" y="384048"/>
+            <a:ext cx="54864" cy="713232"/>
           </a:xfrm>
           <a:prstGeom prst="rect">
             <a:avLst/>
@@ -5040,7 +5040,79 @@
         </p:nvSpPr>
         <p:spPr>
           <a:xfrm>
-            <a:off x="914400" y="320040"/>
+            <a:off x="868680" y="347472"/>
+            <a:ext cx="10515600" cy="219456"/>
+          </a:xfrm>
+          <a:prstGeom prst="rect">
+            <a:avLst/>
+          </a:prstGeom>
+          <a:noFill/>
+        </p:spPr>
+        <p:txBody>
+          <a:bodyPr wrap="square">
+            <a:spAutoFit/>
+          </a:bodyPr>
+          <a:lstStyle/>
+          <a:p>
+            <a:pPr>
+              <a:defRPr sz="950" b="1">
+                <a:solidFill>
+                  <a:srgbClr val="980517"/>
+                </a:solidFill>
+                <a:latin typeface="Arial"/>
+              </a:defRPr>
+            </a:pPr>
+            <a:r>
+              <a:t>STRUKTUR RANTAI PASOK</a:t>
+            </a:r>
+          </a:p>
+        </p:txBody>
+      </p:sp>
+      <p:sp>
+        <p:nvSpPr>
+          <p:cNvPr id="4" name="TextBox 3"/>
+          <p:cNvSpPr txBox="1"/>
+          <p:nvPr/>
+        </p:nvSpPr>
+        <p:spPr>
+          <a:xfrm>
+            <a:off x="868680" y="548640"/>
+            <a:ext cx="10515600" cy="384048"/>
+          </a:xfrm>
+          <a:prstGeom prst="rect">
+            <a:avLst/>
+          </a:prstGeom>
+          <a:noFill/>
+        </p:spPr>
+        <p:txBody>
+          <a:bodyPr wrap="square">
+            <a:spAutoFit/>
+          </a:bodyPr>
+          <a:lstStyle/>
+          <a:p>
+            <a:pPr>
+              <a:defRPr sz="1900" b="1">
+                <a:solidFill>
+                  <a:srgbClr val="0F172A"/>
+                </a:solidFill>
+                <a:latin typeface="Arial"/>
+              </a:defRPr>
+            </a:pPr>
+            <a:r>
+              <a:t>Pemetaan Stakeholder &amp; Aliran Fisik Barang</a:t>
+            </a:r>
+          </a:p>
+        </p:txBody>
+      </p:sp>
+      <p:sp>
+        <p:nvSpPr>
+          <p:cNvPr id="5" name="TextBox 4"/>
+          <p:cNvSpPr txBox="1"/>
+          <p:nvPr/>
+        </p:nvSpPr>
+        <p:spPr>
+          <a:xfrm>
+            <a:off x="868680" y="932688"/>
             <a:ext cx="10515600" cy="256032"/>
           </a:xfrm>
           <a:prstGeom prst="rect">
@@ -5055,79 +5127,7 @@
           <a:lstStyle/>
           <a:p>
             <a:pPr>
-              <a:defRPr sz="1000" b="1">
-                <a:solidFill>
-                  <a:srgbClr val="980517"/>
-                </a:solidFill>
-                <a:latin typeface="Arial"/>
-              </a:defRPr>
-            </a:pPr>
-            <a:r>
-              <a:t>SLIDE 2 • SUPPLY CHAIN STRUCTURE   |   RUBRIK: SUPPLY CHAIN UNDERSTANDING (15%)</a:t>
-            </a:r>
-          </a:p>
-        </p:txBody>
-      </p:sp>
-      <p:sp>
-        <p:nvSpPr>
-          <p:cNvPr id="4" name="TextBox 3"/>
-          <p:cNvSpPr txBox="1"/>
-          <p:nvPr/>
-        </p:nvSpPr>
-        <p:spPr>
-          <a:xfrm>
-            <a:off x="914400" y="548640"/>
-            <a:ext cx="10515600" cy="411480"/>
-          </a:xfrm>
-          <a:prstGeom prst="rect">
-            <a:avLst/>
-          </a:prstGeom>
-          <a:noFill/>
-        </p:spPr>
-        <p:txBody>
-          <a:bodyPr wrap="square">
-            <a:spAutoFit/>
-          </a:bodyPr>
-          <a:lstStyle/>
-          <a:p>
-            <a:pPr>
-              <a:defRPr sz="2000" b="1">
-                <a:solidFill>
-                  <a:srgbClr val="0F172A"/>
-                </a:solidFill>
-                <a:latin typeface="Arial"/>
-              </a:defRPr>
-            </a:pPr>
-            <a:r>
-              <a:t>STRUKTUR RANTAI PASOK: STAKEHOLDER, ALIRAN FISIK &amp; INFORMASI</a:t>
-            </a:r>
-          </a:p>
-        </p:txBody>
-      </p:sp>
-      <p:sp>
-        <p:nvSpPr>
-          <p:cNvPr id="5" name="TextBox 4"/>
-          <p:cNvSpPr txBox="1"/>
-          <p:nvPr/>
-        </p:nvSpPr>
-        <p:spPr>
-          <a:xfrm>
-            <a:off x="914400" y="960120"/>
-            <a:ext cx="10515600" cy="274320"/>
-          </a:xfrm>
-          <a:prstGeom prst="rect">
-            <a:avLst/>
-          </a:prstGeom>
-          <a:noFill/>
-        </p:spPr>
-        <p:txBody>
-          <a:bodyPr wrap="square">
-            <a:spAutoFit/>
-          </a:bodyPr>
-          <a:lstStyle/>
-          <a:p>
-            <a:pPr>
-              <a:defRPr sz="1150">
+              <a:defRPr sz="1100">
                 <a:solidFill>
                   <a:srgbClr val="475569"/>
                 </a:solidFill>
@@ -5135,7 +5135,7 @@
               </a:defRPr>
             </a:pPr>
             <a:r>
-              <a:t>Pemetaan peran stakeholder end-to-end dari hulu ke hilir serta titik kritis perpindahan barang dan otorisasi digital.</a:t>
+              <a:t>Aliran terpadu dari pabrik vendor hingga serah terima mahasiswa dengan prinsip 'Data Mengunci Fisik'</a:t>
             </a:r>
           </a:p>
         </p:txBody>
@@ -5148,8 +5148,8 @@
         </p:nvSpPr>
         <p:spPr>
           <a:xfrm>
-            <a:off x="731520" y="1261872"/>
-            <a:ext cx="10728655" cy="13716"/>
+            <a:off x="731520" y="1243584"/>
+            <a:ext cx="10728655" cy="10972"/>
           </a:xfrm>
           <a:prstGeom prst="rect">
             <a:avLst/>
@@ -5239,9 +5239,9 @@
           <a:p>
             <a:pPr>
               <a:spcAft>
-                <a:spcPts val="600"/>
+                <a:spcPts val="500"/>
               </a:spcAft>
-              <a:defRPr sz="1300" b="1">
+              <a:defRPr sz="1250" b="1">
                 <a:solidFill>
                   <a:srgbClr val="0F172A"/>
                 </a:solidFill>
@@ -5255,7 +5255,7 @@
           <a:p>
             <a:pPr>
               <a:spcAft>
-                <a:spcPts val="400"/>
+                <a:spcPts val="300"/>
               </a:spcAft>
               <a:defRPr sz="1050">
                 <a:solidFill>
@@ -5271,7 +5271,7 @@
           <a:p>
             <a:pPr>
               <a:spcAft>
-                <a:spcPts val="400"/>
+                <a:spcPts val="300"/>
               </a:spcAft>
               <a:defRPr sz="1050">
                 <a:solidFill>
@@ -5281,13 +5281,13 @@
               </a:defRPr>
             </a:pPr>
             <a:r>
-              <a:t>•  Menerapkan standarisasi kode varian SKU seragam.</a:t>
+              <a:t>•  Menerapkan standarisasi kode SKU per kategori dan ukuran.</a:t>
             </a:r>
           </a:p>
           <a:p>
             <a:pPr>
               <a:spcAft>
-                <a:spcPts val="400"/>
+                <a:spcPts val="300"/>
               </a:spcAft>
               <a:defRPr sz="1050">
                 <a:solidFill>
@@ -5297,7 +5297,7 @@
               </a:defRPr>
             </a:pPr>
             <a:r>
-              <a:t>•  Titik Barang: Pengiriman kardus seragam ke gudang kampus (Inbound Logistics).</a:t>
+              <a:t>•  Titik Barang: Pengiriman kontainer stok ke gudang kampus (Inbound Logistics).</a:t>
             </a:r>
           </a:p>
           <a:p>
@@ -5374,9 +5374,9 @@
           <a:p>
             <a:pPr>
               <a:spcAft>
-                <a:spcPts val="600"/>
+                <a:spcPts val="500"/>
               </a:spcAft>
-              <a:defRPr sz="1300" b="1">
+              <a:defRPr sz="1250" b="1">
                 <a:solidFill>
                   <a:srgbClr val="0F172A"/>
                 </a:solidFill>
@@ -5390,7 +5390,7 @@
           <a:p>
             <a:pPr>
               <a:spcAft>
-                <a:spcPts val="400"/>
+                <a:spcPts val="300"/>
               </a:spcAft>
               <a:defRPr sz="1050">
                 <a:solidFill>
@@ -5400,13 +5400,13 @@
               </a:defRPr>
             </a:pPr>
             <a:r>
-              <a:t>•  Penerimaan fisik barang (StockReceive) dan quality checking kualitas seragam.</a:t>
+              <a:t>•  Penerimaan fisik barang (StockReceive) dan pemeriksaan mutu (QC).</a:t>
             </a:r>
           </a:p>
           <a:p>
             <a:pPr>
               <a:spcAft>
-                <a:spcPts val="400"/>
+                <a:spcPts val="300"/>
               </a:spcAft>
               <a:defRPr sz="1050">
                 <a:solidFill>
@@ -5416,13 +5416,13 @@
               </a:defRPr>
             </a:pPr>
             <a:r>
-              <a:t>•  Pencatatan batch urutan FIFO (First-In, First-Out) dan nilai HPP per unit.</a:t>
+              <a:t>•  Pencatatan batch urutan FIFO (First-In, First-Out) dan penetapan harga beli unit.</a:t>
             </a:r>
           </a:p>
           <a:p>
             <a:pPr>
               <a:spcAft>
-                <a:spcPts val="400"/>
+                <a:spcPts val="300"/>
               </a:spcAft>
               <a:defRPr sz="1050">
                 <a:solidFill>
@@ -5432,7 +5432,7 @@
               </a:defRPr>
             </a:pPr>
             <a:r>
-              <a:t>•  Titik Barang &amp; Info: Transfer stok batch tertua menuju posko distribusi loket.</a:t>
+              <a:t>•  Titik Barang: Transfer stok batch tertua menuju posko distribusi loket.</a:t>
             </a:r>
           </a:p>
           <a:p>
@@ -5503,15 +5503,15 @@
               </a:defRPr>
             </a:pPr>
             <a:r>
-              <a:t>03 • KEUANGAN &amp; POSKO</a:t>
+              <a:t>03 • VERIFIKATOR &amp; LOKET</a:t>
             </a:r>
           </a:p>
           <a:p>
             <a:pPr>
               <a:spcAft>
-                <a:spcPts val="600"/>
+                <a:spcPts val="500"/>
               </a:spcAft>
-              <a:defRPr sz="1300" b="1">
+              <a:defRPr sz="1250" b="1">
                 <a:solidFill>
                   <a:srgbClr val="0F172A"/>
                 </a:solidFill>
@@ -5525,7 +5525,7 @@
           <a:p>
             <a:pPr>
               <a:spcAft>
-                <a:spcPts val="400"/>
+                <a:spcPts val="300"/>
               </a:spcAft>
               <a:defRPr sz="1050">
                 <a:solidFill>
@@ -5535,13 +5535,13 @@
               </a:defRPr>
             </a:pPr>
             <a:r>
-              <a:t>•  Keuangan: Otorisasi status pelunasan biaya kuliah (Eligibility Record).</a:t>
+              <a:t>•  Keuangan: Otorisasi status pelunasan biaya kuliah mahasiswa (Eligibility).</a:t>
             </a:r>
           </a:p>
           <a:p>
             <a:pPr>
               <a:spcAft>
-                <a:spcPts val="400"/>
+                <a:spcPts val="300"/>
               </a:spcAft>
               <a:defRPr sz="1050">
                 <a:solidFill>
@@ -5557,7 +5557,7 @@
           <a:p>
             <a:pPr>
               <a:spcAft>
-                <a:spcPts val="400"/>
+                <a:spcPts val="300"/>
               </a:spcAft>
               <a:defRPr sz="1050">
                 <a:solidFill>
@@ -5567,7 +5567,7 @@
               </a:defRPr>
             </a:pPr>
             <a:r>
-              <a:t>•  Titik Kritis: Validasi QR Code dan pencocokan ukuran saat proses fitting.</a:t>
+              <a:t>•  Titik Kritis: Validasi identitas QR Code dan pencocokan ukuran saat proses fitting.</a:t>
             </a:r>
           </a:p>
           <a:p>
@@ -5644,9 +5644,9 @@
           <a:p>
             <a:pPr>
               <a:spcAft>
-                <a:spcPts val="600"/>
+                <a:spcPts val="500"/>
               </a:spcAft>
-              <a:defRPr sz="1300" b="1">
+              <a:defRPr sz="1250" b="1">
                 <a:solidFill>
                   <a:srgbClr val="0F172A"/>
                 </a:solidFill>
@@ -5660,7 +5660,7 @@
           <a:p>
             <a:pPr>
               <a:spcAft>
-                <a:spcPts val="400"/>
+                <a:spcPts val="300"/>
               </a:spcAft>
               <a:defRPr sz="1050">
                 <a:solidFill>
@@ -5676,7 +5676,7 @@
           <a:p>
             <a:pPr>
               <a:spcAft>
-                <a:spcPts val="400"/>
+                <a:spcPts val="300"/>
               </a:spcAft>
               <a:defRPr sz="1050">
                 <a:solidFill>
@@ -5692,7 +5692,7 @@
           <a:p>
             <a:pPr>
               <a:spcAft>
-                <a:spcPts val="400"/>
+                <a:spcPts val="300"/>
               </a:spcAft>
               <a:defRPr sz="1050">
                 <a:solidFill>
@@ -5702,7 +5702,7 @@
               </a:defRPr>
             </a:pPr>
             <a:r>
-              <a:t>•  Titik Info: Menunjukkan QR Code beresolusi tinggi (NIM murni) di meja posko.</a:t>
+              <a:t>•  Titik Info: Menunjukkan tiket QR Code beresolusi tinggi (NIM murni) di loket.</a:t>
             </a:r>
           </a:p>
           <a:p>
@@ -5773,7 +5773,7 @@
               </a:defRPr>
             </a:pPr>
             <a:r>
-              <a:t>PRINSIP INTI 'DATA MENGUNCI FISIK': </a:t>
+              <a:t>Prinsip Inti 'Data Mengunci Fisik': </a:t>
             </a:r>
             <a:r>
               <a:rPr sz="1050">
@@ -5821,8 +5821,8 @@
         </p:nvSpPr>
         <p:spPr>
           <a:xfrm>
-            <a:off x="731520" y="365760"/>
-            <a:ext cx="73152" cy="777240"/>
+            <a:off x="731520" y="384048"/>
+            <a:ext cx="54864" cy="713232"/>
           </a:xfrm>
           <a:prstGeom prst="rect">
             <a:avLst/>
@@ -5864,7 +5864,79 @@
         </p:nvSpPr>
         <p:spPr>
           <a:xfrm>
-            <a:off x="914400" y="320040"/>
+            <a:off x="868680" y="347472"/>
+            <a:ext cx="10515600" cy="219456"/>
+          </a:xfrm>
+          <a:prstGeom prst="rect">
+            <a:avLst/>
+          </a:prstGeom>
+          <a:noFill/>
+        </p:spPr>
+        <p:txBody>
+          <a:bodyPr wrap="square">
+            <a:spAutoFit/>
+          </a:bodyPr>
+          <a:lstStyle/>
+          <a:p>
+            <a:pPr>
+              <a:defRPr sz="950" b="1">
+                <a:solidFill>
+                  <a:srgbClr val="980517"/>
+                </a:solidFill>
+                <a:latin typeface="Arial"/>
+              </a:defRPr>
+            </a:pPr>
+            <a:r>
+              <a:t>ANALISIS MASALAH SISTEM LAMA</a:t>
+            </a:r>
+          </a:p>
+        </p:txBody>
+      </p:sp>
+      <p:sp>
+        <p:nvSpPr>
+          <p:cNvPr id="4" name="TextBox 3"/>
+          <p:cNvSpPr txBox="1"/>
+          <p:nvPr/>
+        </p:nvSpPr>
+        <p:spPr>
+          <a:xfrm>
+            <a:off x="868680" y="548640"/>
+            <a:ext cx="10515600" cy="384048"/>
+          </a:xfrm>
+          <a:prstGeom prst="rect">
+            <a:avLst/>
+          </a:prstGeom>
+          <a:noFill/>
+        </p:spPr>
+        <p:txBody>
+          <a:bodyPr wrap="square">
+            <a:spAutoFit/>
+          </a:bodyPr>
+          <a:lstStyle/>
+          <a:p>
+            <a:pPr>
+              <a:defRPr sz="1900" b="1">
+                <a:solidFill>
+                  <a:srgbClr val="0F172A"/>
+                </a:solidFill>
+                <a:latin typeface="Arial"/>
+              </a:defRPr>
+            </a:pPr>
+            <a:r>
+              <a:t>Evaluasi Kendala Operasional &amp; Dampak Sistemik</a:t>
+            </a:r>
+          </a:p>
+        </p:txBody>
+      </p:sp>
+      <p:sp>
+        <p:nvSpPr>
+          <p:cNvPr id="5" name="TextBox 4"/>
+          <p:cNvSpPr txBox="1"/>
+          <p:nvPr/>
+        </p:nvSpPr>
+        <p:spPr>
+          <a:xfrm>
+            <a:off x="868680" y="932688"/>
             <a:ext cx="10515600" cy="256032"/>
           </a:xfrm>
           <a:prstGeom prst="rect">
@@ -5879,79 +5951,7 @@
           <a:lstStyle/>
           <a:p>
             <a:pPr>
-              <a:defRPr sz="1000" b="1">
-                <a:solidFill>
-                  <a:srgbClr val="980517"/>
-                </a:solidFill>
-                <a:latin typeface="Arial"/>
-              </a:defRPr>
-            </a:pPr>
-            <a:r>
-              <a:t>SLIDE 3 • PROBLEM ANALYSIS   |   RUBRIK: PROBLEM ANALYSIS (20%)</a:t>
-            </a:r>
-          </a:p>
-        </p:txBody>
-      </p:sp>
-      <p:sp>
-        <p:nvSpPr>
-          <p:cNvPr id="4" name="TextBox 3"/>
-          <p:cNvSpPr txBox="1"/>
-          <p:nvPr/>
-        </p:nvSpPr>
-        <p:spPr>
-          <a:xfrm>
-            <a:off x="914400" y="548640"/>
-            <a:ext cx="10515600" cy="411480"/>
-          </a:xfrm>
-          <a:prstGeom prst="rect">
-            <a:avLst/>
-          </a:prstGeom>
-          <a:noFill/>
-        </p:spPr>
-        <p:txBody>
-          <a:bodyPr wrap="square">
-            <a:spAutoFit/>
-          </a:bodyPr>
-          <a:lstStyle/>
-          <a:p>
-            <a:pPr>
-              <a:defRPr sz="2000" b="1">
-                <a:solidFill>
-                  <a:srgbClr val="0F172A"/>
-                </a:solidFill>
-                <a:latin typeface="Arial"/>
-              </a:defRPr>
-            </a:pPr>
-            <a:r>
-              <a:t>ANALISIS AKAR MASALAH: MENGAPA SISTEM MANUAL GAGAL?</a:t>
-            </a:r>
-          </a:p>
-        </p:txBody>
-      </p:sp>
-      <p:sp>
-        <p:nvSpPr>
-          <p:cNvPr id="5" name="TextBox 4"/>
-          <p:cNvSpPr txBox="1"/>
-          <p:nvPr/>
-        </p:nvSpPr>
-        <p:spPr>
-          <a:xfrm>
-            <a:off x="914400" y="960120"/>
-            <a:ext cx="10515600" cy="274320"/>
-          </a:xfrm>
-          <a:prstGeom prst="rect">
-            <a:avLst/>
-          </a:prstGeom>
-          <a:noFill/>
-        </p:spPr>
-        <p:txBody>
-          <a:bodyPr wrap="square">
-            <a:spAutoFit/>
-          </a:bodyPr>
-          <a:lstStyle/>
-          <a:p>
-            <a:pPr>
-              <a:defRPr sz="1150">
+              <a:defRPr sz="1100">
                 <a:solidFill>
                   <a:srgbClr val="475569"/>
                 </a:solidFill>
@@ -5959,7 +5959,7 @@
               </a:defRPr>
             </a:pPr>
             <a:r>
-              <a:t>Matriks analisis empat masalah utama beserta penyebab sistemik dan dampaknya terhadap biaya, waktu, stok, dan pelayanan.</a:t>
+              <a:t>Analisis akar masalah pengelolaan manual terhadap pembengkakan biaya, waktu kerja, dan penurunan mutu layanan</a:t>
             </a:r>
           </a:p>
         </p:txBody>
@@ -5972,8 +5972,8 @@
         </p:nvSpPr>
         <p:spPr>
           <a:xfrm>
-            <a:off x="731520" y="1261872"/>
-            <a:ext cx="10728655" cy="13716"/>
+            <a:off x="731520" y="1243584"/>
+            <a:ext cx="10728655" cy="10972"/>
           </a:xfrm>
           <a:prstGeom prst="rect">
             <a:avLst/>
@@ -6454,7 +6454,7 @@
               </a:defRPr>
             </a:pPr>
             <a:r>
-              <a:t>AKAR KEGAGALAN SISTEMIK: </a:t>
+              <a:t>Akar Kegagalan Sistemik: </a:t>
             </a:r>
             <a:r>
               <a:rPr sz="1050">
@@ -6502,8 +6502,8 @@
         </p:nvSpPr>
         <p:spPr>
           <a:xfrm>
-            <a:off x="731520" y="365760"/>
-            <a:ext cx="73152" cy="777240"/>
+            <a:off x="731520" y="384048"/>
+            <a:ext cx="54864" cy="713232"/>
           </a:xfrm>
           <a:prstGeom prst="rect">
             <a:avLst/>
@@ -6545,7 +6545,79 @@
         </p:nvSpPr>
         <p:spPr>
           <a:xfrm>
-            <a:off x="914400" y="320040"/>
+            <a:off x="868680" y="347472"/>
+            <a:ext cx="10515600" cy="219456"/>
+          </a:xfrm>
+          <a:prstGeom prst="rect">
+            <a:avLst/>
+          </a:prstGeom>
+          <a:noFill/>
+        </p:spPr>
+        <p:txBody>
+          <a:bodyPr wrap="square">
+            <a:spAutoFit/>
+          </a:bodyPr>
+          <a:lstStyle/>
+          <a:p>
+            <a:pPr>
+              <a:defRPr sz="950" b="1">
+                <a:solidFill>
+                  <a:srgbClr val="980517"/>
+                </a:solidFill>
+                <a:latin typeface="Arial"/>
+              </a:defRPr>
+            </a:pPr>
+            <a:r>
+              <a:t>ANALISIS ALIRAN INFORMASI</a:t>
+            </a:r>
+          </a:p>
+        </p:txBody>
+      </p:sp>
+      <p:sp>
+        <p:nvSpPr>
+          <p:cNvPr id="4" name="TextBox 3"/>
+          <p:cNvSpPr txBox="1"/>
+          <p:nvPr/>
+        </p:nvSpPr>
+        <p:spPr>
+          <a:xfrm>
+            <a:off x="868680" y="548640"/>
+            <a:ext cx="10515600" cy="384048"/>
+          </a:xfrm>
+          <a:prstGeom prst="rect">
+            <a:avLst/>
+          </a:prstGeom>
+          <a:noFill/>
+        </p:spPr>
+        <p:txBody>
+          <a:bodyPr wrap="square">
+            <a:spAutoFit/>
+          </a:bodyPr>
+          <a:lstStyle/>
+          <a:p>
+            <a:pPr>
+              <a:defRPr sz="1900" b="1">
+                <a:solidFill>
+                  <a:srgbClr val="0F172A"/>
+                </a:solidFill>
+                <a:latin typeface="Arial"/>
+              </a:defRPr>
+            </a:pPr>
+            <a:r>
+              <a:t>Titik Kemacetan &amp; Isolasi Data (As-Is State)</a:t>
+            </a:r>
+          </a:p>
+        </p:txBody>
+      </p:sp>
+      <p:sp>
+        <p:nvSpPr>
+          <p:cNvPr id="5" name="TextBox 4"/>
+          <p:cNvSpPr txBox="1"/>
+          <p:nvPr/>
+        </p:nvSpPr>
+        <p:spPr>
+          <a:xfrm>
+            <a:off x="868680" y="932688"/>
             <a:ext cx="10515600" cy="256032"/>
           </a:xfrm>
           <a:prstGeom prst="rect">
@@ -6560,79 +6632,7 @@
           <a:lstStyle/>
           <a:p>
             <a:pPr>
-              <a:defRPr sz="1000" b="1">
-                <a:solidFill>
-                  <a:srgbClr val="980517"/>
-                </a:solidFill>
-                <a:latin typeface="Arial"/>
-              </a:defRPr>
-            </a:pPr>
-            <a:r>
-              <a:t>SLIDE 4 • INFORMATION FLOW ANALYSIS   |   RUBRIK: INFORMATION FLOW ANALYSIS (15%)</a:t>
-            </a:r>
-          </a:p>
-        </p:txBody>
-      </p:sp>
-      <p:sp>
-        <p:nvSpPr>
-          <p:cNvPr id="4" name="TextBox 3"/>
-          <p:cNvSpPr txBox="1"/>
-          <p:nvPr/>
-        </p:nvSpPr>
-        <p:spPr>
-          <a:xfrm>
-            <a:off x="914400" y="548640"/>
-            <a:ext cx="10515600" cy="411480"/>
-          </a:xfrm>
-          <a:prstGeom prst="rect">
-            <a:avLst/>
-          </a:prstGeom>
-          <a:noFill/>
-        </p:spPr>
-        <p:txBody>
-          <a:bodyPr wrap="square">
-            <a:spAutoFit/>
-          </a:bodyPr>
-          <a:lstStyle/>
-          <a:p>
-            <a:pPr>
-              <a:defRPr sz="2000" b="1">
-                <a:solidFill>
-                  <a:srgbClr val="0F172A"/>
-                </a:solidFill>
-                <a:latin typeface="Arial"/>
-              </a:defRPr>
-            </a:pPr>
-            <a:r>
-              <a:t>DIAGRAM ALIRAN INFORMASI &amp; TITIK KEMACETAN (AS-IS STATE)</a:t>
-            </a:r>
-          </a:p>
-        </p:txBody>
-      </p:sp>
-      <p:sp>
-        <p:nvSpPr>
-          <p:cNvPr id="5" name="TextBox 4"/>
-          <p:cNvSpPr txBox="1"/>
-          <p:nvPr/>
-        </p:nvSpPr>
-        <p:spPr>
-          <a:xfrm>
-            <a:off x="914400" y="960120"/>
-            <a:ext cx="10515600" cy="274320"/>
-          </a:xfrm>
-          <a:prstGeom prst="rect">
-            <a:avLst/>
-          </a:prstGeom>
-          <a:noFill/>
-        </p:spPr>
-        <p:txBody>
-          <a:bodyPr wrap="square">
-            <a:spAutoFit/>
-          </a:bodyPr>
-          <a:lstStyle/>
-          <a:p>
-            <a:pPr>
-              <a:defRPr sz="1150">
+              <a:defRPr sz="1100">
                 <a:solidFill>
                   <a:srgbClr val="475569"/>
                 </a:solidFill>
@@ -6640,7 +6640,7 @@
               </a:defRPr>
             </a:pPr>
             <a:r>
-              <a:t>Identifikasi kebutuhan informasi stakeholder, asal-tujuan data, serta titik kritis informasi terlambat, tidak akurat, atau terputus.</a:t>
+              <a:t>Hambatan komunikasi antarbagian yang memicu keterlambatan, inkonsistensi data, dan pembatalan layanan</a:t>
             </a:r>
           </a:p>
         </p:txBody>
@@ -6653,8 +6653,8 @@
         </p:nvSpPr>
         <p:spPr>
           <a:xfrm>
-            <a:off x="731520" y="1261872"/>
-            <a:ext cx="10728655" cy="13716"/>
+            <a:off x="731520" y="1243584"/>
+            <a:ext cx="10728655" cy="10972"/>
           </a:xfrm>
           <a:prstGeom prst="rect">
             <a:avLst/>
@@ -6744,9 +6744,9 @@
           <a:p>
             <a:pPr>
               <a:spcAft>
-                <a:spcPts val="600"/>
+                <a:spcPts val="500"/>
               </a:spcAft>
-              <a:defRPr sz="1300" b="1">
+              <a:defRPr sz="1250" b="1">
                 <a:solidFill>
                   <a:srgbClr val="0F172A"/>
                 </a:solidFill>
@@ -6760,7 +6760,7 @@
           <a:p>
             <a:pPr>
               <a:spcAft>
-                <a:spcPts val="400"/>
+                <a:spcPts val="300"/>
               </a:spcAft>
               <a:defRPr sz="1050">
                 <a:solidFill>
@@ -6776,7 +6776,7 @@
           <a:p>
             <a:pPr>
               <a:spcAft>
-                <a:spcPts val="400"/>
+                <a:spcPts val="300"/>
               </a:spcAft>
               <a:defRPr sz="1050">
                 <a:solidFill>
@@ -6786,7 +6786,7 @@
               </a:defRPr>
             </a:pPr>
             <a:r>
-              <a:t>•  Titik Masalah: Google Form terpisah tanpa validasi SKU baku, memicu input ganda dan rekap manual staf terlambat berminggu-minggu.</a:t>
+              <a:t>•  Titik Masalah: Google Form terpisah tanpa validasi SKU baku, memicu input ganda dan rekapitulasi data staf terlambat berminggu-minggu.</a:t>
             </a:r>
           </a:p>
           <a:p>
@@ -6863,9 +6863,9 @@
           <a:p>
             <a:pPr>
               <a:spcAft>
-                <a:spcPts val="600"/>
+                <a:spcPts val="500"/>
               </a:spcAft>
-              <a:defRPr sz="1300" b="1">
+              <a:defRPr sz="1250" b="1">
                 <a:solidFill>
                   <a:srgbClr val="0F172A"/>
                 </a:solidFill>
@@ -6879,7 +6879,7 @@
           <a:p>
             <a:pPr>
               <a:spcAft>
-                <a:spcPts val="400"/>
+                <a:spcPts val="300"/>
               </a:spcAft>
               <a:defRPr sz="1050">
                 <a:solidFill>
@@ -6895,7 +6895,7 @@
           <a:p>
             <a:pPr>
               <a:spcAft>
-                <a:spcPts val="400"/>
+                <a:spcPts val="300"/>
               </a:spcAft>
               <a:defRPr sz="1050">
                 <a:solidFill>
@@ -6982,9 +6982,9 @@
           <a:p>
             <a:pPr>
               <a:spcAft>
-                <a:spcPts val="600"/>
+                <a:spcPts val="500"/>
               </a:spcAft>
-              <a:defRPr sz="1300" b="1">
+              <a:defRPr sz="1250" b="1">
                 <a:solidFill>
                   <a:srgbClr val="0F172A"/>
                 </a:solidFill>
@@ -6998,7 +6998,7 @@
           <a:p>
             <a:pPr>
               <a:spcAft>
-                <a:spcPts val="400"/>
+                <a:spcPts val="300"/>
               </a:spcAft>
               <a:defRPr sz="1050">
                 <a:solidFill>
@@ -7014,7 +7014,7 @@
           <a:p>
             <a:pPr>
               <a:spcAft>
-                <a:spcPts val="400"/>
+                <a:spcPts val="300"/>
               </a:spcAft>
               <a:defRPr sz="1050">
                 <a:solidFill>
@@ -7101,9 +7101,9 @@
           <a:p>
             <a:pPr>
               <a:spcAft>
-                <a:spcPts val="600"/>
+                <a:spcPts val="500"/>
               </a:spcAft>
-              <a:defRPr sz="1300" b="1">
+              <a:defRPr sz="1250" b="1">
                 <a:solidFill>
                   <a:srgbClr val="0F172A"/>
                 </a:solidFill>
@@ -7117,7 +7117,7 @@
           <a:p>
             <a:pPr>
               <a:spcAft>
-                <a:spcPts val="400"/>
+                <a:spcPts val="300"/>
               </a:spcAft>
               <a:defRPr sz="1050">
                 <a:solidFill>
@@ -7133,7 +7133,7 @@
           <a:p>
             <a:pPr>
               <a:spcAft>
-                <a:spcPts val="400"/>
+                <a:spcPts val="300"/>
               </a:spcAft>
               <a:defRPr sz="1050">
                 <a:solidFill>
@@ -7214,7 +7214,7 @@
               </a:defRPr>
             </a:pPr>
             <a:r>
-              <a:t>DIAGNOSA KUNCI: </a:t>
+              <a:t>Diagnosa Kunci: </a:t>
             </a:r>
             <a:r>
               <a:rPr sz="1050">
@@ -7262,8 +7262,8 @@
         </p:nvSpPr>
         <p:spPr>
           <a:xfrm>
-            <a:off x="731520" y="365760"/>
-            <a:ext cx="73152" cy="777240"/>
+            <a:off x="731520" y="384048"/>
+            <a:ext cx="54864" cy="713232"/>
           </a:xfrm>
           <a:prstGeom prst="rect">
             <a:avLst/>
@@ -7305,7 +7305,79 @@
         </p:nvSpPr>
         <p:spPr>
           <a:xfrm>
-            <a:off x="914400" y="320040"/>
+            <a:off x="868680" y="347472"/>
+            <a:ext cx="10515600" cy="219456"/>
+          </a:xfrm>
+          <a:prstGeom prst="rect">
+            <a:avLst/>
+          </a:prstGeom>
+          <a:noFill/>
+        </p:spPr>
+        <p:txBody>
+          <a:bodyPr wrap="square">
+            <a:spAutoFit/>
+          </a:bodyPr>
+          <a:lstStyle/>
+          <a:p>
+            <a:pPr>
+              <a:defRPr sz="950" b="1">
+                <a:solidFill>
+                  <a:srgbClr val="980517"/>
+                </a:solidFill>
+                <a:latin typeface="Arial"/>
+              </a:defRPr>
+            </a:pPr>
+            <a:r>
+              <a:t>REKOMENDASI SISTEM TERPADU</a:t>
+            </a:r>
+          </a:p>
+        </p:txBody>
+      </p:sp>
+      <p:sp>
+        <p:nvSpPr>
+          <p:cNvPr id="4" name="TextBox 3"/>
+          <p:cNvSpPr txBox="1"/>
+          <p:nvPr/>
+        </p:nvSpPr>
+        <p:spPr>
+          <a:xfrm>
+            <a:off x="868680" y="548640"/>
+            <a:ext cx="10515600" cy="384048"/>
+          </a:xfrm>
+          <a:prstGeom prst="rect">
+            <a:avLst/>
+          </a:prstGeom>
+          <a:noFill/>
+        </p:spPr>
+        <p:txBody>
+          <a:bodyPr wrap="square">
+            <a:spAutoFit/>
+          </a:bodyPr>
+          <a:lstStyle/>
+          <a:p>
+            <a:pPr>
+              <a:defRPr sz="1900" b="1">
+                <a:solidFill>
+                  <a:srgbClr val="0F172A"/>
+                </a:solidFill>
+                <a:latin typeface="Arial"/>
+              </a:defRPr>
+            </a:pPr>
+            <a:r>
+              <a:t>Pemilihan Arsitektur Sistem Informasi (UniStock Engine)</a:t>
+            </a:r>
+          </a:p>
+        </p:txBody>
+      </p:sp>
+      <p:sp>
+        <p:nvSpPr>
+          <p:cNvPr id="5" name="TextBox 4"/>
+          <p:cNvSpPr txBox="1"/>
+          <p:nvPr/>
+        </p:nvSpPr>
+        <p:spPr>
+          <a:xfrm>
+            <a:off x="868680" y="932688"/>
             <a:ext cx="10515600" cy="256032"/>
           </a:xfrm>
           <a:prstGeom prst="rect">
@@ -7320,79 +7392,7 @@
           <a:lstStyle/>
           <a:p>
             <a:pPr>
-              <a:defRPr sz="1000" b="1">
-                <a:solidFill>
-                  <a:srgbClr val="980517"/>
-                </a:solidFill>
-                <a:latin typeface="Arial"/>
-              </a:defRPr>
-            </a:pPr>
-            <a:r>
-              <a:t>SLIDE 5 • RECOMMENDED INFORMATION SYSTEMS   |   RUBRIK: IS JUSTIFICATION (20%)</a:t>
-            </a:r>
-          </a:p>
-        </p:txBody>
-      </p:sp>
-      <p:sp>
-        <p:nvSpPr>
-          <p:cNvPr id="4" name="TextBox 3"/>
-          <p:cNvSpPr txBox="1"/>
-          <p:nvPr/>
-        </p:nvSpPr>
-        <p:spPr>
-          <a:xfrm>
-            <a:off x="914400" y="548640"/>
-            <a:ext cx="10515600" cy="411480"/>
-          </a:xfrm>
-          <a:prstGeom prst="rect">
-            <a:avLst/>
-          </a:prstGeom>
-          <a:noFill/>
-        </p:spPr>
-        <p:txBody>
-          <a:bodyPr wrap="square">
-            <a:spAutoFit/>
-          </a:bodyPr>
-          <a:lstStyle/>
-          <a:p>
-            <a:pPr>
-              <a:defRPr sz="2000" b="1">
-                <a:solidFill>
-                  <a:srgbClr val="0F172A"/>
-                </a:solidFill>
-                <a:latin typeface="Arial"/>
-              </a:defRPr>
-            </a:pPr>
-            <a:r>
-              <a:t>REKOMENDASI SISTEM INFORMASI: EKOSISTEM HORIZONU UNIFORM</a:t>
-            </a:r>
-          </a:p>
-        </p:txBody>
-      </p:sp>
-      <p:sp>
-        <p:nvSpPr>
-          <p:cNvPr id="5" name="TextBox 4"/>
-          <p:cNvSpPr txBox="1"/>
-          <p:nvPr/>
-        </p:nvSpPr>
-        <p:spPr>
-          <a:xfrm>
-            <a:off x="914400" y="960120"/>
-            <a:ext cx="10515600" cy="274320"/>
-          </a:xfrm>
-          <a:prstGeom prst="rect">
-            <a:avLst/>
-          </a:prstGeom>
-          <a:noFill/>
-        </p:spPr>
-        <p:txBody>
-          <a:bodyPr wrap="square">
-            <a:spAutoFit/>
-          </a:bodyPr>
-          <a:lstStyle/>
-          <a:p>
-            <a:pPr>
-              <a:defRPr sz="1150">
+              <a:defRPr sz="1100">
                 <a:solidFill>
                   <a:srgbClr val="475569"/>
                 </a:solidFill>
@@ -7400,7 +7400,7 @@
               </a:defRPr>
             </a:pPr>
             <a:r>
-              <a:t>Pemilihan sistem terpadu (ERP, SCM, POS, WMS), justifikasi integrasi, fungsi operasional, dan manfaat nyata terukur.</a:t>
+              <a:t>Integrasi empat pilar sistem: ERP, SCM, POS, dan WMS dalam satu platform web modern</a:t>
             </a:r>
           </a:p>
         </p:txBody>
@@ -7413,8 +7413,8 @@
         </p:nvSpPr>
         <p:spPr>
           <a:xfrm>
-            <a:off x="731520" y="1261872"/>
-            <a:ext cx="10728655" cy="13716"/>
+            <a:off x="731520" y="1243584"/>
+            <a:ext cx="10728655" cy="10972"/>
           </a:xfrm>
           <a:prstGeom prst="rect">
             <a:avLst/>
@@ -8016,7 +8016,7 @@
               </a:defRPr>
             </a:pPr>
             <a:r>
-              <a:t>KEUNGGULAN INTEGRASI UNISTOCK: </a:t>
+              <a:t>Keunggulan Integrasi UniStock: </a:t>
             </a:r>
             <a:r>
               <a:rPr sz="1050">
@@ -8064,8 +8064,8 @@
         </p:nvSpPr>
         <p:spPr>
           <a:xfrm>
-            <a:off x="731520" y="365760"/>
-            <a:ext cx="73152" cy="777240"/>
+            <a:off x="731520" y="384048"/>
+            <a:ext cx="54864" cy="713232"/>
           </a:xfrm>
           <a:prstGeom prst="rect">
             <a:avLst/>
@@ -8107,7 +8107,79 @@
         </p:nvSpPr>
         <p:spPr>
           <a:xfrm>
-            <a:off x="914400" y="320040"/>
+            <a:off x="868680" y="347472"/>
+            <a:ext cx="10515600" cy="219456"/>
+          </a:xfrm>
+          <a:prstGeom prst="rect">
+            <a:avLst/>
+          </a:prstGeom>
+          <a:noFill/>
+        </p:spPr>
+        <p:txBody>
+          <a:bodyPr wrap="square">
+            <a:spAutoFit/>
+          </a:bodyPr>
+          <a:lstStyle/>
+          <a:p>
+            <a:pPr>
+              <a:defRPr sz="950" b="1">
+                <a:solidFill>
+                  <a:srgbClr val="980517"/>
+                </a:solidFill>
+                <a:latin typeface="Arial"/>
+              </a:defRPr>
+            </a:pPr>
+            <a:r>
+              <a:t>DESAIN ARSITEKTUR SOLUSI</a:t>
+            </a:r>
+          </a:p>
+        </p:txBody>
+      </p:sp>
+      <p:sp>
+        <p:nvSpPr>
+          <p:cNvPr id="4" name="TextBox 3"/>
+          <p:cNvSpPr txBox="1"/>
+          <p:nvPr/>
+        </p:nvSpPr>
+        <p:spPr>
+          <a:xfrm>
+            <a:off x="868680" y="548640"/>
+            <a:ext cx="10515600" cy="384048"/>
+          </a:xfrm>
+          <a:prstGeom prst="rect">
+            <a:avLst/>
+          </a:prstGeom>
+          <a:noFill/>
+        </p:spPr>
+        <p:txBody>
+          <a:bodyPr wrap="square">
+            <a:spAutoFit/>
+          </a:bodyPr>
+          <a:lstStyle/>
+          <a:p>
+            <a:pPr>
+              <a:defRPr sz="1900" b="1">
+                <a:solidFill>
+                  <a:srgbClr val="0F172A"/>
+                </a:solidFill>
+                <a:latin typeface="Arial"/>
+              </a:defRPr>
+            </a:pPr>
+            <a:r>
+              <a:t>Aliran 4-Fase Closed-Loop Supply Chain Engine</a:t>
+            </a:r>
+          </a:p>
+        </p:txBody>
+      </p:sp>
+      <p:sp>
+        <p:nvSpPr>
+          <p:cNvPr id="5" name="TextBox 4"/>
+          <p:cNvSpPr txBox="1"/>
+          <p:nvPr/>
+        </p:nvSpPr>
+        <p:spPr>
+          <a:xfrm>
+            <a:off x="868680" y="932688"/>
             <a:ext cx="10515600" cy="256032"/>
           </a:xfrm>
           <a:prstGeom prst="rect">
@@ -8122,79 +8194,7 @@
           <a:lstStyle/>
           <a:p>
             <a:pPr>
-              <a:defRPr sz="1000" b="1">
-                <a:solidFill>
-                  <a:srgbClr val="980517"/>
-                </a:solidFill>
-                <a:latin typeface="Arial"/>
-              </a:defRPr>
-            </a:pPr>
-            <a:r>
-              <a:t>SLIDE 6 • PROPOSED SOLUTION DESIGN   |   RUBRIK: PROPOSED SOLUTION (15%)</a:t>
-            </a:r>
-          </a:p>
-        </p:txBody>
-      </p:sp>
-      <p:sp>
-        <p:nvSpPr>
-          <p:cNvPr id="4" name="TextBox 3"/>
-          <p:cNvSpPr txBox="1"/>
-          <p:nvPr/>
-        </p:nvSpPr>
-        <p:spPr>
-          <a:xfrm>
-            <a:off x="914400" y="548640"/>
-            <a:ext cx="10515600" cy="411480"/>
-          </a:xfrm>
-          <a:prstGeom prst="rect">
-            <a:avLst/>
-          </a:prstGeom>
-          <a:noFill/>
-        </p:spPr>
-        <p:txBody>
-          <a:bodyPr wrap="square">
-            <a:spAutoFit/>
-          </a:bodyPr>
-          <a:lstStyle/>
-          <a:p>
-            <a:pPr>
-              <a:defRPr sz="2000" b="1">
-                <a:solidFill>
-                  <a:srgbClr val="0F172A"/>
-                </a:solidFill>
-                <a:latin typeface="Arial"/>
-              </a:defRPr>
-            </a:pPr>
-            <a:r>
-              <a:t>DIAGRAM ARSITEKTUR SOLUSI: 4 FASE CLOSED-LOOP SCM ENGINE</a:t>
-            </a:r>
-          </a:p>
-        </p:txBody>
-      </p:sp>
-      <p:sp>
-        <p:nvSpPr>
-          <p:cNvPr id="5" name="TextBox 4"/>
-          <p:cNvSpPr txBox="1"/>
-          <p:nvPr/>
-        </p:nvSpPr>
-        <p:spPr>
-          <a:xfrm>
-            <a:off x="914400" y="960120"/>
-            <a:ext cx="10515600" cy="274320"/>
-          </a:xfrm>
-          <a:prstGeom prst="rect">
-            <a:avLst/>
-          </a:prstGeom>
-          <a:noFill/>
-        </p:spPr>
-        <p:txBody>
-          <a:bodyPr wrap="square">
-            <a:spAutoFit/>
-          </a:bodyPr>
-          <a:lstStyle/>
-          <a:p>
-            <a:pPr>
-              <a:defRPr sz="1150">
+              <a:defRPr sz="1100">
                 <a:solidFill>
                   <a:srgbClr val="475569"/>
                 </a:solidFill>
@@ -8202,7 +8202,7 @@
               </a:defRPr>
             </a:pPr>
             <a:r>
-              <a:t>Bagaimana subsistem terhubung erat, aliran data setelah perbaikan, dan pemanfaatan data untuk pengambilan keputusan.</a:t>
+              <a:t>Konektivitas sistem end-to-end, pemrosesan transaksi atomik, dan closed-loop data feedback</a:t>
             </a:r>
           </a:p>
         </p:txBody>
@@ -8215,8 +8215,8 @@
         </p:nvSpPr>
         <p:spPr>
           <a:xfrm>
-            <a:off x="731520" y="1261872"/>
-            <a:ext cx="10728655" cy="13716"/>
+            <a:off x="731520" y="1243584"/>
+            <a:ext cx="10728655" cy="10972"/>
           </a:xfrm>
           <a:prstGeom prst="rect">
             <a:avLst/>
@@ -8306,9 +8306,9 @@
           <a:p>
             <a:pPr>
               <a:spcAft>
-                <a:spcPts val="600"/>
+                <a:spcPts val="500"/>
               </a:spcAft>
-              <a:defRPr sz="1300" b="1">
+              <a:defRPr sz="1250" b="1">
                 <a:solidFill>
                   <a:srgbClr val="0F172A"/>
                 </a:solidFill>
@@ -8322,7 +8322,7 @@
           <a:p>
             <a:pPr>
               <a:spcAft>
-                <a:spcPts val="400"/>
+                <a:spcPts val="300"/>
               </a:spcAft>
               <a:defRPr sz="1050">
                 <a:solidFill>
@@ -8338,7 +8338,7 @@
           <a:p>
             <a:pPr>
               <a:spcAft>
-                <a:spcPts val="400"/>
+                <a:spcPts val="300"/>
               </a:spcAft>
               <a:defRPr sz="1050">
                 <a:solidFill>
@@ -8354,7 +8354,7 @@
           <a:p>
             <a:pPr>
               <a:spcAft>
-                <a:spcPts val="400"/>
+                <a:spcPts val="300"/>
               </a:spcAft>
               <a:defRPr sz="1050">
                 <a:solidFill>
@@ -8441,9 +8441,9 @@
           <a:p>
             <a:pPr>
               <a:spcAft>
-                <a:spcPts val="600"/>
+                <a:spcPts val="500"/>
               </a:spcAft>
-              <a:defRPr sz="1300" b="1">
+              <a:defRPr sz="1250" b="1">
                 <a:solidFill>
                   <a:srgbClr val="0F172A"/>
                 </a:solidFill>
@@ -8457,7 +8457,7 @@
           <a:p>
             <a:pPr>
               <a:spcAft>
-                <a:spcPts val="400"/>
+                <a:spcPts val="300"/>
               </a:spcAft>
               <a:defRPr sz="1050">
                 <a:solidFill>
@@ -8473,7 +8473,7 @@
           <a:p>
             <a:pPr>
               <a:spcAft>
-                <a:spcPts val="400"/>
+                <a:spcPts val="300"/>
               </a:spcAft>
               <a:defRPr sz="1050">
                 <a:solidFill>
@@ -8489,7 +8489,7 @@
           <a:p>
             <a:pPr>
               <a:spcAft>
-                <a:spcPts val="400"/>
+                <a:spcPts val="300"/>
               </a:spcAft>
               <a:defRPr sz="1050">
                 <a:solidFill>
@@ -8576,9 +8576,9 @@
           <a:p>
             <a:pPr>
               <a:spcAft>
-                <a:spcPts val="600"/>
+                <a:spcPts val="500"/>
               </a:spcAft>
-              <a:defRPr sz="1300" b="1">
+              <a:defRPr sz="1250" b="1">
                 <a:solidFill>
                   <a:srgbClr val="0F172A"/>
                 </a:solidFill>
@@ -8592,7 +8592,7 @@
           <a:p>
             <a:pPr>
               <a:spcAft>
-                <a:spcPts val="400"/>
+                <a:spcPts val="300"/>
               </a:spcAft>
               <a:defRPr sz="1050">
                 <a:solidFill>
@@ -8608,7 +8608,7 @@
           <a:p>
             <a:pPr>
               <a:spcAft>
-                <a:spcPts val="400"/>
+                <a:spcPts val="300"/>
               </a:spcAft>
               <a:defRPr sz="1050">
                 <a:solidFill>
@@ -8624,7 +8624,7 @@
           <a:p>
             <a:pPr>
               <a:spcAft>
-                <a:spcPts val="400"/>
+                <a:spcPts val="300"/>
               </a:spcAft>
               <a:defRPr sz="1050">
                 <a:solidFill>
@@ -8711,9 +8711,9 @@
           <a:p>
             <a:pPr>
               <a:spcAft>
-                <a:spcPts val="600"/>
+                <a:spcPts val="500"/>
               </a:spcAft>
-              <a:defRPr sz="1300" b="1">
+              <a:defRPr sz="1250" b="1">
                 <a:solidFill>
                   <a:srgbClr val="0F172A"/>
                 </a:solidFill>
@@ -8727,7 +8727,7 @@
           <a:p>
             <a:pPr>
               <a:spcAft>
-                <a:spcPts val="400"/>
+                <a:spcPts val="300"/>
               </a:spcAft>
               <a:defRPr sz="1050">
                 <a:solidFill>
@@ -8743,7 +8743,7 @@
           <a:p>
             <a:pPr>
               <a:spcAft>
-                <a:spcPts val="400"/>
+                <a:spcPts val="300"/>
               </a:spcAft>
               <a:defRPr sz="1050">
                 <a:solidFill>
@@ -8759,7 +8759,7 @@
           <a:p>
             <a:pPr>
               <a:spcAft>
-                <a:spcPts val="400"/>
+                <a:spcPts val="300"/>
               </a:spcAft>
               <a:defRPr sz="1050">
                 <a:solidFill>
@@ -8840,7 +8840,7 @@
               </a:defRPr>
             </a:pPr>
             <a:r>
-              <a:t>PENGAMBILAN KEPUTUSAN CLOSED-LOOP: </a:t>
+              <a:t>Pengambilan Keputusan Closed-Loop: </a:t>
             </a:r>
             <a:r>
               <a:rPr sz="1050">
@@ -8888,8 +8888,8 @@
         </p:nvSpPr>
         <p:spPr>
           <a:xfrm>
-            <a:off x="731520" y="365760"/>
-            <a:ext cx="73152" cy="777240"/>
+            <a:off x="731520" y="384048"/>
+            <a:ext cx="54864" cy="713232"/>
           </a:xfrm>
           <a:prstGeom prst="rect">
             <a:avLst/>
@@ -8931,7 +8931,79 @@
         </p:nvSpPr>
         <p:spPr>
           <a:xfrm>
-            <a:off x="914400" y="320040"/>
+            <a:off x="868680" y="347472"/>
+            <a:ext cx="10515600" cy="219456"/>
+          </a:xfrm>
+          <a:prstGeom prst="rect">
+            <a:avLst/>
+          </a:prstGeom>
+          <a:noFill/>
+        </p:spPr>
+        <p:txBody>
+          <a:bodyPr wrap="square">
+            <a:spAutoFit/>
+          </a:bodyPr>
+          <a:lstStyle/>
+          <a:p>
+            <a:pPr>
+              <a:defRPr sz="950" b="1">
+                <a:solidFill>
+                  <a:srgbClr val="980517"/>
+                </a:solidFill>
+                <a:latin typeface="Arial"/>
+              </a:defRPr>
+            </a:pPr>
+            <a:r>
+              <a:t>RENCANA PENERAPAN &amp; MITIGASI</a:t>
+            </a:r>
+          </a:p>
+        </p:txBody>
+      </p:sp>
+      <p:sp>
+        <p:nvSpPr>
+          <p:cNvPr id="4" name="TextBox 3"/>
+          <p:cNvSpPr txBox="1"/>
+          <p:nvPr/>
+        </p:nvSpPr>
+        <p:spPr>
+          <a:xfrm>
+            <a:off x="868680" y="548640"/>
+            <a:ext cx="10515600" cy="384048"/>
+          </a:xfrm>
+          <a:prstGeom prst="rect">
+            <a:avLst/>
+          </a:prstGeom>
+          <a:noFill/>
+        </p:spPr>
+        <p:txBody>
+          <a:bodyPr wrap="square">
+            <a:spAutoFit/>
+          </a:bodyPr>
+          <a:lstStyle/>
+          <a:p>
+            <a:pPr>
+              <a:defRPr sz="1900" b="1">
+                <a:solidFill>
+                  <a:srgbClr val="0F172A"/>
+                </a:solidFill>
+                <a:latin typeface="Arial"/>
+              </a:defRPr>
+            </a:pPr>
+            <a:r>
+              <a:t>Prioritas Implementasi &amp; Manajemen Risiko Lapangan</a:t>
+            </a:r>
+          </a:p>
+        </p:txBody>
+      </p:sp>
+      <p:sp>
+        <p:nvSpPr>
+          <p:cNvPr id="5" name="TextBox 4"/>
+          <p:cNvSpPr txBox="1"/>
+          <p:nvPr/>
+        </p:nvSpPr>
+        <p:spPr>
+          <a:xfrm>
+            <a:off x="868680" y="932688"/>
             <a:ext cx="10515600" cy="256032"/>
           </a:xfrm>
           <a:prstGeom prst="rect">
@@ -8946,79 +9018,7 @@
           <a:lstStyle/>
           <a:p>
             <a:pPr>
-              <a:defRPr sz="1000" b="1">
-                <a:solidFill>
-                  <a:srgbClr val="980517"/>
-                </a:solidFill>
-                <a:latin typeface="Arial"/>
-              </a:defRPr>
-            </a:pPr>
-            <a:r>
-              <a:t>SLIDE 7 • IMPLEMENTATION AND RISKS   |   RUBRIK: FEASIBILITY &amp; RISK MITIGATION (15%)</a:t>
-            </a:r>
-          </a:p>
-        </p:txBody>
-      </p:sp>
-      <p:sp>
-        <p:nvSpPr>
-          <p:cNvPr id="4" name="TextBox 3"/>
-          <p:cNvSpPr txBox="1"/>
-          <p:nvPr/>
-        </p:nvSpPr>
-        <p:spPr>
-          <a:xfrm>
-            <a:off x="914400" y="548640"/>
-            <a:ext cx="10515600" cy="411480"/>
-          </a:xfrm>
-          <a:prstGeom prst="rect">
-            <a:avLst/>
-          </a:prstGeom>
-          <a:noFill/>
-        </p:spPr>
-        <p:txBody>
-          <a:bodyPr wrap="square">
-            <a:spAutoFit/>
-          </a:bodyPr>
-          <a:lstStyle/>
-          <a:p>
-            <a:pPr>
-              <a:defRPr sz="2000" b="1">
-                <a:solidFill>
-                  <a:srgbClr val="0F172A"/>
-                </a:solidFill>
-                <a:latin typeface="Arial"/>
-              </a:defRPr>
-            </a:pPr>
-            <a:r>
-              <a:t>PRIORITAS IMPLEMENTASI &amp; MITIGASI RISIKO LAPANGAN</a:t>
-            </a:r>
-          </a:p>
-        </p:txBody>
-      </p:sp>
-      <p:sp>
-        <p:nvSpPr>
-          <p:cNvPr id="5" name="TextBox 4"/>
-          <p:cNvSpPr txBox="1"/>
-          <p:nvPr/>
-        </p:nvSpPr>
-        <p:spPr>
-          <a:xfrm>
-            <a:off x="914400" y="960120"/>
-            <a:ext cx="10515600" cy="274320"/>
-          </a:xfrm>
-          <a:prstGeom prst="rect">
-            <a:avLst/>
-          </a:prstGeom>
-          <a:noFill/>
-        </p:spPr>
-        <p:txBody>
-          <a:bodyPr wrap="square">
-            <a:spAutoFit/>
-          </a:bodyPr>
-          <a:lstStyle/>
-          <a:p>
-            <a:pPr>
-              <a:defRPr sz="1150">
+              <a:defRPr sz="1100">
                 <a:solidFill>
                   <a:srgbClr val="475569"/>
                 </a:solidFill>
@@ -9026,7 +9026,7 @@
               </a:defRPr>
             </a:pPr>
             <a:r>
-              <a:t>Tiga langkah penerapan terencana, kesiapan SDM, serta mitigasi risiko kontingensi darurat hari-H pembagian.</a:t>
+              <a:t>Tahapan kesiapan operasional serta prosedur kontingensi darurat saat hari-H distribusi</a:t>
             </a:r>
           </a:p>
         </p:txBody>
@@ -9039,8 +9039,8 @@
         </p:nvSpPr>
         <p:spPr>
           <a:xfrm>
-            <a:off x="731520" y="1261872"/>
-            <a:ext cx="10728655" cy="13716"/>
+            <a:off x="731520" y="1243584"/>
+            <a:ext cx="10728655" cy="10972"/>
           </a:xfrm>
           <a:prstGeom prst="rect">
             <a:avLst/>
@@ -9130,9 +9130,9 @@
           <a:p>
             <a:pPr>
               <a:spcAft>
-                <a:spcPts val="600"/>
+                <a:spcPts val="500"/>
               </a:spcAft>
-              <a:defRPr sz="1300" b="1">
+              <a:defRPr sz="1250" b="1">
                 <a:solidFill>
                   <a:srgbClr val="0F172A"/>
                 </a:solidFill>
@@ -9146,7 +9146,7 @@
           <a:p>
             <a:pPr>
               <a:spcAft>
-                <a:spcPts val="400"/>
+                <a:spcPts val="300"/>
               </a:spcAft>
               <a:defRPr sz="1050">
                 <a:solidFill>
@@ -9162,7 +9162,7 @@
           <a:p>
             <a:pPr>
               <a:spcAft>
-                <a:spcPts val="400"/>
+                <a:spcPts val="300"/>
               </a:spcAft>
               <a:defRPr sz="1050">
                 <a:solidFill>
@@ -9178,7 +9178,7 @@
           <a:p>
             <a:pPr>
               <a:spcAft>
-                <a:spcPts val="400"/>
+                <a:spcPts val="300"/>
               </a:spcAft>
               <a:defRPr sz="1050">
                 <a:solidFill>
@@ -9259,15 +9259,15 @@
               </a:defRPr>
             </a:pPr>
             <a:r>
-              <a:t>3 RISIKO DARURAT LAPANGAN &amp; CARA MITIGASI</a:t>
+              <a:t>3 RISIKO LAPANGAN &amp; CARA MITIGASI</a:t>
             </a:r>
           </a:p>
           <a:p>
             <a:pPr>
               <a:spcAft>
-                <a:spcPts val="600"/>
+                <a:spcPts val="500"/>
               </a:spcAft>
-              <a:defRPr sz="1300" b="1">
+              <a:defRPr sz="1250" b="1">
                 <a:solidFill>
                   <a:srgbClr val="0F172A"/>
                 </a:solidFill>
@@ -9281,7 +9281,7 @@
           <a:p>
             <a:pPr>
               <a:spcAft>
-                <a:spcPts val="400"/>
+                <a:spcPts val="300"/>
               </a:spcAft>
               <a:defRPr sz="1050">
                 <a:solidFill>
@@ -9305,7 +9305,7 @@
           <a:p>
             <a:pPr>
               <a:spcAft>
-                <a:spcPts val="400"/>
+                <a:spcPts val="300"/>
               </a:spcAft>
               <a:defRPr sz="1050">
                 <a:solidFill>
@@ -9329,7 +9329,7 @@
           <a:p>
             <a:pPr>
               <a:spcAft>
-                <a:spcPts val="400"/>
+                <a:spcPts val="300"/>
               </a:spcAft>
               <a:defRPr sz="1050">
                 <a:solidFill>
@@ -9418,7 +9418,7 @@
               </a:defRPr>
             </a:pPr>
             <a:r>
-              <a:t>RESILIENSI OPERASIONAL TINGGI: </a:t>
+              <a:t>Resiliensi Operasional Tinggi: </a:t>
             </a:r>
             <a:r>
               <a:rPr sz="1050">
@@ -9466,8 +9466,8 @@
         </p:nvSpPr>
         <p:spPr>
           <a:xfrm>
-            <a:off x="731520" y="365760"/>
-            <a:ext cx="73152" cy="777240"/>
+            <a:off x="731520" y="384048"/>
+            <a:ext cx="54864" cy="713232"/>
           </a:xfrm>
           <a:prstGeom prst="rect">
             <a:avLst/>
@@ -9509,7 +9509,79 @@
         </p:nvSpPr>
         <p:spPr>
           <a:xfrm>
-            <a:off x="914400" y="320040"/>
+            <a:off x="868680" y="347472"/>
+            <a:ext cx="10515600" cy="219456"/>
+          </a:xfrm>
+          <a:prstGeom prst="rect">
+            <a:avLst/>
+          </a:prstGeom>
+          <a:noFill/>
+        </p:spPr>
+        <p:txBody>
+          <a:bodyPr wrap="square">
+            <a:spAutoFit/>
+          </a:bodyPr>
+          <a:lstStyle/>
+          <a:p>
+            <a:pPr>
+              <a:defRPr sz="950" b="1">
+                <a:solidFill>
+                  <a:srgbClr val="980517"/>
+                </a:solidFill>
+                <a:latin typeface="Arial"/>
+              </a:defRPr>
+            </a:pPr>
+            <a:r>
+              <a:t>KESIMPULAN &amp; HASIL TERUKUR</a:t>
+            </a:r>
+          </a:p>
+        </p:txBody>
+      </p:sp>
+      <p:sp>
+        <p:nvSpPr>
+          <p:cNvPr id="4" name="TextBox 3"/>
+          <p:cNvSpPr txBox="1"/>
+          <p:nvPr/>
+        </p:nvSpPr>
+        <p:spPr>
+          <a:xfrm>
+            <a:off x="868680" y="548640"/>
+            <a:ext cx="10515600" cy="384048"/>
+          </a:xfrm>
+          <a:prstGeom prst="rect">
+            <a:avLst/>
+          </a:prstGeom>
+          <a:noFill/>
+        </p:spPr>
+        <p:txBody>
+          <a:bodyPr wrap="square">
+            <a:spAutoFit/>
+          </a:bodyPr>
+          <a:lstStyle/>
+          <a:p>
+            <a:pPr>
+              <a:defRPr sz="1900" b="1">
+                <a:solidFill>
+                  <a:srgbClr val="0F172A"/>
+                </a:solidFill>
+                <a:latin typeface="Arial"/>
+              </a:defRPr>
+            </a:pPr>
+            <a:r>
+              <a:t>Dampak Strategis &amp; Manfaat Nyata Implementasi</a:t>
+            </a:r>
+          </a:p>
+        </p:txBody>
+      </p:sp>
+      <p:sp>
+        <p:nvSpPr>
+          <p:cNvPr id="5" name="TextBox 4"/>
+          <p:cNvSpPr txBox="1"/>
+          <p:nvPr/>
+        </p:nvSpPr>
+        <p:spPr>
+          <a:xfrm>
+            <a:off x="868680" y="932688"/>
             <a:ext cx="10515600" cy="256032"/>
           </a:xfrm>
           <a:prstGeom prst="rect">
@@ -9524,79 +9596,7 @@
           <a:lstStyle/>
           <a:p>
             <a:pPr>
-              <a:defRPr sz="1000" b="1">
-                <a:solidFill>
-                  <a:srgbClr val="980517"/>
-                </a:solidFill>
-                <a:latin typeface="Arial"/>
-              </a:defRPr>
-            </a:pPr>
-            <a:r>
-              <a:t>SLIDE 8 • CONCLUSION &amp; BENEFITS   |   RUBRIK: PRESENTATION &amp; IMPACT (15%)</a:t>
-            </a:r>
-          </a:p>
-        </p:txBody>
-      </p:sp>
-      <p:sp>
-        <p:nvSpPr>
-          <p:cNvPr id="4" name="TextBox 3"/>
-          <p:cNvSpPr txBox="1"/>
-          <p:nvPr/>
-        </p:nvSpPr>
-        <p:spPr>
-          <a:xfrm>
-            <a:off x="914400" y="548640"/>
-            <a:ext cx="10515600" cy="411480"/>
-          </a:xfrm>
-          <a:prstGeom prst="rect">
-            <a:avLst/>
-          </a:prstGeom>
-          <a:noFill/>
-        </p:spPr>
-        <p:txBody>
-          <a:bodyPr wrap="square">
-            <a:spAutoFit/>
-          </a:bodyPr>
-          <a:lstStyle/>
-          <a:p>
-            <a:pPr>
-              <a:defRPr sz="2000" b="1">
-                <a:solidFill>
-                  <a:srgbClr val="0F172A"/>
-                </a:solidFill>
-                <a:latin typeface="Arial"/>
-              </a:defRPr>
-            </a:pPr>
-            <a:r>
-              <a:t>KESIMPULAN &amp; TIGA MANFAAT TERUKUR YANG DIHASILKAN</a:t>
-            </a:r>
-          </a:p>
-        </p:txBody>
-      </p:sp>
-      <p:sp>
-        <p:nvSpPr>
-          <p:cNvPr id="5" name="TextBox 4"/>
-          <p:cNvSpPr txBox="1"/>
-          <p:nvPr/>
-        </p:nvSpPr>
-        <p:spPr>
-          <a:xfrm>
-            <a:off x="914400" y="960120"/>
-            <a:ext cx="10515600" cy="274320"/>
-          </a:xfrm>
-          <a:prstGeom prst="rect">
-            <a:avLst/>
-          </a:prstGeom>
-          <a:noFill/>
-        </p:spPr>
-        <p:txBody>
-          <a:bodyPr wrap="square">
-            <a:spAutoFit/>
-          </a:bodyPr>
-          <a:lstStyle/>
-          <a:p>
-            <a:pPr>
-              <a:defRPr sz="1150">
+              <a:defRPr sz="1100">
                 <a:solidFill>
                   <a:srgbClr val="475569"/>
                 </a:solidFill>
@@ -9604,7 +9604,7 @@
               </a:defRPr>
             </a:pPr>
             <a:r>
-              <a:t>Rangkuman dampak nyata sistem informasi HorizonU Uniform (UniStock SCM) bagi efisiensi operasional dan akuntabilitas keuangan.</a:t>
+              <a:t>Transformasi operasional Departemen Keuangan Universitas Horizon Indonesia pasca-digitalisasi</a:t>
             </a:r>
           </a:p>
         </p:txBody>
@@ -9617,8 +9617,8 @@
         </p:nvSpPr>
         <p:spPr>
           <a:xfrm>
-            <a:off x="731520" y="1261872"/>
-            <a:ext cx="10728655" cy="13716"/>
+            <a:off x="731520" y="1243584"/>
+            <a:ext cx="10728655" cy="10972"/>
           </a:xfrm>
           <a:prstGeom prst="rect">
             <a:avLst/>
@@ -9708,9 +9708,9 @@
           <a:p>
             <a:pPr>
               <a:spcAft>
-                <a:spcPts val="600"/>
+                <a:spcPts val="500"/>
               </a:spcAft>
-              <a:defRPr sz="1300" b="1">
+              <a:defRPr sz="1250" b="1">
                 <a:solidFill>
                   <a:srgbClr val="0F172A"/>
                 </a:solidFill>
@@ -9724,7 +9724,7 @@
           <a:p>
             <a:pPr>
               <a:spcAft>
-                <a:spcPts val="400"/>
+                <a:spcPts val="300"/>
               </a:spcAft>
               <a:defRPr sz="1050">
                 <a:solidFill>
@@ -9740,7 +9740,7 @@
           <a:p>
             <a:pPr>
               <a:spcAft>
-                <a:spcPts val="400"/>
+                <a:spcPts val="300"/>
               </a:spcAft>
               <a:defRPr sz="1050">
                 <a:solidFill>
@@ -9756,7 +9756,7 @@
           <a:p>
             <a:pPr>
               <a:spcAft>
-                <a:spcPts val="400"/>
+                <a:spcPts val="300"/>
               </a:spcAft>
               <a:defRPr sz="1050">
                 <a:solidFill>
@@ -9843,9 +9843,9 @@
           <a:p>
             <a:pPr>
               <a:spcAft>
-                <a:spcPts val="600"/>
+                <a:spcPts val="500"/>
               </a:spcAft>
-              <a:defRPr sz="1300" b="1">
+              <a:defRPr sz="1250" b="1">
                 <a:solidFill>
                   <a:srgbClr val="0F172A"/>
                 </a:solidFill>
@@ -9859,7 +9859,7 @@
           <a:p>
             <a:pPr>
               <a:spcAft>
-                <a:spcPts val="400"/>
+                <a:spcPts val="300"/>
               </a:spcAft>
               <a:defRPr sz="1050">
                 <a:solidFill>
@@ -9875,7 +9875,7 @@
           <a:p>
             <a:pPr>
               <a:spcAft>
-                <a:spcPts val="400"/>
+                <a:spcPts val="300"/>
               </a:spcAft>
               <a:defRPr sz="1050">
                 <a:solidFill>
@@ -9891,7 +9891,7 @@
           <a:p>
             <a:pPr>
               <a:spcAft>
-                <a:spcPts val="400"/>
+                <a:spcPts val="300"/>
               </a:spcAft>
               <a:defRPr sz="1050">
                 <a:solidFill>
@@ -9978,9 +9978,9 @@
           <a:p>
             <a:pPr>
               <a:spcAft>
-                <a:spcPts val="600"/>
+                <a:spcPts val="500"/>
               </a:spcAft>
-              <a:defRPr sz="1300" b="1">
+              <a:defRPr sz="1250" b="1">
                 <a:solidFill>
                   <a:srgbClr val="0F172A"/>
                 </a:solidFill>
@@ -9994,7 +9994,7 @@
           <a:p>
             <a:pPr>
               <a:spcAft>
-                <a:spcPts val="400"/>
+                <a:spcPts val="300"/>
               </a:spcAft>
               <a:defRPr sz="1050">
                 <a:solidFill>
@@ -10010,7 +10010,7 @@
           <a:p>
             <a:pPr>
               <a:spcAft>
-                <a:spcPts val="400"/>
+                <a:spcPts val="300"/>
               </a:spcAft>
               <a:defRPr sz="1050">
                 <a:solidFill>
@@ -10026,7 +10026,7 @@
           <a:p>
             <a:pPr>
               <a:spcAft>
-                <a:spcPts val="400"/>
+                <a:spcPts val="300"/>
               </a:spcAft>
               <a:defRPr sz="1050">
                 <a:solidFill>
@@ -10107,7 +10107,7 @@
               </a:defRPr>
             </a:pPr>
             <a:r>
-              <a:t>KESIMPULAN STRATEGIS SISTEM INFORMASI: </a:t>
+              <a:t>Kesimpulan Strategis Sistem Informasi: </a:t>
             </a:r>
             <a:r>
               <a:rPr sz="1050">

</xml_diff>

<commit_message>
refactor: remove bottom callout banners from all slides in html and pptx
</commit_message>
<xml_diff>
--- a/HorizonU_Uniform_UniStock_SCM_Presentasi_Technospark.pptx
+++ b/HorizonU_Uniform_UniStock_SCM_Presentasi_Technospark.pptx
@@ -4455,7 +4455,7 @@
         <p:spPr>
           <a:xfrm>
             <a:off x="731520" y="1417320"/>
-            <a:ext cx="3429000" cy="4297680"/>
+            <a:ext cx="3429000" cy="4800600"/>
           </a:xfrm>
           <a:prstGeom prst="roundRect">
             <a:avLst/>
@@ -4590,7 +4590,7 @@
         <p:spPr>
           <a:xfrm>
             <a:off x="4370832" y="1417320"/>
-            <a:ext cx="3429000" cy="4297680"/>
+            <a:ext cx="3429000" cy="4800600"/>
           </a:xfrm>
           <a:prstGeom prst="roundRect">
             <a:avLst/>
@@ -4725,7 +4725,7 @@
         <p:spPr>
           <a:xfrm>
             <a:off x="8010144" y="1417320"/>
-            <a:ext cx="3429000" cy="4297680"/>
+            <a:ext cx="3429000" cy="4800600"/>
           </a:xfrm>
           <a:prstGeom prst="roundRect">
             <a:avLst/>
@@ -4895,70 +4895,6 @@
             </a:pPr>
             <a:r>
               <a:t>➔  URL Sistem: unistok.nirwana.biz.id</a:t>
-            </a:r>
-          </a:p>
-        </p:txBody>
-      </p:sp>
-      <p:sp>
-        <p:nvSpPr>
-          <p:cNvPr id="10" name="Rounded Rectangle 9"/>
-          <p:cNvSpPr/>
-          <p:nvPr/>
-        </p:nvSpPr>
-        <p:spPr>
-          <a:xfrm>
-            <a:off x="731520" y="5870448"/>
-            <a:ext cx="10728655" cy="658368"/>
-          </a:xfrm>
-          <a:prstGeom prst="roundRect">
-            <a:avLst/>
-          </a:prstGeom>
-          <a:solidFill>
-            <a:srgbClr val="FEF2F2"/>
-          </a:solidFill>
-          <a:ln w="19050">
-            <a:solidFill>
-              <a:srgbClr val="980517"/>
-            </a:solidFill>
-          </a:ln>
-        </p:spPr>
-        <p:style>
-          <a:lnRef idx="1">
-            <a:schemeClr val="accent1"/>
-          </a:lnRef>
-          <a:fillRef idx="3">
-            <a:schemeClr val="accent1"/>
-          </a:fillRef>
-          <a:effectRef idx="2">
-            <a:schemeClr val="accent1"/>
-          </a:effectRef>
-          <a:fontRef idx="minor">
-            <a:schemeClr val="lt1"/>
-          </a:fontRef>
-        </p:style>
-        <p:txBody>
-          <a:bodyPr rtlCol="0" anchor="ctr" wrap="square" lIns="228600" rIns="228600"/>
-          <a:lstStyle/>
-          <a:p>
-            <a:pPr algn="ctr">
-              <a:defRPr sz="1050" b="1">
-                <a:solidFill>
-                  <a:srgbClr val="980517"/>
-                </a:solidFill>
-                <a:latin typeface="Arial"/>
-              </a:defRPr>
-            </a:pPr>
-            <a:r>
-              <a:t>Misi Solusi HorizonU Uniform: </a:t>
-            </a:r>
-            <a:r>
-              <a:rPr sz="1050">
-                <a:solidFill>
-                  <a:srgbClr val="0F172A"/>
-                </a:solidFill>
-                <a:latin typeface="Calibri"/>
-              </a:rPr>
-              <a:t>Menghubungkan Hulu (Vendor Pabrik), Gudang Kampus, Bagian Keuangan, hingga Hilir (Mahasiswa) dalam satu arsitektur terintegrasi bertenaga Laravel 12 dan aturan FIFO.</a:t>
             </a:r>
           </a:p>
         </p:txBody>
@@ -5192,7 +5128,7 @@
         <p:spPr>
           <a:xfrm>
             <a:off x="731520" y="1417320"/>
-            <a:ext cx="2542032" cy="4297680"/>
+            <a:ext cx="2542032" cy="4800600"/>
           </a:xfrm>
           <a:prstGeom prst="roundRect">
             <a:avLst/>
@@ -5327,7 +5263,7 @@
         <p:spPr>
           <a:xfrm>
             <a:off x="3456432" y="1417320"/>
-            <a:ext cx="2542032" cy="4297680"/>
+            <a:ext cx="2542032" cy="4800600"/>
           </a:xfrm>
           <a:prstGeom prst="roundRect">
             <a:avLst/>
@@ -5462,7 +5398,7 @@
         <p:spPr>
           <a:xfrm>
             <a:off x="6181344" y="1417320"/>
-            <a:ext cx="2542032" cy="4297680"/>
+            <a:ext cx="2542032" cy="4800600"/>
           </a:xfrm>
           <a:prstGeom prst="roundRect">
             <a:avLst/>
@@ -5597,7 +5533,7 @@
         <p:spPr>
           <a:xfrm>
             <a:off x="8906256" y="1417320"/>
-            <a:ext cx="2542032" cy="4297680"/>
+            <a:ext cx="2542032" cy="4800600"/>
           </a:xfrm>
           <a:prstGeom prst="roundRect">
             <a:avLst/>
@@ -5719,70 +5655,6 @@
             </a:pPr>
             <a:r>
               <a:t>➔  Aliran: Profil ➔ Seragam Pas</a:t>
-            </a:r>
-          </a:p>
-        </p:txBody>
-      </p:sp>
-      <p:sp>
-        <p:nvSpPr>
-          <p:cNvPr id="11" name="Rounded Rectangle 10"/>
-          <p:cNvSpPr/>
-          <p:nvPr/>
-        </p:nvSpPr>
-        <p:spPr>
-          <a:xfrm>
-            <a:off x="731520" y="5870448"/>
-            <a:ext cx="10728655" cy="658368"/>
-          </a:xfrm>
-          <a:prstGeom prst="roundRect">
-            <a:avLst/>
-          </a:prstGeom>
-          <a:solidFill>
-            <a:srgbClr val="FEF2F2"/>
-          </a:solidFill>
-          <a:ln w="19050">
-            <a:solidFill>
-              <a:srgbClr val="980517"/>
-            </a:solidFill>
-          </a:ln>
-        </p:spPr>
-        <p:style>
-          <a:lnRef idx="1">
-            <a:schemeClr val="accent1"/>
-          </a:lnRef>
-          <a:fillRef idx="3">
-            <a:schemeClr val="accent1"/>
-          </a:fillRef>
-          <a:effectRef idx="2">
-            <a:schemeClr val="accent1"/>
-          </a:effectRef>
-          <a:fontRef idx="minor">
-            <a:schemeClr val="lt1"/>
-          </a:fontRef>
-        </p:style>
-        <p:txBody>
-          <a:bodyPr rtlCol="0" anchor="ctr" wrap="square" lIns="228600" rIns="228600"/>
-          <a:lstStyle/>
-          <a:p>
-            <a:pPr algn="ctr">
-              <a:defRPr sz="1050" b="1">
-                <a:solidFill>
-                  <a:srgbClr val="980517"/>
-                </a:solidFill>
-                <a:latin typeface="Arial"/>
-              </a:defRPr>
-            </a:pPr>
-            <a:r>
-              <a:t>Prinsip Inti 'Data Mengunci Fisik': </a:t>
-            </a:r>
-            <a:r>
-              <a:rPr sz="1050">
-                <a:solidFill>
-                  <a:srgbClr val="0F172A"/>
-                </a:solidFill>
-                <a:latin typeface="Calibri"/>
-              </a:rPr>
-              <a:t>Barang fisik di loket gudang pantang diserahkan tanpa otorisasi digital. Pemindaian QR Code mengeksekusi validasi atomik di database: jika belum lunas atau kuota habis, fisik seragam tidak dapat keluar.</a:t>
             </a:r>
           </a:p>
         </p:txBody>
@@ -6017,7 +5889,7 @@
         </p:nvGraphicFramePr>
         <p:xfrm>
           <a:off x="731520" y="1417320"/>
-          <a:ext cx="10728655" cy="4297680"/>
+          <a:ext cx="10728655" cy="4800600"/>
         </p:xfrm>
         <a:graphic>
           <a:graphicData uri="http://schemas.openxmlformats.org/drawingml/2006/table">
@@ -6030,7 +5902,7 @@
                 <a:gridCol w="3840480"/>
                 <a:gridCol w="3962095"/>
               </a:tblGrid>
-              <a:tr h="859536">
+              <a:tr h="960120">
                 <a:tc>
                   <a:txBody>
                     <a:bodyPr/>
@@ -6104,7 +5976,7 @@
                   </a:tcPr>
                 </a:tc>
               </a:tr>
-              <a:tr h="859536">
+              <a:tr h="960120">
                 <a:tc>
                   <a:txBody>
                     <a:bodyPr/>
@@ -6178,7 +6050,7 @@
                   </a:tcPr>
                 </a:tc>
               </a:tr>
-              <a:tr h="859536">
+              <a:tr h="960120">
                 <a:tc>
                   <a:txBody>
                     <a:bodyPr/>
@@ -6252,7 +6124,7 @@
                   </a:tcPr>
                 </a:tc>
               </a:tr>
-              <a:tr h="859536">
+              <a:tr h="960120">
                 <a:tc>
                   <a:txBody>
                     <a:bodyPr/>
@@ -6326,7 +6198,7 @@
                   </a:tcPr>
                 </a:tc>
               </a:tr>
-              <a:tr h="859536">
+              <a:tr h="960120">
                 <a:tc>
                   <a:txBody>
                     <a:bodyPr/>
@@ -6404,70 +6276,6 @@
           </a:graphicData>
         </a:graphic>
       </p:graphicFrame>
-      <p:sp>
-        <p:nvSpPr>
-          <p:cNvPr id="8" name="Rounded Rectangle 7"/>
-          <p:cNvSpPr/>
-          <p:nvPr/>
-        </p:nvSpPr>
-        <p:spPr>
-          <a:xfrm>
-            <a:off x="731520" y="5870448"/>
-            <a:ext cx="10728655" cy="658368"/>
-          </a:xfrm>
-          <a:prstGeom prst="roundRect">
-            <a:avLst/>
-          </a:prstGeom>
-          <a:solidFill>
-            <a:srgbClr val="FEF2F2"/>
-          </a:solidFill>
-          <a:ln w="19050">
-            <a:solidFill>
-              <a:srgbClr val="980517"/>
-            </a:solidFill>
-          </a:ln>
-        </p:spPr>
-        <p:style>
-          <a:lnRef idx="1">
-            <a:schemeClr val="accent1"/>
-          </a:lnRef>
-          <a:fillRef idx="3">
-            <a:schemeClr val="accent1"/>
-          </a:fillRef>
-          <a:effectRef idx="2">
-            <a:schemeClr val="accent1"/>
-          </a:effectRef>
-          <a:fontRef idx="minor">
-            <a:schemeClr val="lt1"/>
-          </a:fontRef>
-        </p:style>
-        <p:txBody>
-          <a:bodyPr rtlCol="0" anchor="ctr" wrap="square" lIns="228600" rIns="228600"/>
-          <a:lstStyle/>
-          <a:p>
-            <a:pPr algn="ctr">
-              <a:defRPr sz="1050" b="1">
-                <a:solidFill>
-                  <a:srgbClr val="980517"/>
-                </a:solidFill>
-                <a:latin typeface="Arial"/>
-              </a:defRPr>
-            </a:pPr>
-            <a:r>
-              <a:t>Akar Kegagalan Sistemik: </a:t>
-            </a:r>
-            <a:r>
-              <a:rPr sz="1050">
-                <a:solidFill>
-                  <a:srgbClr val="0F172A"/>
-                </a:solidFill>
-                <a:latin typeface="Calibri"/>
-              </a:rPr>
-              <a:t>Ketiadaan Single Source of Truth berbasis database relasional menyebabkan silo data antar-staf, memicu kebocoran persediaan, dan membahayakan akuntabilitas keuangan.</a:t>
-            </a:r>
-          </a:p>
-        </p:txBody>
-      </p:sp>
     </p:spTree>
   </p:cSld>
   <p:clrMapOvr>
@@ -6697,7 +6505,7 @@
         <p:spPr>
           <a:xfrm>
             <a:off x="731520" y="1417320"/>
-            <a:ext cx="5257800" cy="2057400"/>
+            <a:ext cx="5257800" cy="2331720"/>
           </a:xfrm>
           <a:prstGeom prst="roundRect">
             <a:avLst/>
@@ -6816,7 +6624,7 @@
         <p:spPr>
           <a:xfrm>
             <a:off x="6199632" y="1417320"/>
-            <a:ext cx="5257800" cy="2057400"/>
+            <a:ext cx="5257800" cy="2331720"/>
           </a:xfrm>
           <a:prstGeom prst="roundRect">
             <a:avLst/>
@@ -6934,8 +6742,8 @@
         </p:nvSpPr>
         <p:spPr>
           <a:xfrm>
-            <a:off x="731520" y="3657600"/>
-            <a:ext cx="5257800" cy="2057400"/>
+            <a:off x="731520" y="3886200"/>
+            <a:ext cx="5257800" cy="2331720"/>
           </a:xfrm>
           <a:prstGeom prst="roundRect">
             <a:avLst/>
@@ -7053,8 +6861,8 @@
         </p:nvSpPr>
         <p:spPr>
           <a:xfrm>
-            <a:off x="6199632" y="3657600"/>
-            <a:ext cx="5257800" cy="2057400"/>
+            <a:off x="6199632" y="3886200"/>
+            <a:ext cx="5257800" cy="2331720"/>
           </a:xfrm>
           <a:prstGeom prst="roundRect">
             <a:avLst/>
@@ -7160,70 +6968,6 @@
             </a:pPr>
             <a:r>
               <a:t>➔  Kondisi: Informasi Tidak Akurat (Blind Ordering)</a:t>
-            </a:r>
-          </a:p>
-        </p:txBody>
-      </p:sp>
-      <p:sp>
-        <p:nvSpPr>
-          <p:cNvPr id="11" name="Rounded Rectangle 10"/>
-          <p:cNvSpPr/>
-          <p:nvPr/>
-        </p:nvSpPr>
-        <p:spPr>
-          <a:xfrm>
-            <a:off x="731520" y="5870448"/>
-            <a:ext cx="10728655" cy="658368"/>
-          </a:xfrm>
-          <a:prstGeom prst="roundRect">
-            <a:avLst/>
-          </a:prstGeom>
-          <a:solidFill>
-            <a:srgbClr val="FEF2F2"/>
-          </a:solidFill>
-          <a:ln w="19050">
-            <a:solidFill>
-              <a:srgbClr val="980517"/>
-            </a:solidFill>
-          </a:ln>
-        </p:spPr>
-        <p:style>
-          <a:lnRef idx="1">
-            <a:schemeClr val="accent1"/>
-          </a:lnRef>
-          <a:fillRef idx="3">
-            <a:schemeClr val="accent1"/>
-          </a:fillRef>
-          <a:effectRef idx="2">
-            <a:schemeClr val="accent1"/>
-          </a:effectRef>
-          <a:fontRef idx="minor">
-            <a:schemeClr val="lt1"/>
-          </a:fontRef>
-        </p:style>
-        <p:txBody>
-          <a:bodyPr rtlCol="0" anchor="ctr" wrap="square" lIns="228600" rIns="228600"/>
-          <a:lstStyle/>
-          <a:p>
-            <a:pPr algn="ctr">
-              <a:defRPr sz="1050" b="1">
-                <a:solidFill>
-                  <a:srgbClr val="980517"/>
-                </a:solidFill>
-                <a:latin typeface="Arial"/>
-              </a:defRPr>
-            </a:pPr>
-            <a:r>
-              <a:t>Diagnosa Kunci: </a:t>
-            </a:r>
-            <a:r>
-              <a:rPr sz="1050">
-                <a:solidFill>
-                  <a:srgbClr val="0F172A"/>
-                </a:solidFill>
-                <a:latin typeface="Calibri"/>
-              </a:rPr>
-              <a:t>Terjadi Information Latency dan Data Asymmetry akut yang melumpuhkan koordinasi antar-bagian. Solusi mutlak membutuhkan platform web tunggal terpusat.</a:t>
             </a:r>
           </a:p>
         </p:txBody>
@@ -7458,7 +7202,7 @@
         </p:nvGraphicFramePr>
         <p:xfrm>
           <a:off x="731520" y="1417320"/>
-          <a:ext cx="10728654" cy="4297680"/>
+          <a:ext cx="10728654" cy="4800600"/>
         </p:xfrm>
         <a:graphic>
           <a:graphicData uri="http://schemas.openxmlformats.org/drawingml/2006/table">
@@ -7472,7 +7216,7 @@
                 <a:gridCol w="3749039"/>
                 <a:gridCol w="2041855"/>
               </a:tblGrid>
-              <a:tr h="859536">
+              <a:tr h="960120">
                 <a:tc>
                   <a:txBody>
                     <a:bodyPr/>
@@ -7570,7 +7314,7 @@
                   </a:tcPr>
                 </a:tc>
               </a:tr>
-              <a:tr h="859536">
+              <a:tr h="960120">
                 <a:tc>
                   <a:txBody>
                     <a:bodyPr/>
@@ -7668,7 +7412,7 @@
                   </a:tcPr>
                 </a:tc>
               </a:tr>
-              <a:tr h="859536">
+              <a:tr h="960120">
                 <a:tc>
                   <a:txBody>
                     <a:bodyPr/>
@@ -7766,7 +7510,7 @@
                   </a:tcPr>
                 </a:tc>
               </a:tr>
-              <a:tr h="859536">
+              <a:tr h="960120">
                 <a:tc>
                   <a:txBody>
                     <a:bodyPr/>
@@ -7864,7 +7608,7 @@
                   </a:tcPr>
                 </a:tc>
               </a:tr>
-              <a:tr h="859536">
+              <a:tr h="960120">
                 <a:tc>
                   <a:txBody>
                     <a:bodyPr/>
@@ -7966,70 +7710,6 @@
           </a:graphicData>
         </a:graphic>
       </p:graphicFrame>
-      <p:sp>
-        <p:nvSpPr>
-          <p:cNvPr id="8" name="Rounded Rectangle 7"/>
-          <p:cNvSpPr/>
-          <p:nvPr/>
-        </p:nvSpPr>
-        <p:spPr>
-          <a:xfrm>
-            <a:off x="731520" y="5870448"/>
-            <a:ext cx="10728655" cy="658368"/>
-          </a:xfrm>
-          <a:prstGeom prst="roundRect">
-            <a:avLst/>
-          </a:prstGeom>
-          <a:solidFill>
-            <a:srgbClr val="FEF2F2"/>
-          </a:solidFill>
-          <a:ln w="19050">
-            <a:solidFill>
-              <a:srgbClr val="980517"/>
-            </a:solidFill>
-          </a:ln>
-        </p:spPr>
-        <p:style>
-          <a:lnRef idx="1">
-            <a:schemeClr val="accent1"/>
-          </a:lnRef>
-          <a:fillRef idx="3">
-            <a:schemeClr val="accent1"/>
-          </a:fillRef>
-          <a:effectRef idx="2">
-            <a:schemeClr val="accent1"/>
-          </a:effectRef>
-          <a:fontRef idx="minor">
-            <a:schemeClr val="lt1"/>
-          </a:fontRef>
-        </p:style>
-        <p:txBody>
-          <a:bodyPr rtlCol="0" anchor="ctr" wrap="square" lIns="228600" rIns="228600"/>
-          <a:lstStyle/>
-          <a:p>
-            <a:pPr algn="ctr">
-              <a:defRPr sz="1050" b="1">
-                <a:solidFill>
-                  <a:srgbClr val="980517"/>
-                </a:solidFill>
-                <a:latin typeface="Arial"/>
-              </a:defRPr>
-            </a:pPr>
-            <a:r>
-              <a:t>Keunggulan Integrasi UniStock: </a:t>
-            </a:r>
-            <a:r>
-              <a:rPr sz="1050">
-                <a:solidFill>
-                  <a:srgbClr val="0F172A"/>
-                </a:solidFill>
-                <a:latin typeface="Calibri"/>
-              </a:rPr>
-              <a:t>Menyatukan keandalan ERP, perencanaan SCM, kecepatan POS loket, dan ketatnya WMS dalam satu portal monolitik Laravel 12 modern yang tangguh.</a:t>
-            </a:r>
-          </a:p>
-        </p:txBody>
-      </p:sp>
     </p:spTree>
   </p:cSld>
   <p:clrMapOvr>
@@ -8259,7 +7939,7 @@
         <p:spPr>
           <a:xfrm>
             <a:off x="731520" y="1417320"/>
-            <a:ext cx="2542032" cy="4297680"/>
+            <a:ext cx="2542032" cy="4800600"/>
           </a:xfrm>
           <a:prstGeom prst="roundRect">
             <a:avLst/>
@@ -8394,7 +8074,7 @@
         <p:spPr>
           <a:xfrm>
             <a:off x="3456432" y="1417320"/>
-            <a:ext cx="2542032" cy="4297680"/>
+            <a:ext cx="2542032" cy="4800600"/>
           </a:xfrm>
           <a:prstGeom prst="roundRect">
             <a:avLst/>
@@ -8529,7 +8209,7 @@
         <p:spPr>
           <a:xfrm>
             <a:off x="6181344" y="1417320"/>
-            <a:ext cx="2542032" cy="4297680"/>
+            <a:ext cx="2542032" cy="4800600"/>
           </a:xfrm>
           <a:prstGeom prst="roundRect">
             <a:avLst/>
@@ -8664,7 +8344,7 @@
         <p:spPr>
           <a:xfrm>
             <a:off x="8906256" y="1417320"/>
-            <a:ext cx="2542032" cy="4297680"/>
+            <a:ext cx="2542032" cy="4800600"/>
           </a:xfrm>
           <a:prstGeom prst="roundRect">
             <a:avLst/>
@@ -8786,70 +8466,6 @@
             </a:pPr>
             <a:r>
               <a:t>➔  Output: Feedback Siklus Baru</a:t>
-            </a:r>
-          </a:p>
-        </p:txBody>
-      </p:sp>
-      <p:sp>
-        <p:nvSpPr>
-          <p:cNvPr id="11" name="Rounded Rectangle 10"/>
-          <p:cNvSpPr/>
-          <p:nvPr/>
-        </p:nvSpPr>
-        <p:spPr>
-          <a:xfrm>
-            <a:off x="731520" y="5870448"/>
-            <a:ext cx="10728655" cy="658368"/>
-          </a:xfrm>
-          <a:prstGeom prst="roundRect">
-            <a:avLst/>
-          </a:prstGeom>
-          <a:solidFill>
-            <a:srgbClr val="FEF2F2"/>
-          </a:solidFill>
-          <a:ln w="19050">
-            <a:solidFill>
-              <a:srgbClr val="980517"/>
-            </a:solidFill>
-          </a:ln>
-        </p:spPr>
-        <p:style>
-          <a:lnRef idx="1">
-            <a:schemeClr val="accent1"/>
-          </a:lnRef>
-          <a:fillRef idx="3">
-            <a:schemeClr val="accent1"/>
-          </a:fillRef>
-          <a:effectRef idx="2">
-            <a:schemeClr val="accent1"/>
-          </a:effectRef>
-          <a:fontRef idx="minor">
-            <a:schemeClr val="lt1"/>
-          </a:fontRef>
-        </p:style>
-        <p:txBody>
-          <a:bodyPr rtlCol="0" anchor="ctr" wrap="square" lIns="228600" rIns="228600"/>
-          <a:lstStyle/>
-          <a:p>
-            <a:pPr algn="ctr">
-              <a:defRPr sz="1050" b="1">
-                <a:solidFill>
-                  <a:srgbClr val="980517"/>
-                </a:solidFill>
-                <a:latin typeface="Arial"/>
-              </a:defRPr>
-            </a:pPr>
-            <a:r>
-              <a:t>Pengambilan Keputusan Closed-Loop: </a:t>
-            </a:r>
-            <a:r>
-              <a:rPr sz="1050">
-                <a:solidFill>
-                  <a:srgbClr val="0F172A"/>
-                </a:solidFill>
-                <a:latin typeface="Calibri"/>
-              </a:rPr>
-              <a:t>Data analitik stok sisa dan tren ukuran dari Fase 4 secara otomatis menjadi input penetapan kuota anggaran dan purchase order ke pabrik pada Fase 1 semester berikutnya.</a:t>
             </a:r>
           </a:p>
         </p:txBody>
@@ -9083,7 +8699,7 @@
         <p:spPr>
           <a:xfrm>
             <a:off x="731520" y="1417320"/>
-            <a:ext cx="3429000" cy="4297680"/>
+            <a:ext cx="3429000" cy="4800600"/>
           </a:xfrm>
           <a:prstGeom prst="roundRect">
             <a:avLst/>
@@ -9218,7 +8834,7 @@
         <p:spPr>
           <a:xfrm>
             <a:off x="4370832" y="1417320"/>
-            <a:ext cx="7086600" cy="4297680"/>
+            <a:ext cx="7086600" cy="4800600"/>
           </a:xfrm>
           <a:prstGeom prst="roundRect">
             <a:avLst/>
@@ -9364,70 +8980,6 @@
             </a:pPr>
             <a:r>
               <a:t>➔  Toleransi Kesalahan: Resiliensi Operasional Tinggi</a:t>
-            </a:r>
-          </a:p>
-        </p:txBody>
-      </p:sp>
-      <p:sp>
-        <p:nvSpPr>
-          <p:cNvPr id="9" name="Rounded Rectangle 8"/>
-          <p:cNvSpPr/>
-          <p:nvPr/>
-        </p:nvSpPr>
-        <p:spPr>
-          <a:xfrm>
-            <a:off x="731520" y="5870448"/>
-            <a:ext cx="10728655" cy="658368"/>
-          </a:xfrm>
-          <a:prstGeom prst="roundRect">
-            <a:avLst/>
-          </a:prstGeom>
-          <a:solidFill>
-            <a:srgbClr val="FEF2F2"/>
-          </a:solidFill>
-          <a:ln w="19050">
-            <a:solidFill>
-              <a:srgbClr val="980517"/>
-            </a:solidFill>
-          </a:ln>
-        </p:spPr>
-        <p:style>
-          <a:lnRef idx="1">
-            <a:schemeClr val="accent1"/>
-          </a:lnRef>
-          <a:fillRef idx="3">
-            <a:schemeClr val="accent1"/>
-          </a:fillRef>
-          <a:effectRef idx="2">
-            <a:schemeClr val="accent1"/>
-          </a:effectRef>
-          <a:fontRef idx="minor">
-            <a:schemeClr val="lt1"/>
-          </a:fontRef>
-        </p:style>
-        <p:txBody>
-          <a:bodyPr rtlCol="0" anchor="ctr" wrap="square" lIns="228600" rIns="228600"/>
-          <a:lstStyle/>
-          <a:p>
-            <a:pPr algn="ctr">
-              <a:defRPr sz="1050" b="1">
-                <a:solidFill>
-                  <a:srgbClr val="980517"/>
-                </a:solidFill>
-                <a:latin typeface="Arial"/>
-              </a:defRPr>
-            </a:pPr>
-            <a:r>
-              <a:t>Resiliensi Operasional Tinggi: </a:t>
-            </a:r>
-            <a:r>
-              <a:rPr sz="1050">
-                <a:solidFill>
-                  <a:srgbClr val="0F172A"/>
-                </a:solidFill>
-                <a:latin typeface="Calibri"/>
-              </a:rPr>
-              <a:t>UniStock dirancang dengan pertimbangan toleransi kesalahan nyata (fault-tolerant), menjamin pembagian di posko kampus tetap berjalan lancar dalam kondisi darurat apa pun.</a:t>
             </a:r>
           </a:p>
         </p:txBody>
@@ -9661,7 +9213,7 @@
         <p:spPr>
           <a:xfrm>
             <a:off x="731520" y="1417320"/>
-            <a:ext cx="3429000" cy="4297680"/>
+            <a:ext cx="3429000" cy="4800600"/>
           </a:xfrm>
           <a:prstGeom prst="roundRect">
             <a:avLst/>
@@ -9796,7 +9348,7 @@
         <p:spPr>
           <a:xfrm>
             <a:off x="4370832" y="1417320"/>
-            <a:ext cx="3429000" cy="4297680"/>
+            <a:ext cx="3429000" cy="4800600"/>
           </a:xfrm>
           <a:prstGeom prst="roundRect">
             <a:avLst/>
@@ -9931,7 +9483,7 @@
         <p:spPr>
           <a:xfrm>
             <a:off x="8010144" y="1417320"/>
-            <a:ext cx="3429000" cy="4297680"/>
+            <a:ext cx="3429000" cy="4800600"/>
           </a:xfrm>
           <a:prstGeom prst="roundRect">
             <a:avLst/>
@@ -10053,70 +9605,6 @@
             </a:pPr>
             <a:r>
               <a:t>➔  Dampak: Audit Trail Keuangan Bebas Selisih</a:t>
-            </a:r>
-          </a:p>
-        </p:txBody>
-      </p:sp>
-      <p:sp>
-        <p:nvSpPr>
-          <p:cNvPr id="10" name="Rounded Rectangle 9"/>
-          <p:cNvSpPr/>
-          <p:nvPr/>
-        </p:nvSpPr>
-        <p:spPr>
-          <a:xfrm>
-            <a:off x="731520" y="5870448"/>
-            <a:ext cx="10728655" cy="658368"/>
-          </a:xfrm>
-          <a:prstGeom prst="roundRect">
-            <a:avLst/>
-          </a:prstGeom>
-          <a:solidFill>
-            <a:srgbClr val="FEF2F2"/>
-          </a:solidFill>
-          <a:ln w="19050">
-            <a:solidFill>
-              <a:srgbClr val="980517"/>
-            </a:solidFill>
-          </a:ln>
-        </p:spPr>
-        <p:style>
-          <a:lnRef idx="1">
-            <a:schemeClr val="accent1"/>
-          </a:lnRef>
-          <a:fillRef idx="3">
-            <a:schemeClr val="accent1"/>
-          </a:fillRef>
-          <a:effectRef idx="2">
-            <a:schemeClr val="accent1"/>
-          </a:effectRef>
-          <a:fontRef idx="minor">
-            <a:schemeClr val="lt1"/>
-          </a:fontRef>
-        </p:style>
-        <p:txBody>
-          <a:bodyPr rtlCol="0" anchor="ctr" wrap="square" lIns="228600" rIns="228600"/>
-          <a:lstStyle/>
-          <a:p>
-            <a:pPr algn="ctr">
-              <a:defRPr sz="1050" b="1">
-                <a:solidFill>
-                  <a:srgbClr val="980517"/>
-                </a:solidFill>
-                <a:latin typeface="Arial"/>
-              </a:defRPr>
-            </a:pPr>
-            <a:r>
-              <a:t>Kesimpulan Strategis Sistem Informasi: </a:t>
-            </a:r>
-            <a:r>
-              <a:rPr sz="1050">
-                <a:solidFill>
-                  <a:srgbClr val="0F172A"/>
-                </a:solidFill>
-                <a:latin typeface="Calibri"/>
-              </a:rPr>
-              <a:t>Sistem Informasi bukan sekadar alat pencatat administrasi, melainkan saraf penggerak rantai pasok yang mengunci fisik barang dengan kepatuhan finansial, serta mentransformasi tebakan manual menjadi keputusan bisnis berakurasi tinggi.</a:t>
             </a:r>
           </a:p>
         </p:txBody>

</xml_diff>

<commit_message>
fix: responsive auto-scaling for fullscreen view and sync slide 1 landing layout in pptx
</commit_message>
<xml_diff>
--- a/HorizonU_Uniform_UniStock_SCM_Presentasi_Technospark.pptx
+++ b/HorizonU_Uniform_UniStock_SCM_Presentasi_Technospark.pptx
@@ -4237,14 +4237,6 @@
 <file path=ppt/slides/slide1.xml><?xml version="1.0" encoding="utf-8"?>
 <p:sld xmlns:a="http://schemas.openxmlformats.org/drawingml/2006/main" xmlns:p="http://schemas.openxmlformats.org/presentationml/2006/main" xmlns:r="http://schemas.openxmlformats.org/officeDocument/2006/relationships">
   <p:cSld>
-    <p:bg>
-      <p:bgPr>
-        <a:solidFill>
-          <a:srgbClr val="FFFFFF"/>
-        </a:solidFill>
-        <a:effectLst/>
-      </p:bgPr>
-    </p:bg>
     <p:spTree>
       <p:nvGrpSpPr>
         <p:cNvPr id="1" name=""/>
@@ -4254,57 +4246,14 @@
       <p:grpSpPr/>
       <p:sp>
         <p:nvSpPr>
-          <p:cNvPr id="2" name="Rectangle 1"/>
-          <p:cNvSpPr/>
+          <p:cNvPr id="2" name="TextBox 1"/>
+          <p:cNvSpPr txBox="1"/>
           <p:nvPr/>
         </p:nvSpPr>
         <p:spPr>
           <a:xfrm>
-            <a:off x="731520" y="384048"/>
-            <a:ext cx="54864" cy="713232"/>
-          </a:xfrm>
-          <a:prstGeom prst="rect">
-            <a:avLst/>
-          </a:prstGeom>
-          <a:solidFill>
-            <a:srgbClr val="980517"/>
-          </a:solidFill>
-          <a:ln>
-            <a:noFill/>
-          </a:ln>
-        </p:spPr>
-        <p:style>
-          <a:lnRef idx="1">
-            <a:schemeClr val="accent1"/>
-          </a:lnRef>
-          <a:fillRef idx="3">
-            <a:schemeClr val="accent1"/>
-          </a:fillRef>
-          <a:effectRef idx="2">
-            <a:schemeClr val="accent1"/>
-          </a:effectRef>
-          <a:fontRef idx="minor">
-            <a:schemeClr val="lt1"/>
-          </a:fontRef>
-        </p:style>
-        <p:txBody>
-          <a:bodyPr rtlCol="0" anchor="ctr"/>
-          <a:lstStyle/>
-          <a:p>
-            <a:pPr algn="ctr"/>
-          </a:p>
-        </p:txBody>
-      </p:sp>
-      <p:sp>
-        <p:nvSpPr>
-          <p:cNvPr id="3" name="TextBox 2"/>
-          <p:cNvSpPr txBox="1"/>
-          <p:nvPr/>
-        </p:nvSpPr>
-        <p:spPr>
-          <a:xfrm>
-            <a:off x="868680" y="347472"/>
-            <a:ext cx="10515600" cy="219456"/>
+            <a:off x="731520" y="365760"/>
+            <a:ext cx="10728655" cy="411480"/>
           </a:xfrm>
           <a:prstGeom prst="rect">
             <a:avLst/>
@@ -4312,107 +4261,42 @@
           <a:noFill/>
         </p:spPr>
         <p:txBody>
-          <a:bodyPr wrap="square">
+          <a:bodyPr wrap="square" lIns="0" rIns="0" tIns="0" bIns="0">
             <a:spAutoFit/>
           </a:bodyPr>
           <a:lstStyle/>
           <a:p>
-            <a:pPr>
-              <a:defRPr sz="950" b="1">
+            <a:r>
+              <a:rPr sz="950" b="1">
+                <a:solidFill>
+                  <a:srgbClr val="64748B"/>
+                </a:solidFill>
+                <a:latin typeface="Calibri"/>
+              </a:rPr>
+              <a:t>DEPARTEMEN KEUANGAN • UNIVERSITAS HORIZON INDONESIA</a:t>
+            </a:r>
+            <a:r>
+              <a:rPr sz="950" b="1">
                 <a:solidFill>
                   <a:srgbClr val="980517"/>
                 </a:solidFill>
-                <a:latin typeface="Arial"/>
-              </a:defRPr>
-            </a:pPr>
-            <a:r>
-              <a:t>UNIVERSITAS HORIZON INDONESIA • DEPARTEMEN KEUANGAN</a:t>
-            </a:r>
-          </a:p>
-        </p:txBody>
-      </p:sp>
-      <p:sp>
-        <p:nvSpPr>
-          <p:cNvPr id="4" name="TextBox 3"/>
-          <p:cNvSpPr txBox="1"/>
+                <a:latin typeface="Calibri"/>
+              </a:rPr>
+              <a:t>                                                                                   TECHNOSPARK 2026 PITCH DECK</a:t>
+            </a:r>
+          </a:p>
+        </p:txBody>
+      </p:sp>
+      <p:sp>
+        <p:nvSpPr>
+          <p:cNvPr id="3" name="Rectangle 2"/>
+          <p:cNvSpPr/>
           <p:nvPr/>
         </p:nvSpPr>
         <p:spPr>
           <a:xfrm>
-            <a:off x="868680" y="548640"/>
-            <a:ext cx="10515600" cy="384048"/>
-          </a:xfrm>
-          <a:prstGeom prst="rect">
-            <a:avLst/>
-          </a:prstGeom>
-          <a:noFill/>
-        </p:spPr>
-        <p:txBody>
-          <a:bodyPr wrap="square">
-            <a:spAutoFit/>
-          </a:bodyPr>
-          <a:lstStyle/>
-          <a:p>
-            <a:pPr>
-              <a:defRPr sz="1900" b="1">
-                <a:solidFill>
-                  <a:srgbClr val="0F172A"/>
-                </a:solidFill>
-                <a:latin typeface="Arial"/>
-              </a:defRPr>
-            </a:pPr>
-            <a:r>
-              <a:t>HorizonU Uniform: Transformasi Rantai Pasok Seragam Mahasiswa</a:t>
-            </a:r>
-          </a:p>
-        </p:txBody>
-      </p:sp>
-      <p:sp>
-        <p:nvSpPr>
-          <p:cNvPr id="5" name="TextBox 4"/>
-          <p:cNvSpPr txBox="1"/>
-          <p:nvPr/>
-        </p:nvSpPr>
-        <p:spPr>
-          <a:xfrm>
-            <a:off x="868680" y="932688"/>
-            <a:ext cx="10515600" cy="256032"/>
-          </a:xfrm>
-          <a:prstGeom prst="rect">
-            <a:avLst/>
-          </a:prstGeom>
-          <a:noFill/>
-        </p:spPr>
-        <p:txBody>
-          <a:bodyPr wrap="square">
-            <a:spAutoFit/>
-          </a:bodyPr>
-          <a:lstStyle/>
-          <a:p>
-            <a:pPr>
-              <a:defRPr sz="1100">
-                <a:solidFill>
-                  <a:srgbClr val="475569"/>
-                </a:solidFill>
-                <a:latin typeface="Calibri"/>
-              </a:defRPr>
-            </a:pPr>
-            <a:r>
-              <a:t>Modernisasi Pengadaan, Tata Kelola Stok FIFO, dan Distribusi Berbasis Web Terintegrasi</a:t>
-            </a:r>
-          </a:p>
-        </p:txBody>
-      </p:sp>
-      <p:sp>
-        <p:nvSpPr>
-          <p:cNvPr id="6" name="Rectangle 5"/>
-          <p:cNvSpPr/>
-          <p:nvPr/>
-        </p:nvSpPr>
-        <p:spPr>
-          <a:xfrm>
-            <a:off x="731520" y="1243584"/>
-            <a:ext cx="10728655" cy="10972"/>
+            <a:off x="731520" y="804672"/>
+            <a:ext cx="10728655" cy="18288"/>
           </a:xfrm>
           <a:prstGeom prst="rect">
             <a:avLst/>
@@ -4421,7 +4305,9 @@
             <a:srgbClr val="E2E8F0"/>
           </a:solidFill>
           <a:ln>
-            <a:noFill/>
+            <a:solidFill>
+              <a:srgbClr val="E2E8F0"/>
+            </a:solidFill>
           </a:ln>
         </p:spPr>
         <p:style>
@@ -4448,14 +4334,94 @@
       </p:sp>
       <p:sp>
         <p:nvSpPr>
-          <p:cNvPr id="7" name="Rounded Rectangle 6"/>
+          <p:cNvPr id="4" name="TextBox 3"/>
+          <p:cNvSpPr txBox="1"/>
+          <p:nvPr/>
+        </p:nvSpPr>
+        <p:spPr>
+          <a:xfrm>
+            <a:off x="731520" y="1051560"/>
+            <a:ext cx="10728655" cy="2286000"/>
+          </a:xfrm>
+          <a:prstGeom prst="rect">
+            <a:avLst/>
+          </a:prstGeom>
+          <a:noFill/>
+        </p:spPr>
+        <p:txBody>
+          <a:bodyPr wrap="square" lIns="0" rIns="0" tIns="0" bIns="0">
+            <a:spAutoFit/>
+          </a:bodyPr>
+          <a:lstStyle/>
+          <a:p>
+            <a:pPr>
+              <a:spcAft>
+                <a:spcPts val="400"/>
+              </a:spcAft>
+              <a:defRPr sz="1100" b="1">
+                <a:solidFill>
+                  <a:srgbClr val="980517"/>
+                </a:solidFill>
+                <a:latin typeface="Arial"/>
+              </a:defRPr>
+            </a:pPr>
+            <a:r>
+              <a:t>SOLUSI RANTAI PASOK LOGISTIK KAMPUS TERINTEGRASI</a:t>
+            </a:r>
+          </a:p>
+          <a:p>
+            <a:pPr>
+              <a:spcAft>
+                <a:spcPts val="800"/>
+              </a:spcAft>
+            </a:pPr>
+            <a:r>
+              <a:rPr sz="3600" b="1">
+                <a:solidFill>
+                  <a:srgbClr val="0F172A"/>
+                </a:solidFill>
+                <a:latin typeface="Arial"/>
+              </a:rPr>
+              <a:t>HORIZONU </a:t>
+            </a:r>
+            <a:r>
+              <a:rPr sz="3600" b="1" u="sng">
+                <a:solidFill>
+                  <a:srgbClr val="980517"/>
+                </a:solidFill>
+                <a:latin typeface="Arial"/>
+              </a:rPr>
+              <a:t>UNIFORM</a:t>
+            </a:r>
+          </a:p>
+          <a:p>
+            <a:pPr>
+              <a:lnSpc>
+                <a:spcPct val="125000"/>
+              </a:lnSpc>
+              <a:defRPr sz="1200">
+                <a:solidFill>
+                  <a:srgbClr val="4B5563"/>
+                </a:solidFill>
+                <a:latin typeface="Calibri"/>
+              </a:defRPr>
+            </a:pPr>
+            <a:r>
+              <a:t>Transformasi digital operasional seragam mahasiswa: Menghubungkan Hulu (Vendor Pabrik), Gudang Kampus, dan Bagian Keuangan hingga Hilir (Mahasiswa) berbasis data presisi dan aturan inventaris FIFO.</a:t>
+            </a:r>
+          </a:p>
+        </p:txBody>
+      </p:sp>
+      <p:sp>
+        <p:nvSpPr>
+          <p:cNvPr id="5" name="Rounded Rectangle 4"/>
           <p:cNvSpPr/>
           <p:nvPr/>
         </p:nvSpPr>
         <p:spPr>
           <a:xfrm>
-            <a:off x="731520" y="1417320"/>
-            <a:ext cx="3429000" cy="4800600"/>
+            <a:off x="731520" y="3520440"/>
+            <a:ext cx="3429000" cy="2697480"/>
           </a:xfrm>
           <a:prstGeom prst="roundRect">
             <a:avLst/>
@@ -4496,7 +4462,7 @@
               </a:defRPr>
             </a:pPr>
             <a:r>
-              <a:t>PROFIL INSTITUSI &amp; OBJEK</a:t>
+              <a:t>OBJEK &amp; KOMODITAS</a:t>
             </a:r>
           </a:p>
           <a:p>
@@ -4512,7 +4478,7 @@
               </a:defRPr>
             </a:pPr>
             <a:r>
-              <a:t>Logistik Perlengkapan Kampus</a:t>
+              <a:t>Pengadaan Perlengkapan Kampus</a:t>
             </a:r>
           </a:p>
           <a:p>
@@ -4528,7 +4494,7 @@
               </a:defRPr>
             </a:pPr>
             <a:r>
-              <a:t>•  Departemen Keuangan mengelola siklus pengadaan, pencatatan keuangan, dan distribusi perlengkapan maba.</a:t>
+              <a:t>•  Pengadaan dan pembagian tahunan: Jas Almamater, Kemeja Putih, Celana/Rok, Sepatu Lab &amp; Dinas, serta Medical Kit.</a:t>
             </a:r>
           </a:p>
           <a:p>
@@ -4544,23 +4510,7 @@
               </a:defRPr>
             </a:pPr>
             <a:r>
-              <a:t>•  Komoditas: Jas Almamater, Kemeja Putih, Celana/Rok Bahan, Sepatu Lab &amp; Dinas, serta Medical Kit.</a:t>
-            </a:r>
-          </a:p>
-          <a:p>
-            <a:pPr>
-              <a:spcAft>
-                <a:spcPts val="300"/>
-              </a:spcAft>
-              <a:defRPr sz="1050">
-                <a:solidFill>
-                  <a:srgbClr val="0F172A"/>
-                </a:solidFill>
-                <a:latin typeface="Calibri"/>
-              </a:defRPr>
-            </a:pPr>
-            <a:r>
-              <a:t>•  Karakteristik: Penyaluran langsung ke ribuan mahasiswa baru tanpa perantara ritel komersial.</a:t>
+              <a:t>•  Penyaluran langsung ke ribuan mahasiswa baru tanpa perantara ritel komersial.</a:t>
             </a:r>
           </a:p>
           <a:p>
@@ -4576,21 +4526,21 @@
               </a:defRPr>
             </a:pPr>
             <a:r>
-              <a:t>➔  Model: Direct Closed-Loop Campus SCM</a:t>
-            </a:r>
-          </a:p>
-        </p:txBody>
-      </p:sp>
-      <p:sp>
-        <p:nvSpPr>
-          <p:cNvPr id="8" name="Rounded Rectangle 7"/>
+              <a:t>➔  Model: Closed-Loop Campus SCM</a:t>
+            </a:r>
+          </a:p>
+        </p:txBody>
+      </p:sp>
+      <p:sp>
+        <p:nvSpPr>
+          <p:cNvPr id="6" name="Rounded Rectangle 5"/>
           <p:cNvSpPr/>
           <p:nvPr/>
         </p:nvSpPr>
         <p:spPr>
           <a:xfrm>
-            <a:off x="4370832" y="1417320"/>
-            <a:ext cx="3429000" cy="4800600"/>
+            <a:off x="4370832" y="3520440"/>
+            <a:ext cx="3429000" cy="2697480"/>
           </a:xfrm>
           <a:prstGeom prst="roundRect">
             <a:avLst/>
@@ -4631,7 +4581,7 @@
               </a:defRPr>
             </a:pPr>
             <a:r>
-              <a:t>KENDALA OPERASIONAL UTAMA</a:t>
+              <a:t>TANTANGAN UTAMA</a:t>
             </a:r>
           </a:p>
           <a:p>
@@ -4663,7 +4613,7 @@
               </a:defRPr>
             </a:pPr>
             <a:r>
-              <a:t>•  Spreadsheet Excel Induk (~4.5 MB, 19 sheet) sering mengalami lag atau crash saat data membesar.</a:t>
+              <a:t>•  Spreadsheet Excel 4.5 MB crash saat ribuan maba mendaftar serentak.</a:t>
             </a:r>
           </a:p>
           <a:p>
@@ -4679,7 +4629,7 @@
               </a:defRPr>
             </a:pPr>
             <a:r>
-              <a:t>•  Antrean di posko kampus sangat lambat (15–20 menit per mahasiswa) akibat verifikasi berkas manual.</a:t>
+              <a:t>•  Antrean fisik posko 15–20 menit/orang akibat verifikasi berkas manual.</a:t>
             </a:r>
           </a:p>
           <a:p>
@@ -4695,7 +4645,7 @@
               </a:defRPr>
             </a:pPr>
             <a:r>
-              <a:t>•  Pemesanan seragam ke pabrik hanya estimasi historis tanpa survey ukuran mandiri, memicu dead-stock.</a:t>
+              <a:t>•  Tebakan order pabrik memicu penumpukan dead-stock ukuran ekstrem.</a:t>
             </a:r>
           </a:p>
           <a:p>
@@ -4711,21 +4661,21 @@
               </a:defRPr>
             </a:pPr>
             <a:r>
-              <a:t>➔  Dampak: Modal Mengendap &amp; Risiko Klaim Ganda</a:t>
-            </a:r>
-          </a:p>
-        </p:txBody>
-      </p:sp>
-      <p:sp>
-        <p:nvSpPr>
-          <p:cNvPr id="9" name="Rounded Rectangle 8"/>
+              <a:t>➔  Dampak: Modal Mengendap</a:t>
+            </a:r>
+          </a:p>
+        </p:txBody>
+      </p:sp>
+      <p:sp>
+        <p:nvSpPr>
+          <p:cNvPr id="7" name="Rounded Rectangle 6"/>
           <p:cNvSpPr/>
           <p:nvPr/>
         </p:nvSpPr>
         <p:spPr>
           <a:xfrm>
-            <a:off x="8010144" y="1417320"/>
-            <a:ext cx="3429000" cy="4800600"/>
+            <a:off x="8010144" y="3520440"/>
+            <a:ext cx="3429000" cy="2697480"/>
           </a:xfrm>
           <a:prstGeom prst="roundRect">
             <a:avLst/>
@@ -4766,7 +4716,7 @@
               </a:defRPr>
             </a:pPr>
             <a:r>
-              <a:t>TIM PENGEMBANG</a:t>
+              <a:t>NIRWANA TEAM</a:t>
             </a:r>
           </a:p>
           <a:p>
@@ -4782,7 +4732,7 @@
               </a:defRPr>
             </a:pPr>
             <a:r>
-              <a:t>Nirwana Development Team</a:t>
+              <a:t>Tim Pengembang Sistem</a:t>
             </a:r>
           </a:p>
           <a:p>
@@ -4798,7 +4748,7 @@
               </a:defRPr>
             </a:pPr>
             <a:r>
-              <a:t>•  Fhazar Raffiful Aqyla — Project Manager</a:t>
+              <a:t>•  Fhazar Raffiful Aqyla (Project Manager)</a:t>
             </a:r>
           </a:p>
           <a:p>
@@ -4814,7 +4764,7 @@
               </a:defRPr>
             </a:pPr>
             <a:r>
-              <a:t>•  Ferry Noer Hendriawan — Frontend Engineer</a:t>
+              <a:t>•  Ferry Noer Hendriawan (Frontend) • Hildan (Backend)</a:t>
             </a:r>
           </a:p>
           <a:p>
@@ -4830,55 +4780,7 @@
               </a:defRPr>
             </a:pPr>
             <a:r>
-              <a:t>•  Hildan Anugrah Tamadi Putra — Backend Engineer</a:t>
-            </a:r>
-          </a:p>
-          <a:p>
-            <a:pPr>
-              <a:spcAft>
-                <a:spcPts val="300"/>
-              </a:spcAft>
-              <a:defRPr sz="1050">
-                <a:solidFill>
-                  <a:srgbClr val="0F172A"/>
-                </a:solidFill>
-                <a:latin typeface="Calibri"/>
-              </a:defRPr>
-            </a:pPr>
-            <a:r>
-              <a:t>•  Fadel Rahmadhan — Quality Assurance</a:t>
-            </a:r>
-          </a:p>
-          <a:p>
-            <a:pPr>
-              <a:spcAft>
-                <a:spcPts val="300"/>
-              </a:spcAft>
-              <a:defRPr sz="1050">
-                <a:solidFill>
-                  <a:srgbClr val="0F172A"/>
-                </a:solidFill>
-                <a:latin typeface="Calibri"/>
-              </a:defRPr>
-            </a:pPr>
-            <a:r>
-              <a:t>•  Daffa Nazriel Zaidan — UI/UX Designer</a:t>
-            </a:r>
-          </a:p>
-          <a:p>
-            <a:pPr>
-              <a:spcAft>
-                <a:spcPts val="300"/>
-              </a:spcAft>
-              <a:defRPr sz="1050">
-                <a:solidFill>
-                  <a:srgbClr val="0F172A"/>
-                </a:solidFill>
-                <a:latin typeface="Calibri"/>
-              </a:defRPr>
-            </a:pPr>
-            <a:r>
-              <a:t>•  Acep Ugan Saputra — System Analyst</a:t>
+              <a:t>•  Fadel Rahmadhan (QA) • Daffa (UI/UX) • Acep (Analyst)</a:t>
             </a:r>
           </a:p>
           <a:p>
@@ -4894,7 +4796,7 @@
               </a:defRPr>
             </a:pPr>
             <a:r>
-              <a:t>➔  Tim Nirwana • Horizon University</a:t>
+              <a:t>➔  Horizon University</a:t>
             </a:r>
           </a:p>
         </p:txBody>
@@ -8907,15 +8809,7 @@
               </a:defRPr>
             </a:pPr>
             <a:r>
-              <a:t>•  RISIKO 1: Baterai HP Mahasiswa Mati / QR Rusak</a:t>
-            </a:r>
-            <a:br/>
-            <a:r>
-              <a:t>• Kendala: Mahasiswa tidak bisa menampilkan QR Code di layar ponsel.</a:t>
-            </a:r>
-            <a:br/>
-            <a:r>
-              <a:t>• Mitigasi UniStock: Bilah scanner staf posko dilengkapi fitur Fallback Search manual via NIM atau Nama yang langsung memanggil profil hak seketika.</a:t>
+              <a:t>•  RISIKO 1 (Baterai HP Mati / QR Rusak): Fallback Search manual via NIM atau Nama langsung memanggil profil hak seketika.</a:t>
             </a:r>
           </a:p>
           <a:p>
@@ -8931,15 +8825,7 @@
               </a:defRPr>
             </a:pPr>
             <a:r>
-              <a:t>•  RISIKO 2: Ukuran Rak Habis / Fitting Beda</a:t>
-            </a:r>
-            <a:br/>
-            <a:r>
-              <a:t>• Kendala: Ukuran fisik seragam di rak posko habis saat dicoba langsung.</a:t>
-            </a:r>
-            <a:br/>
-            <a:r>
-              <a:t>• Mitigasi UniStock: Fitur Partial Pickup memungkinkan staf menyerahkan barang yang tersedia (sisa hak tidak hangus &amp; dijadwal ulang) dan mencatat tukar ukuran di student_size_histories.</a:t>
+              <a:t>•  RISIKO 2 (Ukuran Rak Habis / Fitting Beda): Fitur Partial Pickup serahkan barang yang tersedia tanpa menghanguskan sisa hak.</a:t>
             </a:r>
           </a:p>
           <a:p>
@@ -8955,15 +8841,7 @@
               </a:defRPr>
             </a:pPr>
             <a:r>
-              <a:t>•  RISIKO 3: Jaringan Internet Kampus Lambat / Dobel Klik</a:t>
-            </a:r>
-            <a:br/>
-            <a:r>
-              <a:t>• Kendala: Sinyal wifi fluktuatif menyebabkan staf mengklik tombol konfirmasi berulang kali.</a:t>
-            </a:r>
-            <a:br/>
-            <a:r>
-              <a:t>• Mitigasi UniStock: Transaksi dilindungi Pessimistic Row Locking (lockForUpdate) dan proteksi idempotensi, menjamin nol pemotongan stok ganda.</a:t>
+              <a:t>•  RISIKO 3 (Jaringan Internet Kampus Lambat): Pessimistic Row Locking (lockForUpdate) dan idempotensi menjamin nol pemotongan ganda.</a:t>
             </a:r>
           </a:p>
           <a:p>

</xml_diff>

<commit_message>
feat: insert Our Team slide between slide 1 and 2 with Neo-Brutalist cards and photos
</commit_message>
<xml_diff>
--- a/HorizonU_Uniform_UniStock_SCM_Presentasi_Technospark.pptx
+++ b/HorizonU_Uniform_UniStock_SCM_Presentasi_Technospark.pptx
@@ -13,6 +13,7 @@
     <p:sldId id="261" r:id="rId13"/>
     <p:sldId id="262" r:id="rId14"/>
     <p:sldId id="263" r:id="rId15"/>
+    <p:sldId id="264" r:id="rId16"/>
   </p:sldIdLst>
   <p:sldSz cx="12191695" cy="6858000" type="screen4x3"/>
   <p:notesSz cx="6858000" cy="9144000"/>
@@ -596,39 +597,49 @@
           <a:lstStyle/>
           <a:p>
             <a:r>
-              <a:t>NASKAH BACA PRESENTER SLIDE 2 (Target: 01:15 Menit):</a:t>
-            </a:r>
-          </a:p>
-          <a:p>
-            <a:r>
-              <a:t>"Masuk ke Slide 2 mengenai Struktur Rantai Pasok. Rantai pasok HorizonU Uniform menghubungkan empat entitas stakeholder secara closed-loop:</a:t>
+              <a:t>NASKAH BACA PRESENTER SLIDE 2 (Target: 00:45 Menit):</a:t>
+            </a:r>
+          </a:p>
+          <a:p>
+            <a:r>
+              <a:t>"Pada Slide 2, izinkan kami memperkenalkan 6 anggota Tim Nirwana yang memiliki spesialisasi peran masing-masing dalam membangun UniStock:</a:t>
             </a:r>
           </a:p>
           <a:p/>
           <a:p>
             <a:r>
-              <a:t>Pertama, di sisi Hulu (Supplier), terdapat Pabrik Garmen dan Sepatu yang memproduksi barang sesuai Purchase Order agregat kampus.</a:t>
-            </a:r>
-          </a:p>
-          <a:p>
-            <a:r>
-              <a:t>Kedua, Gudang Logistik Kampus, yang bertindak sebagai distributor internal untuk memeriksa fisik, mencatat penerimaan batch, dan memberi nomor urut FIFO.</a:t>
-            </a:r>
-          </a:p>
-          <a:p>
-            <a:r>
-              <a:t>Ketiga, Departemen Keuangan dan Staf Posko, yang bertugas memvalidasi status kelayakan pelunasan biaya serta melayani serah terima barang di loket.</a:t>
-            </a:r>
-          </a:p>
-          <a:p>
-            <a:r>
-              <a:t>Dan keempat, di sisi Hilir (Customer), adalah Mahasiswa yang memiliki kuota hak barang sesuai prodinya.</a:t>
+              <a:t>1. Fhazar Raffiful Aqyla sebagai Project Manager, memimpin perumusan roadmap produk dan keselarasan strategi rantai pasok.</a:t>
+            </a:r>
+          </a:p>
+          <a:p>
+            <a:r>
+              <a:t>2. Ferry Noer Hendriawan sebagai Frontend Developer, merancang tampilan antarmuka interaktif dan modul scanner posko.</a:t>
+            </a:r>
+          </a:p>
+          <a:p>
+            <a:r>
+              <a:t>3. Hildan Anugrah Tamadi Putra sebagai Backend Developer, membangun logic Laravel 12, algoritma FIFO, dan concurrency lock.</a:t>
+            </a:r>
+          </a:p>
+          <a:p>
+            <a:r>
+              <a:t>4. Fadel Rahmadhan sebagai Quality Assurance, menguji ketahanan sistem terhadap skenario double-claim dan stress test transaksi.</a:t>
+            </a:r>
+          </a:p>
+          <a:p>
+            <a:r>
+              <a:t>5. Daffa Nazriel Zaidan sebagai UI/UX Designer, menyusun prototipe sistem desain Neo-Brutalism yang ergonomis bagi mahasiswa.</a:t>
+            </a:r>
+          </a:p>
+          <a:p>
+            <a:r>
+              <a:t>6. Acep Ugan Saputra sebagai System Analyst, merancang pemodelan proses bisnis BPMN dan normalisasi basis data relasional.</a:t>
             </a:r>
           </a:p>
           <a:p/>
           <a:p>
             <a:r>
-              <a:t>Prinsip dasar yang kami tanamkan adalah: 'Data Mengunci Fisik'. Artinya, seragam fisik di meja loket pantang keluar sebelum sistem memindai QR Code mahasiswa dan memastikan hak kuota serta status pembayarannya sah." </a:t>
+              <a:t>Dengan sinergi lintas peran inilah kami mentransformasi sistem rantai pasok seragam kampus secara utuh." </a:t>
             </a:r>
           </a:p>
         </p:txBody>
@@ -698,36 +709,39 @@
           <a:lstStyle/>
           <a:p>
             <a:r>
-              <a:t>NASKAH BACA PRESENTER SLIDE 3 (Target: 01:30 Menit):</a:t>
-            </a:r>
-          </a:p>
-          <a:p>
-            <a:r>
-              <a:t>"Pada Slide 3, kami membedah empat akar masalah utama melalui tabel hubungan Masalah, Penyebab, dan Dampak sistemik:</a:t>
+              <a:t>NASKAH BACA PRESENTER SLIDE 3 (Target: 01:15 Menit):</a:t>
+            </a:r>
+          </a:p>
+          <a:p>
+            <a:r>
+              <a:t>"Masuk ke Slide 3 mengenai Struktur Rantai Pasok. Rantai pasok HorizonU Uniform menghubungkan empat entitas stakeholder secara closed-loop:</a:t>
             </a:r>
           </a:p>
           <a:p/>
           <a:p>
             <a:r>
-              <a:t>Masalah Pertama: Ketidakcocokan ukuran dan penumpukan dead-stock. Penyebabnya adalah pemesanan ke vendor hanya berbasis estimasi historis tanpa survey ukuran mandiri mahasiswa. Dampaknya, ukuran favorit habis seketika, ukuran ekstrem menumpuk bertahun-tahun, dan dana kampus tertahan.</a:t>
+              <a:t>Pertama, di sisi Hulu (Supplier), terdapat Pabrik Garmen dan Sepatu yang memproduksi barang sesuai Purchase Order agregat kampus.</a:t>
+            </a:r>
+          </a:p>
+          <a:p>
+            <a:r>
+              <a:t>Kedua, Gudang Logistik Kampus, yang bertindak sebagai distributor internal untuk memeriksa fisik, mencatat penerimaan batch, dan memberi nomor urut FIFO.</a:t>
+            </a:r>
+          </a:p>
+          <a:p>
+            <a:r>
+              <a:t>Ketiga, Departemen Keuangan dan Staf Posko, yang bertugas memvalidasi status kelayakan pelunasan biaya serta melayani serah terima barang di loket.</a:t>
+            </a:r>
+          </a:p>
+          <a:p>
+            <a:r>
+              <a:t>Dan keempat, di sisi Hilir (Customer), adalah Mahasiswa yang memiliki kuota hak barang sesuai prodinya.</a:t>
             </a:r>
           </a:p>
           <a:p/>
           <a:p>
             <a:r>
-              <a:t>Masalah Kedua: Ketergantungan pada lembar kerja Excel raksasa yang sering crash saat mengolah ribuan data maba, ditambah broadcast jadwal dikirim manual per surel. Dampaknya waktu kerja staf terbuang berminggu-minggu dan informasi jadwal terlambat diterima mahasiswa.</a:t>
-            </a:r>
-          </a:p>
-          <a:p/>
-          <a:p>
-            <a:r>
-              <a:t>Masalah Ketiga: Kemacetan parah di loket posko karena verifikasi lunas dan pencatatan dilakukan manual di atas kertas. Dampaknya antrean meliuk ratusan meter dengan waktu layan hingga 15-20 menit per orang, serta rawan klaim ganda.</a:t>
-            </a:r>
-          </a:p>
-          <a:p/>
-          <a:p>
-            <a:r>
-              <a:t>Masalah Keempat: Penyusutan stok tanpa jejak audit karena pencampuran barang antar-pembelian tanpa kaidah FIFO, sehingga nilai HPP dan laba kotor tidak dapat dihitung akurat." </a:t>
+              <a:t>Prinsip dasar yang kami tanamkan adalah: 'Data Mengunci Fisik'. Artinya, seragam fisik di meja loket pantang keluar sebelum sistem memindai QR Code mahasiswa dan memastikan hak kuota serta status pembayarannya sah." </a:t>
             </a:r>
           </a:p>
         </p:txBody>
@@ -797,39 +811,36 @@
           <a:lstStyle/>
           <a:p>
             <a:r>
-              <a:t>NASKAH BACA PRESENTER SLIDE 4 (Target: 01:15 Menit):</a:t>
-            </a:r>
-          </a:p>
-          <a:p>
-            <a:r>
-              <a:t>"Selanjutnya pada Slide 4, kami memetakan Analisis Aliran Informasi pada kondisi As-Is dan titik-titik kemacetannya:</a:t>
+              <a:t>NASKAH BACA PRESENTER SLIDE 4 (Target: 01:30 Menit):</a:t>
+            </a:r>
+          </a:p>
+          <a:p>
+            <a:r>
+              <a:t>"Pada Slide 4, kami membedah empat akar masalah utama melalui tabel hubungan Masalah, Penyebab, dan Dampak sistemik:</a:t>
             </a:r>
           </a:p>
           <a:p/>
           <a:p>
             <a:r>
-              <a:t>Pada Aliran 1 dari Mahasiswa ke Kampus, data ukuran diisi via formulir acak tanpa validasi SKU baku, sehingga rekapitulasi data terlambat dan penuh duplikasi.</a:t>
-            </a:r>
-          </a:p>
-          <a:p>
-            <a:r>
-              <a:t>Pada Aliran 2 dari Keuangan ke Posko, data pelunasan terisolasi di laptop staf finance. Saat mahasiswa baru saja melunasi di bank pada hari-H, staf posko tidak mengetahuinya karena data belum tersinkronisasi.</a:t>
-            </a:r>
-          </a:p>
-          <a:p>
-            <a:r>
-              <a:t>Pada Aliran 3 di meja posko, pencatatan serah terima memakai kertas checklist yang baru direkap malam hari, memicu celah barang hilang dan manipulasi.</a:t>
-            </a:r>
-          </a:p>
-          <a:p>
-            <a:r>
-              <a:t>Dan pada Aliran 4 ke pabrik vendor, order produksi dibuat berdasar tebakan kasar sehingga waktu tunggu revisi ukuran memakan waktu berbulan-bulan.</a:t>
+              <a:t>Masalah Pertama: Ketidakcocokan ukuran dan penumpukan dead-stock. Penyebabnya adalah pemesanan ke vendor hanya berbasis estimasi historis tanpa survey ukuran mandiri mahasiswa. Dampaknya, ukuran favorit habis seketika, ukuran ekstrem menumpuk bertahun-tahun, dan dana kampus tertahan.</a:t>
             </a:r>
           </a:p>
           <a:p/>
           <a:p>
             <a:r>
-              <a:t>Kesimpulannya, terjadi silo data dan keterlambatan informasi akut yang melumpuhkan efisiensi." </a:t>
+              <a:t>Masalah Kedua: Ketergantungan pada lembar kerja Excel raksasa yang sering crash saat mengolah ribuan data maba, ditambah broadcast jadwal dikirim manual per surel. Dampaknya waktu kerja staf terbuang berminggu-minggu dan informasi jadwal terlambat diterima mahasiswa.</a:t>
+            </a:r>
+          </a:p>
+          <a:p/>
+          <a:p>
+            <a:r>
+              <a:t>Masalah Ketiga: Kemacetan parah di loket posko karena verifikasi lunas dan pencatatan dilakukan manual di atas kertas. Dampaknya antrean meliuk ratusan meter dengan waktu layan hingga 15-20 menit per orang, serta rawan klaim ganda.</a:t>
+            </a:r>
+          </a:p>
+          <a:p/>
+          <a:p>
+            <a:r>
+              <a:t>Masalah Keempat: Penyusutan stok tanpa jejak audit karena pencampuran barang antar-pembelian tanpa kaidah FIFO, sehingga nilai HPP dan laba kotor tidak dapat dihitung akurat." </a:t>
             </a:r>
           </a:p>
         </p:txBody>
@@ -899,36 +910,39 @@
           <a:lstStyle/>
           <a:p>
             <a:r>
-              <a:t>NASKAH BACA PRESENTER SLIDE 5 (Target: 01:30 Menit):</a:t>
-            </a:r>
-          </a:p>
-          <a:p>
-            <a:r>
-              <a:t>"Untuk mengatasi persoalan tersebut, pada Slide 5 kami merekomendasikan empat subsistem terpadu di dalam arsitektur HorizonU Uniform (UniStock):</a:t>
+              <a:t>NASKAH BACA PRESENTER SLIDE 5 (Target: 01:15 Menit):</a:t>
+            </a:r>
+          </a:p>
+          <a:p>
+            <a:r>
+              <a:t>"Selanjutnya pada Slide 5, kami memetakan Analisis Aliran Informasi pada kondisi As-Is dan titik-titik kemacetannya:</a:t>
             </a:r>
           </a:p>
           <a:p/>
           <a:p>
             <a:r>
-              <a:t>1. ERP Master &amp; Entitlement Engine: Berfungsi menggantikan Excel dengan basis data relasional MySQL InnoDB terstruktur, mengelola kuota hak per program studi, dan mengunci integritas transaksi. Manfaatnya: 100% bebas kendala Excel rusak.</a:t>
+              <a:t>Pada Aliran 1 dari Mahasiswa ke Kampus, data ukuran diisi via formulir acak tanpa validasi SKU baku, sehingga rekapitulasi data terlambat dan penuh duplikasi.</a:t>
+            </a:r>
+          </a:p>
+          <a:p>
+            <a:r>
+              <a:t>Pada Aliran 2 dari Keuangan ke Posko, data pelunasan terisolasi di laptop staf finance. Saat mahasiswa baru saja melunasi di bank pada hari-H, staf posko tidak mengetahuinya karena data belum tersinkronisasi.</a:t>
+            </a:r>
+          </a:p>
+          <a:p>
+            <a:r>
+              <a:t>Pada Aliran 3 di meja posko, pencatatan serah terima memakai kertas checklist yang baru direkap malam hari, memicu celah barang hilang dan manipulasi.</a:t>
+            </a:r>
+          </a:p>
+          <a:p>
+            <a:r>
+              <a:t>Dan pada Aliran 4 ke pabrik vendor, order produksi dibuat berdasar tebakan kasar sehingga waktu tunggu revisi ukuran memakan waktu berbulan-bulan.</a:t>
             </a:r>
           </a:p>
           <a:p/>
           <a:p>
             <a:r>
-              <a:t>2. SCM Demand Planning Portal: Membuka portal mandiri bagi mahasiswa untuk mengisi ukuran baju dan sepatu sebelum produksi, serta menghitung kalkulasi demand vs shortage secara otomatis. Manfaatnya: Zero dead-stock dan pengadaan pabrik tepat sasaran.</a:t>
-            </a:r>
-          </a:p>
-          <a:p/>
-          <a:p>
-            <a:r>
-              <a:t>3. POS QR Verification Engine: Menghasilkan QR Code instan berbasis NIM dan mengeksekusi 6-Lapis Validasi otomatis melalui kamera webcam posko. Manfaatnya: Memangkas waktu layan menjadi di bawah 30 detik dan nol risiko klaim ganda.</a:t>
-            </a:r>
-          </a:p>
-          <a:p/>
-          <a:p>
-            <a:r>
-              <a:t>4. WMS &amp; FIFO Inventory Costing Engine: Mengatur pemotongan mutasi dari batch pembelian tertua secara FIFO, rekonsiliasi stock opname fisik, serta perhitungan valuasi HPP dan margin laba secara presisi." </a:t>
+              <a:t>Kesimpulannya, terjadi silo data dan keterlambatan informasi akut yang melumpuhkan efisiensi." </a:t>
             </a:r>
           </a:p>
         </p:txBody>
@@ -998,42 +1012,36 @@
           <a:lstStyle/>
           <a:p>
             <a:r>
-              <a:t>NASKAH BACA PRESENTER SLIDE 6 (Target: 01:25 Menit):</a:t>
-            </a:r>
-          </a:p>
-          <a:p>
-            <a:r>
-              <a:t>"Pada Slide 6, kami tampilkan Desain Arsitektur Solusi yang bekerja dalam 4 Fase Tertutup (Closed-Loop Engine):</a:t>
+              <a:t>NASKAH BACA PRESENTER SLIDE 6 (Target: 01:30 Menit):</a:t>
+            </a:r>
+          </a:p>
+          <a:p>
+            <a:r>
+              <a:t>"Untuk mengatasi persoalan tersebut, pada Slide 6 kami merekomendasikan empat subsistem terpadu di dalam arsitektur HorizonU Uniform (UniStock):</a:t>
             </a:r>
           </a:p>
           <a:p/>
           <a:p>
             <a:r>
-              <a:t>Fase 1 (Inbound): Saat barang dari pabrik tiba, staf gudang mencatatnya pada modul StockReceive, menetapkan batch FIFO, dan mencatat unit HPP pembelian.</a:t>
+              <a:t>1. ERP Master &amp; Entitlement Engine: Berfungsi menggantikan Excel dengan basis data relasional MySQL InnoDB terstruktur, mengelola kuota hak per program studi, dan mengunci integritas transaksi. Manfaatnya: 100% bebas kendala Excel rusak.</a:t>
             </a:r>
           </a:p>
           <a:p/>
           <a:p>
             <a:r>
-              <a:t>Fase 2 (Planning): Departemen Keuangan mengaktifkan status lunas di Eligibility Record, mahasiswa mengisi profil ukuran di portal, dan sistem mengalokasikan paket hak barang.</a:t>
+              <a:t>2. SCM Demand Planning Portal: Membuka portal mandiri bagi mahasiswa untuk mengisi ukuran baju dan sepatu sebelum produksi, serta menghitung kalkulasi demand vs shortage secara otomatis. Manfaatnya: Zero dead-stock dan pengadaan pabrik tepat sasaran.</a:t>
             </a:r>
           </a:p>
           <a:p/>
           <a:p>
             <a:r>
-              <a:t>Fase 3 (Outbound): Di posko hari-H, staf memindai QR Code mahasiswa. Sistem mengeksekusi 6-lapis validasi menggunakan teknik pessimistic locking, memotong stok batch tertua, dan menyerahkan seragam.</a:t>
+              <a:t>3. POS QR Verification Engine: Menghasilkan QR Code instan berbasis NIM dan mengeksekusi 6-Lapis Validasi otomatis melalui kamera webcam posko. Manfaatnya: Memangkas waktu layan menjadi di bawah 30 detik dan nol risiko klaim ganda.</a:t>
             </a:r>
           </a:p>
           <a:p/>
           <a:p>
             <a:r>
-              <a:t>Fase 4 (Audit &amp; Control): Stock opname fisik berkala menghitung selisih varians, dan sistem menerbitkan laporan Gross Profit Margin.</a:t>
-            </a:r>
-          </a:p>
-          <a:p/>
-          <a:p>
-            <a:r>
-              <a:t>Data sisa stok dan tren ukuran dari Fase 4 ini secara otomatis menjadi acuan belanja pengadaan Fase 1 pada semester berikutnya, menutup siklus rantai pasok secara sempurna." </a:t>
+              <a:t>4. WMS &amp; FIFO Inventory Costing Engine: Mengatur pemotongan mutasi dari batch pembelian tertua secara FIFO, rekonsiliasi stock opname fisik, serta perhitungan valuasi HPP dan margin laba secara presisi." </a:t>
             </a:r>
           </a:p>
         </p:txBody>
@@ -1103,39 +1111,42 @@
           <a:lstStyle/>
           <a:p>
             <a:r>
-              <a:t>NASKAH BACA PRESENTER SLIDE 7 (Target: 01:15 Menit):</a:t>
-            </a:r>
-          </a:p>
-          <a:p>
-            <a:r>
-              <a:t>"Masuk ke Slide 7 mengenai Prioritas Implementasi dan Mitigasi Risiko Lapangan.</a:t>
+              <a:t>NASKAH BACA PRESENTER SLIDE 7 (Target: 01:25 Menit):</a:t>
+            </a:r>
+          </a:p>
+          <a:p>
+            <a:r>
+              <a:t>"Pada Slide 7, kami tampilkan Desain Arsitektur Solusi yang bekerja dalam 4 Fase Tertutup (Closed-Loop Engine):</a:t>
             </a:r>
           </a:p>
           <a:p/>
           <a:p>
             <a:r>
-              <a:t>Kami membagi tahapan implementasi menjadi 3 prioritas: Prioritas 1 adalah standarisasi master data dan SKU; Prioritas 2 adalah sinkronisasi status keuangan dan pembukaan portal ukuran; dan Prioritas 3 adalah pelatihan staf loket serta simulasi antrean posko.</a:t>
+              <a:t>Fase 1 (Inbound): Saat barang dari pabrik tiba, staf gudang mencatatnya pada modul StockReceive, menetapkan batch FIFO, dan mencatat unit HPP pembelian.</a:t>
             </a:r>
           </a:p>
           <a:p/>
           <a:p>
             <a:r>
-              <a:t>Kami juga telah merancang solusi atas 3 risiko darurat nyata di lapangan:</a:t>
-            </a:r>
-          </a:p>
-          <a:p>
-            <a:r>
-              <a:t>Pertama, jika baterai HP mahasiswa mati atau tidak membawa QR, staf posko dapat menggunakan fitur fallback search manual via NIM.</a:t>
-            </a:r>
-          </a:p>
-          <a:p>
-            <a:r>
-              <a:t>Kedua, jika stok ukuran di rak habis saat fitting, sistem mendukung fitur Partial Pickup di mana barang yang ada diserahkan tanpa menghanguskan sisa hak mahasiswa.</a:t>
-            </a:r>
-          </a:p>
-          <a:p>
-            <a:r>
-              <a:t>Ketiga, jika koneksi internet kampus fluktuatif, database diproteksi oleh pessimistic row locking agar tidak terjadi pengurangan stok ganda." </a:t>
+              <a:t>Fase 2 (Planning): Departemen Keuangan mengaktifkan status lunas di Eligibility Record, mahasiswa mengisi profil ukuran di portal, dan sistem mengalokasikan paket hak barang.</a:t>
+            </a:r>
+          </a:p>
+          <a:p/>
+          <a:p>
+            <a:r>
+              <a:t>Fase 3 (Outbound): Di posko hari-H, staf memindai QR Code mahasiswa. Sistem mengeksekusi 6-lapis validasi menggunakan teknik pessimistic locking, memotong stok batch tertua, dan menyerahkan seragam.</a:t>
+            </a:r>
+          </a:p>
+          <a:p/>
+          <a:p>
+            <a:r>
+              <a:t>Fase 4 (Audit &amp; Control): Stock opname fisik berkala menghitung selisih varians, dan sistem menerbitkan laporan Gross Profit Margin.</a:t>
+            </a:r>
+          </a:p>
+          <a:p/>
+          <a:p>
+            <a:r>
+              <a:t>Data sisa stok dan tren ukuran dari Fase 4 ini secara otomatis menjadi acuan belanja pengadaan Fase 1 pada semester berikutnya, menutup siklus rantai pasok secara sempurna." </a:t>
             </a:r>
           </a:p>
         </p:txBody>
@@ -1205,12 +1216,114 @@
           <a:lstStyle/>
           <a:p>
             <a:r>
-              <a:t>NASKAH BACA PRESENTER SLIDE 8 (Target: 00:55 Menit):</a:t>
-            </a:r>
-          </a:p>
-          <a:p>
-            <a:r>
-              <a:t>"Sebagai penutup pada Slide 8, implementasi HorizonU Uniform menghadirkan 3 manfaat nyata dan terukur:</a:t>
+              <a:t>NASKAH BACA PRESENTER SLIDE 8 (Target: 01:15 Menit):</a:t>
+            </a:r>
+          </a:p>
+          <a:p>
+            <a:r>
+              <a:t>"Masuk ke Slide 8 mengenai Prioritas Implementasi dan Mitigasi Risiko Lapangan.</a:t>
+            </a:r>
+          </a:p>
+          <a:p/>
+          <a:p>
+            <a:r>
+              <a:t>Kami membagi tahapan implementasi menjadi 3 prioritas: Prioritas 1 adalah standarisasi master data dan SKU; Prioritas 2 adalah sinkronisasi status keuangan dan pembukaan portal ukuran; dan Prioritas 3 adalah pelatihan staf loket serta simulasi antrean posko.</a:t>
+            </a:r>
+          </a:p>
+          <a:p/>
+          <a:p>
+            <a:r>
+              <a:t>Kami juga telah merancang solusi atas 3 risiko darurat nyata di lapangan:</a:t>
+            </a:r>
+          </a:p>
+          <a:p>
+            <a:r>
+              <a:t>Pertama, jika baterai HP mahasiswa mati atau tidak membawa QR, staf posko dapat menggunakan fitur fallback search manual via NIM.</a:t>
+            </a:r>
+          </a:p>
+          <a:p>
+            <a:r>
+              <a:t>Kedua, jika stok ukuran di rak habis saat fitting, sistem mendukung fitur Partial Pickup di mana barang yang ada diserahkan tanpa menghanguskan sisa hak mahasiswa.</a:t>
+            </a:r>
+          </a:p>
+          <a:p>
+            <a:r>
+              <a:t>Ketiga, jika koneksi internet kampus fluktuatif, database diproteksi oleh pessimistic row locking agar tidak terjadi pengurangan stok ganda." </a:t>
+            </a:r>
+          </a:p>
+        </p:txBody>
+      </p:sp>
+      <p:sp>
+        <p:nvSpPr>
+          <p:cNvPr id="4" name="Slide Number Placeholder 3"/>
+          <p:cNvSpPr>
+            <a:spLocks noGrp="1"/>
+          </p:cNvSpPr>
+          <p:nvPr>
+            <p:ph type="sldNum" idx="5" sz="quarter"/>
+          </p:nvPr>
+        </p:nvSpPr>
+        <p:spPr/>
+      </p:sp>
+    </p:spTree>
+  </p:cSld>
+  <p:clrMapOvr>
+    <a:masterClrMapping/>
+  </p:clrMapOvr>
+</p:notes>
+</file>
+
+<file path=ppt/notesSlides/notesSlide9.xml><?xml version="1.0" encoding="utf-8"?>
+<p:notes xmlns:a="http://schemas.openxmlformats.org/drawingml/2006/main" xmlns:p="http://schemas.openxmlformats.org/presentationml/2006/main" xmlns:r="http://schemas.openxmlformats.org/officeDocument/2006/relationships">
+  <p:cSld>
+    <p:spTree>
+      <p:nvGrpSpPr>
+        <p:cNvPr id="1" name=""/>
+        <p:cNvGrpSpPr/>
+        <p:nvPr/>
+      </p:nvGrpSpPr>
+      <p:grpSpPr>
+        <a:xfrm>
+          <a:off x="0" y="0"/>
+          <a:ext cx="0" cy="0"/>
+          <a:chOff x="0" y="0"/>
+          <a:chExt cx="0" cy="0"/>
+        </a:xfrm>
+      </p:grpSpPr>
+      <p:sp>
+        <p:nvSpPr>
+          <p:cNvPr id="2" name="Slide Image Placeholder 1"/>
+          <p:cNvSpPr>
+            <a:spLocks noGrp="1"/>
+          </p:cNvSpPr>
+          <p:nvPr>
+            <p:ph type="sldImg" idx="2"/>
+          </p:nvPr>
+        </p:nvSpPr>
+        <p:spPr/>
+      </p:sp>
+      <p:sp>
+        <p:nvSpPr>
+          <p:cNvPr id="3" name="Notes Placeholder 2"/>
+          <p:cNvSpPr>
+            <a:spLocks noGrp="1"/>
+          </p:cNvSpPr>
+          <p:nvPr>
+            <p:ph type="body" idx="3" sz="quarter"/>
+          </p:nvPr>
+        </p:nvSpPr>
+        <p:spPr/>
+        <p:txBody>
+          <a:bodyPr/>
+          <a:lstStyle/>
+          <a:p>
+            <a:r>
+              <a:t>NASKAH BACA PRESENTER SLIDE 9 (Target: 00:55 Menit):</a:t>
+            </a:r>
+          </a:p>
+          <a:p>
+            <a:r>
+              <a:t>"Sebagai penutup pada Slide 9, implementasi HorizonU Uniform menghadirkan 3 manfaat nyata dan terukur:</a:t>
             </a:r>
           </a:p>
           <a:p/>
@@ -4901,6 +5014,1282 @@
               </a:defRPr>
             </a:pPr>
             <a:r>
+              <a:t>PROFIL TIM PENGEMBANG</a:t>
+            </a:r>
+          </a:p>
+        </p:txBody>
+      </p:sp>
+      <p:sp>
+        <p:nvSpPr>
+          <p:cNvPr id="4" name="TextBox 3"/>
+          <p:cNvSpPr txBox="1"/>
+          <p:nvPr/>
+        </p:nvSpPr>
+        <p:spPr>
+          <a:xfrm>
+            <a:off x="868680" y="548640"/>
+            <a:ext cx="10515600" cy="384048"/>
+          </a:xfrm>
+          <a:prstGeom prst="rect">
+            <a:avLst/>
+          </a:prstGeom>
+          <a:noFill/>
+        </p:spPr>
+        <p:txBody>
+          <a:bodyPr wrap="square">
+            <a:spAutoFit/>
+          </a:bodyPr>
+          <a:lstStyle/>
+          <a:p>
+            <a:pPr>
+              <a:defRPr sz="1900" b="1">
+                <a:solidFill>
+                  <a:srgbClr val="0F172A"/>
+                </a:solidFill>
+                <a:latin typeface="Arial"/>
+              </a:defRPr>
+            </a:pPr>
+            <a:r>
+              <a:t>Our Team • Nirwana Development Team</a:t>
+            </a:r>
+          </a:p>
+        </p:txBody>
+      </p:sp>
+      <p:sp>
+        <p:nvSpPr>
+          <p:cNvPr id="5" name="TextBox 4"/>
+          <p:cNvSpPr txBox="1"/>
+          <p:nvPr/>
+        </p:nvSpPr>
+        <p:spPr>
+          <a:xfrm>
+            <a:off x="868680" y="932688"/>
+            <a:ext cx="10515600" cy="256032"/>
+          </a:xfrm>
+          <a:prstGeom prst="rect">
+            <a:avLst/>
+          </a:prstGeom>
+          <a:noFill/>
+        </p:spPr>
+        <p:txBody>
+          <a:bodyPr wrap="square">
+            <a:spAutoFit/>
+          </a:bodyPr>
+          <a:lstStyle/>
+          <a:p>
+            <a:pPr>
+              <a:defRPr sz="1100">
+                <a:solidFill>
+                  <a:srgbClr val="475569"/>
+                </a:solidFill>
+                <a:latin typeface="Calibri"/>
+              </a:defRPr>
+            </a:pPr>
+            <a:r>
+              <a:t>Kolaborasi lintas disiplin dalam perancangan arsitektur, rekayasa kode, dan tata kelola platform UniStock</a:t>
+            </a:r>
+          </a:p>
+        </p:txBody>
+      </p:sp>
+      <p:sp>
+        <p:nvSpPr>
+          <p:cNvPr id="6" name="Rectangle 5"/>
+          <p:cNvSpPr/>
+          <p:nvPr/>
+        </p:nvSpPr>
+        <p:spPr>
+          <a:xfrm>
+            <a:off x="731520" y="1243584"/>
+            <a:ext cx="10728655" cy="10972"/>
+          </a:xfrm>
+          <a:prstGeom prst="rect">
+            <a:avLst/>
+          </a:prstGeom>
+          <a:solidFill>
+            <a:srgbClr val="E2E8F0"/>
+          </a:solidFill>
+          <a:ln>
+            <a:noFill/>
+          </a:ln>
+        </p:spPr>
+        <p:style>
+          <a:lnRef idx="1">
+            <a:schemeClr val="accent1"/>
+          </a:lnRef>
+          <a:fillRef idx="3">
+            <a:schemeClr val="accent1"/>
+          </a:fillRef>
+          <a:effectRef idx="2">
+            <a:schemeClr val="accent1"/>
+          </a:effectRef>
+          <a:fontRef idx="minor">
+            <a:schemeClr val="lt1"/>
+          </a:fontRef>
+        </p:style>
+        <p:txBody>
+          <a:bodyPr rtlCol="0" anchor="ctr"/>
+          <a:lstStyle/>
+          <a:p>
+            <a:pPr algn="ctr"/>
+          </a:p>
+        </p:txBody>
+      </p:sp>
+      <p:sp>
+        <p:nvSpPr>
+          <p:cNvPr id="7" name="Rounded Rectangle 6"/>
+          <p:cNvSpPr/>
+          <p:nvPr/>
+        </p:nvSpPr>
+        <p:spPr>
+          <a:xfrm>
+            <a:off x="731520" y="1417320"/>
+            <a:ext cx="3429000" cy="2286000"/>
+          </a:xfrm>
+          <a:prstGeom prst="roundRect">
+            <a:avLst/>
+          </a:prstGeom>
+          <a:solidFill>
+            <a:srgbClr val="F8FAFC"/>
+          </a:solidFill>
+          <a:ln w="19050">
+            <a:solidFill>
+              <a:srgbClr val="E2E8F0"/>
+            </a:solidFill>
+          </a:ln>
+        </p:spPr>
+        <p:style>
+          <a:lnRef idx="1">
+            <a:schemeClr val="accent1"/>
+          </a:lnRef>
+          <a:fillRef idx="3">
+            <a:schemeClr val="accent1"/>
+          </a:fillRef>
+          <a:effectRef idx="2">
+            <a:schemeClr val="accent1"/>
+          </a:effectRef>
+          <a:fontRef idx="minor">
+            <a:schemeClr val="lt1"/>
+          </a:fontRef>
+        </p:style>
+        <p:txBody>
+          <a:bodyPr rtlCol="0" anchor="ctr"/>
+          <a:lstStyle/>
+          <a:p>
+            <a:pPr algn="ctr"/>
+          </a:p>
+        </p:txBody>
+      </p:sp>
+      <p:pic>
+        <p:nvPicPr>
+          <p:cNvPr id="8" name="Picture 7" descr="ferry.jpg"/>
+          <p:cNvPicPr>
+            <a:picLocks noChangeAspect="1"/>
+          </p:cNvPicPr>
+          <p:nvPr/>
+        </p:nvPicPr>
+        <p:blipFill>
+          <a:blip r:embed="rId2"/>
+          <a:stretch>
+            <a:fillRect/>
+          </a:stretch>
+        </p:blipFill>
+        <p:spPr>
+          <a:xfrm>
+            <a:off x="1965960" y="1554480"/>
+            <a:ext cx="960120" cy="960120"/>
+          </a:xfrm>
+          <a:prstGeom prst="rect">
+            <a:avLst/>
+          </a:prstGeom>
+        </p:spPr>
+      </p:pic>
+      <p:sp>
+        <p:nvSpPr>
+          <p:cNvPr id="9" name="Rounded Rectangle 8"/>
+          <p:cNvSpPr/>
+          <p:nvPr/>
+        </p:nvSpPr>
+        <p:spPr>
+          <a:xfrm>
+            <a:off x="982980" y="2587752"/>
+            <a:ext cx="2926080" cy="292608"/>
+          </a:xfrm>
+          <a:prstGeom prst="roundRect">
+            <a:avLst/>
+          </a:prstGeom>
+          <a:solidFill>
+            <a:srgbClr val="980517"/>
+          </a:solidFill>
+          <a:ln w="12700">
+            <a:solidFill>
+              <a:srgbClr val="E2E8F0"/>
+            </a:solidFill>
+          </a:ln>
+        </p:spPr>
+        <p:style>
+          <a:lnRef idx="1">
+            <a:schemeClr val="accent1"/>
+          </a:lnRef>
+          <a:fillRef idx="3">
+            <a:schemeClr val="accent1"/>
+          </a:fillRef>
+          <a:effectRef idx="2">
+            <a:schemeClr val="accent1"/>
+          </a:effectRef>
+          <a:fontRef idx="minor">
+            <a:schemeClr val="lt1"/>
+          </a:fontRef>
+        </p:style>
+        <p:txBody>
+          <a:bodyPr rtlCol="0" anchor="ctr" wrap="none" lIns="0" rIns="0" tIns="0" bIns="0"/>
+          <a:lstStyle/>
+          <a:p>
+            <a:pPr algn="ctr">
+              <a:defRPr sz="850" b="1">
+                <a:solidFill>
+                  <a:srgbClr val="FFFFFF"/>
+                </a:solidFill>
+                <a:latin typeface="Arial"/>
+              </a:defRPr>
+            </a:pPr>
+            <a:r>
+              <a:t>FERRY NOER HENDRIAWAN</a:t>
+            </a:r>
+          </a:p>
+        </p:txBody>
+      </p:sp>
+      <p:sp>
+        <p:nvSpPr>
+          <p:cNvPr id="10" name="TextBox 9"/>
+          <p:cNvSpPr txBox="1"/>
+          <p:nvPr/>
+        </p:nvSpPr>
+        <p:spPr>
+          <a:xfrm>
+            <a:off x="822960" y="2907791"/>
+            <a:ext cx="3246120" cy="685800"/>
+          </a:xfrm>
+          <a:prstGeom prst="rect">
+            <a:avLst/>
+          </a:prstGeom>
+          <a:noFill/>
+        </p:spPr>
+        <p:txBody>
+          <a:bodyPr wrap="square" lIns="0" rIns="0" tIns="0" bIns="0">
+            <a:spAutoFit/>
+          </a:bodyPr>
+          <a:lstStyle/>
+          <a:p>
+            <a:pPr algn="ctr">
+              <a:spcAft>
+                <a:spcPts val="200"/>
+              </a:spcAft>
+              <a:defRPr sz="1000" b="1">
+                <a:solidFill>
+                  <a:srgbClr val="0F172A"/>
+                </a:solidFill>
+                <a:latin typeface="Arial"/>
+              </a:defRPr>
+            </a:pPr>
+            <a:r>
+              <a:t>Frontend Developer</a:t>
+            </a:r>
+          </a:p>
+          <a:p>
+            <a:pPr algn="ctr">
+              <a:defRPr sz="850">
+                <a:solidFill>
+                  <a:srgbClr val="64748B"/>
+                </a:solidFill>
+                <a:latin typeface="Calibri"/>
+              </a:defRPr>
+            </a:pPr>
+            <a:r>
+              <a:t>Blade + Tailwind • Responsive UI • Scanner Client</a:t>
+            </a:r>
+          </a:p>
+        </p:txBody>
+      </p:sp>
+      <p:sp>
+        <p:nvSpPr>
+          <p:cNvPr id="11" name="Rounded Rectangle 10"/>
+          <p:cNvSpPr/>
+          <p:nvPr/>
+        </p:nvSpPr>
+        <p:spPr>
+          <a:xfrm>
+            <a:off x="4370832" y="1417320"/>
+            <a:ext cx="3429000" cy="2286000"/>
+          </a:xfrm>
+          <a:prstGeom prst="roundRect">
+            <a:avLst/>
+          </a:prstGeom>
+          <a:solidFill>
+            <a:srgbClr val="FEF2F2"/>
+          </a:solidFill>
+          <a:ln w="19050">
+            <a:solidFill>
+              <a:srgbClr val="980517"/>
+            </a:solidFill>
+          </a:ln>
+        </p:spPr>
+        <p:style>
+          <a:lnRef idx="1">
+            <a:schemeClr val="accent1"/>
+          </a:lnRef>
+          <a:fillRef idx="3">
+            <a:schemeClr val="accent1"/>
+          </a:fillRef>
+          <a:effectRef idx="2">
+            <a:schemeClr val="accent1"/>
+          </a:effectRef>
+          <a:fontRef idx="minor">
+            <a:schemeClr val="lt1"/>
+          </a:fontRef>
+        </p:style>
+        <p:txBody>
+          <a:bodyPr rtlCol="0" anchor="ctr"/>
+          <a:lstStyle/>
+          <a:p>
+            <a:pPr algn="ctr"/>
+          </a:p>
+        </p:txBody>
+      </p:sp>
+      <p:pic>
+        <p:nvPicPr>
+          <p:cNvPr id="12" name="Picture 11" descr="fhazar.jpg"/>
+          <p:cNvPicPr>
+            <a:picLocks noChangeAspect="1"/>
+          </p:cNvPicPr>
+          <p:nvPr/>
+        </p:nvPicPr>
+        <p:blipFill>
+          <a:blip r:embed="rId3"/>
+          <a:stretch>
+            <a:fillRect/>
+          </a:stretch>
+        </p:blipFill>
+        <p:spPr>
+          <a:xfrm>
+            <a:off x="5605272" y="1554480"/>
+            <a:ext cx="960120" cy="960120"/>
+          </a:xfrm>
+          <a:prstGeom prst="rect">
+            <a:avLst/>
+          </a:prstGeom>
+        </p:spPr>
+      </p:pic>
+      <p:sp>
+        <p:nvSpPr>
+          <p:cNvPr id="13" name="Rounded Rectangle 12"/>
+          <p:cNvSpPr/>
+          <p:nvPr/>
+        </p:nvSpPr>
+        <p:spPr>
+          <a:xfrm>
+            <a:off x="4622292" y="2587752"/>
+            <a:ext cx="2926080" cy="292608"/>
+          </a:xfrm>
+          <a:prstGeom prst="roundRect">
+            <a:avLst/>
+          </a:prstGeom>
+          <a:solidFill>
+            <a:srgbClr val="980517"/>
+          </a:solidFill>
+          <a:ln w="12700">
+            <a:solidFill>
+              <a:srgbClr val="E2E8F0"/>
+            </a:solidFill>
+          </a:ln>
+        </p:spPr>
+        <p:style>
+          <a:lnRef idx="1">
+            <a:schemeClr val="accent1"/>
+          </a:lnRef>
+          <a:fillRef idx="3">
+            <a:schemeClr val="accent1"/>
+          </a:fillRef>
+          <a:effectRef idx="2">
+            <a:schemeClr val="accent1"/>
+          </a:effectRef>
+          <a:fontRef idx="minor">
+            <a:schemeClr val="lt1"/>
+          </a:fontRef>
+        </p:style>
+        <p:txBody>
+          <a:bodyPr rtlCol="0" anchor="ctr" wrap="none" lIns="0" rIns="0" tIns="0" bIns="0"/>
+          <a:lstStyle/>
+          <a:p>
+            <a:pPr algn="ctr">
+              <a:defRPr sz="850" b="1">
+                <a:solidFill>
+                  <a:srgbClr val="FFFFFF"/>
+                </a:solidFill>
+                <a:latin typeface="Arial"/>
+              </a:defRPr>
+            </a:pPr>
+            <a:r>
+              <a:t>FHAZAR RAFFIFUL AQYLA</a:t>
+            </a:r>
+          </a:p>
+        </p:txBody>
+      </p:sp>
+      <p:sp>
+        <p:nvSpPr>
+          <p:cNvPr id="14" name="TextBox 13"/>
+          <p:cNvSpPr txBox="1"/>
+          <p:nvPr/>
+        </p:nvSpPr>
+        <p:spPr>
+          <a:xfrm>
+            <a:off x="4462272" y="2907791"/>
+            <a:ext cx="3246120" cy="685800"/>
+          </a:xfrm>
+          <a:prstGeom prst="rect">
+            <a:avLst/>
+          </a:prstGeom>
+          <a:noFill/>
+        </p:spPr>
+        <p:txBody>
+          <a:bodyPr wrap="square" lIns="0" rIns="0" tIns="0" bIns="0">
+            <a:spAutoFit/>
+          </a:bodyPr>
+          <a:lstStyle/>
+          <a:p>
+            <a:pPr algn="ctr">
+              <a:spcAft>
+                <a:spcPts val="200"/>
+              </a:spcAft>
+              <a:defRPr sz="1000" b="1">
+                <a:solidFill>
+                  <a:srgbClr val="980517"/>
+                </a:solidFill>
+                <a:latin typeface="Arial"/>
+              </a:defRPr>
+            </a:pPr>
+            <a:r>
+              <a:t>Project Manager</a:t>
+            </a:r>
+          </a:p>
+          <a:p>
+            <a:pPr algn="ctr">
+              <a:defRPr sz="850">
+                <a:solidFill>
+                  <a:srgbClr val="64748B"/>
+                </a:solidFill>
+                <a:latin typeface="Calibri"/>
+              </a:defRPr>
+            </a:pPr>
+            <a:r>
+              <a:t>Scrum Master • Product Roadmap • SCM Strategy</a:t>
+            </a:r>
+          </a:p>
+        </p:txBody>
+      </p:sp>
+      <p:sp>
+        <p:nvSpPr>
+          <p:cNvPr id="15" name="Rounded Rectangle 14"/>
+          <p:cNvSpPr/>
+          <p:nvPr/>
+        </p:nvSpPr>
+        <p:spPr>
+          <a:xfrm>
+            <a:off x="8010144" y="1417320"/>
+            <a:ext cx="3429000" cy="2286000"/>
+          </a:xfrm>
+          <a:prstGeom prst="roundRect">
+            <a:avLst/>
+          </a:prstGeom>
+          <a:solidFill>
+            <a:srgbClr val="F8FAFC"/>
+          </a:solidFill>
+          <a:ln w="19050">
+            <a:solidFill>
+              <a:srgbClr val="E2E8F0"/>
+            </a:solidFill>
+          </a:ln>
+        </p:spPr>
+        <p:style>
+          <a:lnRef idx="1">
+            <a:schemeClr val="accent1"/>
+          </a:lnRef>
+          <a:fillRef idx="3">
+            <a:schemeClr val="accent1"/>
+          </a:fillRef>
+          <a:effectRef idx="2">
+            <a:schemeClr val="accent1"/>
+          </a:effectRef>
+          <a:fontRef idx="minor">
+            <a:schemeClr val="lt1"/>
+          </a:fontRef>
+        </p:style>
+        <p:txBody>
+          <a:bodyPr rtlCol="0" anchor="ctr"/>
+          <a:lstStyle/>
+          <a:p>
+            <a:pPr algn="ctr"/>
+          </a:p>
+        </p:txBody>
+      </p:sp>
+      <p:pic>
+        <p:nvPicPr>
+          <p:cNvPr id="16" name="Picture 15" descr="hildan.png"/>
+          <p:cNvPicPr>
+            <a:picLocks noChangeAspect="1"/>
+          </p:cNvPicPr>
+          <p:nvPr/>
+        </p:nvPicPr>
+        <p:blipFill>
+          <a:blip r:embed="rId4"/>
+          <a:stretch>
+            <a:fillRect/>
+          </a:stretch>
+        </p:blipFill>
+        <p:spPr>
+          <a:xfrm>
+            <a:off x="9244584" y="1554480"/>
+            <a:ext cx="960120" cy="960120"/>
+          </a:xfrm>
+          <a:prstGeom prst="rect">
+            <a:avLst/>
+          </a:prstGeom>
+        </p:spPr>
+      </p:pic>
+      <p:sp>
+        <p:nvSpPr>
+          <p:cNvPr id="17" name="Rounded Rectangle 16"/>
+          <p:cNvSpPr/>
+          <p:nvPr/>
+        </p:nvSpPr>
+        <p:spPr>
+          <a:xfrm>
+            <a:off x="8261604" y="2587752"/>
+            <a:ext cx="2926080" cy="292608"/>
+          </a:xfrm>
+          <a:prstGeom prst="roundRect">
+            <a:avLst/>
+          </a:prstGeom>
+          <a:solidFill>
+            <a:srgbClr val="980517"/>
+          </a:solidFill>
+          <a:ln w="12700">
+            <a:solidFill>
+              <a:srgbClr val="E2E8F0"/>
+            </a:solidFill>
+          </a:ln>
+        </p:spPr>
+        <p:style>
+          <a:lnRef idx="1">
+            <a:schemeClr val="accent1"/>
+          </a:lnRef>
+          <a:fillRef idx="3">
+            <a:schemeClr val="accent1"/>
+          </a:fillRef>
+          <a:effectRef idx="2">
+            <a:schemeClr val="accent1"/>
+          </a:effectRef>
+          <a:fontRef idx="minor">
+            <a:schemeClr val="lt1"/>
+          </a:fontRef>
+        </p:style>
+        <p:txBody>
+          <a:bodyPr rtlCol="0" anchor="ctr" wrap="none" lIns="0" rIns="0" tIns="0" bIns="0"/>
+          <a:lstStyle/>
+          <a:p>
+            <a:pPr algn="ctr">
+              <a:defRPr sz="850" b="1">
+                <a:solidFill>
+                  <a:srgbClr val="FFFFFF"/>
+                </a:solidFill>
+                <a:latin typeface="Arial"/>
+              </a:defRPr>
+            </a:pPr>
+            <a:r>
+              <a:t>HILDAN ANUGRAH TAMADI PUTRA</a:t>
+            </a:r>
+          </a:p>
+        </p:txBody>
+      </p:sp>
+      <p:sp>
+        <p:nvSpPr>
+          <p:cNvPr id="18" name="TextBox 17"/>
+          <p:cNvSpPr txBox="1"/>
+          <p:nvPr/>
+        </p:nvSpPr>
+        <p:spPr>
+          <a:xfrm>
+            <a:off x="8101583" y="2907791"/>
+            <a:ext cx="3246120" cy="685800"/>
+          </a:xfrm>
+          <a:prstGeom prst="rect">
+            <a:avLst/>
+          </a:prstGeom>
+          <a:noFill/>
+        </p:spPr>
+        <p:txBody>
+          <a:bodyPr wrap="square" lIns="0" rIns="0" tIns="0" bIns="0">
+            <a:spAutoFit/>
+          </a:bodyPr>
+          <a:lstStyle/>
+          <a:p>
+            <a:pPr algn="ctr">
+              <a:spcAft>
+                <a:spcPts val="200"/>
+              </a:spcAft>
+              <a:defRPr sz="1000" b="1">
+                <a:solidFill>
+                  <a:srgbClr val="0F172A"/>
+                </a:solidFill>
+                <a:latin typeface="Arial"/>
+              </a:defRPr>
+            </a:pPr>
+            <a:r>
+              <a:t>Backend Developer</a:t>
+            </a:r>
+          </a:p>
+          <a:p>
+            <a:pPr algn="ctr">
+              <a:defRPr sz="850">
+                <a:solidFill>
+                  <a:srgbClr val="64748B"/>
+                </a:solidFill>
+                <a:latin typeface="Calibri"/>
+              </a:defRPr>
+            </a:pPr>
+            <a:r>
+              <a:t>Laravel 12 • FIFO Engine • Pessimistic Lock</a:t>
+            </a:r>
+          </a:p>
+        </p:txBody>
+      </p:sp>
+      <p:sp>
+        <p:nvSpPr>
+          <p:cNvPr id="19" name="Rounded Rectangle 18"/>
+          <p:cNvSpPr/>
+          <p:nvPr/>
+        </p:nvSpPr>
+        <p:spPr>
+          <a:xfrm>
+            <a:off x="731520" y="3886200"/>
+            <a:ext cx="3429000" cy="2286000"/>
+          </a:xfrm>
+          <a:prstGeom prst="roundRect">
+            <a:avLst/>
+          </a:prstGeom>
+          <a:solidFill>
+            <a:srgbClr val="F8FAFC"/>
+          </a:solidFill>
+          <a:ln w="19050">
+            <a:solidFill>
+              <a:srgbClr val="E2E8F0"/>
+            </a:solidFill>
+          </a:ln>
+        </p:spPr>
+        <p:style>
+          <a:lnRef idx="1">
+            <a:schemeClr val="accent1"/>
+          </a:lnRef>
+          <a:fillRef idx="3">
+            <a:schemeClr val="accent1"/>
+          </a:fillRef>
+          <a:effectRef idx="2">
+            <a:schemeClr val="accent1"/>
+          </a:effectRef>
+          <a:fontRef idx="minor">
+            <a:schemeClr val="lt1"/>
+          </a:fontRef>
+        </p:style>
+        <p:txBody>
+          <a:bodyPr rtlCol="0" anchor="ctr"/>
+          <a:lstStyle/>
+          <a:p>
+            <a:pPr algn="ctr"/>
+          </a:p>
+        </p:txBody>
+      </p:sp>
+      <p:pic>
+        <p:nvPicPr>
+          <p:cNvPr id="20" name="Picture 19" descr="fadel.png"/>
+          <p:cNvPicPr>
+            <a:picLocks noChangeAspect="1"/>
+          </p:cNvPicPr>
+          <p:nvPr/>
+        </p:nvPicPr>
+        <p:blipFill>
+          <a:blip r:embed="rId5"/>
+          <a:stretch>
+            <a:fillRect/>
+          </a:stretch>
+        </p:blipFill>
+        <p:spPr>
+          <a:xfrm>
+            <a:off x="1965960" y="4023360"/>
+            <a:ext cx="960120" cy="960120"/>
+          </a:xfrm>
+          <a:prstGeom prst="rect">
+            <a:avLst/>
+          </a:prstGeom>
+        </p:spPr>
+      </p:pic>
+      <p:sp>
+        <p:nvSpPr>
+          <p:cNvPr id="21" name="Rounded Rectangle 20"/>
+          <p:cNvSpPr/>
+          <p:nvPr/>
+        </p:nvSpPr>
+        <p:spPr>
+          <a:xfrm>
+            <a:off x="982980" y="5056632"/>
+            <a:ext cx="2926080" cy="292608"/>
+          </a:xfrm>
+          <a:prstGeom prst="roundRect">
+            <a:avLst/>
+          </a:prstGeom>
+          <a:solidFill>
+            <a:srgbClr val="980517"/>
+          </a:solidFill>
+          <a:ln w="12700">
+            <a:solidFill>
+              <a:srgbClr val="E2E8F0"/>
+            </a:solidFill>
+          </a:ln>
+        </p:spPr>
+        <p:style>
+          <a:lnRef idx="1">
+            <a:schemeClr val="accent1"/>
+          </a:lnRef>
+          <a:fillRef idx="3">
+            <a:schemeClr val="accent1"/>
+          </a:fillRef>
+          <a:effectRef idx="2">
+            <a:schemeClr val="accent1"/>
+          </a:effectRef>
+          <a:fontRef idx="minor">
+            <a:schemeClr val="lt1"/>
+          </a:fontRef>
+        </p:style>
+        <p:txBody>
+          <a:bodyPr rtlCol="0" anchor="ctr" wrap="none" lIns="0" rIns="0" tIns="0" bIns="0"/>
+          <a:lstStyle/>
+          <a:p>
+            <a:pPr algn="ctr">
+              <a:defRPr sz="850" b="1">
+                <a:solidFill>
+                  <a:srgbClr val="FFFFFF"/>
+                </a:solidFill>
+                <a:latin typeface="Arial"/>
+              </a:defRPr>
+            </a:pPr>
+            <a:r>
+              <a:t>FADEL RAHMADHAN</a:t>
+            </a:r>
+          </a:p>
+        </p:txBody>
+      </p:sp>
+      <p:sp>
+        <p:nvSpPr>
+          <p:cNvPr id="22" name="TextBox 21"/>
+          <p:cNvSpPr txBox="1"/>
+          <p:nvPr/>
+        </p:nvSpPr>
+        <p:spPr>
+          <a:xfrm>
+            <a:off x="822960" y="5376672"/>
+            <a:ext cx="3246120" cy="685800"/>
+          </a:xfrm>
+          <a:prstGeom prst="rect">
+            <a:avLst/>
+          </a:prstGeom>
+          <a:noFill/>
+        </p:spPr>
+        <p:txBody>
+          <a:bodyPr wrap="square" lIns="0" rIns="0" tIns="0" bIns="0">
+            <a:spAutoFit/>
+          </a:bodyPr>
+          <a:lstStyle/>
+          <a:p>
+            <a:pPr algn="ctr">
+              <a:spcAft>
+                <a:spcPts val="200"/>
+              </a:spcAft>
+              <a:defRPr sz="1000" b="1">
+                <a:solidFill>
+                  <a:srgbClr val="0F172A"/>
+                </a:solidFill>
+                <a:latin typeface="Arial"/>
+              </a:defRPr>
+            </a:pPr>
+            <a:r>
+              <a:t>Quality Assurance</a:t>
+            </a:r>
+          </a:p>
+          <a:p>
+            <a:pPr algn="ctr">
+              <a:defRPr sz="850">
+                <a:solidFill>
+                  <a:srgbClr val="64748B"/>
+                </a:solidFill>
+                <a:latin typeface="Calibri"/>
+              </a:defRPr>
+            </a:pPr>
+            <a:r>
+              <a:t>Blackbox Testing • Stress Load • Anti-Double Claim</a:t>
+            </a:r>
+          </a:p>
+        </p:txBody>
+      </p:sp>
+      <p:sp>
+        <p:nvSpPr>
+          <p:cNvPr id="23" name="Rounded Rectangle 22"/>
+          <p:cNvSpPr/>
+          <p:nvPr/>
+        </p:nvSpPr>
+        <p:spPr>
+          <a:xfrm>
+            <a:off x="4370832" y="3886200"/>
+            <a:ext cx="3429000" cy="2286000"/>
+          </a:xfrm>
+          <a:prstGeom prst="roundRect">
+            <a:avLst/>
+          </a:prstGeom>
+          <a:solidFill>
+            <a:srgbClr val="F8FAFC"/>
+          </a:solidFill>
+          <a:ln w="19050">
+            <a:solidFill>
+              <a:srgbClr val="E2E8F0"/>
+            </a:solidFill>
+          </a:ln>
+        </p:spPr>
+        <p:style>
+          <a:lnRef idx="1">
+            <a:schemeClr val="accent1"/>
+          </a:lnRef>
+          <a:fillRef idx="3">
+            <a:schemeClr val="accent1"/>
+          </a:fillRef>
+          <a:effectRef idx="2">
+            <a:schemeClr val="accent1"/>
+          </a:effectRef>
+          <a:fontRef idx="minor">
+            <a:schemeClr val="lt1"/>
+          </a:fontRef>
+        </p:style>
+        <p:txBody>
+          <a:bodyPr rtlCol="0" anchor="ctr"/>
+          <a:lstStyle/>
+          <a:p>
+            <a:pPr algn="ctr"/>
+          </a:p>
+        </p:txBody>
+      </p:sp>
+      <p:pic>
+        <p:nvPicPr>
+          <p:cNvPr id="24" name="Picture 23" descr="daffa.jpg"/>
+          <p:cNvPicPr>
+            <a:picLocks noChangeAspect="1"/>
+          </p:cNvPicPr>
+          <p:nvPr/>
+        </p:nvPicPr>
+        <p:blipFill>
+          <a:blip r:embed="rId6"/>
+          <a:stretch>
+            <a:fillRect/>
+          </a:stretch>
+        </p:blipFill>
+        <p:spPr>
+          <a:xfrm>
+            <a:off x="5605272" y="4023360"/>
+            <a:ext cx="960120" cy="960120"/>
+          </a:xfrm>
+          <a:prstGeom prst="rect">
+            <a:avLst/>
+          </a:prstGeom>
+        </p:spPr>
+      </p:pic>
+      <p:sp>
+        <p:nvSpPr>
+          <p:cNvPr id="25" name="Rounded Rectangle 24"/>
+          <p:cNvSpPr/>
+          <p:nvPr/>
+        </p:nvSpPr>
+        <p:spPr>
+          <a:xfrm>
+            <a:off x="4622292" y="5056632"/>
+            <a:ext cx="2926080" cy="292608"/>
+          </a:xfrm>
+          <a:prstGeom prst="roundRect">
+            <a:avLst/>
+          </a:prstGeom>
+          <a:solidFill>
+            <a:srgbClr val="980517"/>
+          </a:solidFill>
+          <a:ln w="12700">
+            <a:solidFill>
+              <a:srgbClr val="E2E8F0"/>
+            </a:solidFill>
+          </a:ln>
+        </p:spPr>
+        <p:style>
+          <a:lnRef idx="1">
+            <a:schemeClr val="accent1"/>
+          </a:lnRef>
+          <a:fillRef idx="3">
+            <a:schemeClr val="accent1"/>
+          </a:fillRef>
+          <a:effectRef idx="2">
+            <a:schemeClr val="accent1"/>
+          </a:effectRef>
+          <a:fontRef idx="minor">
+            <a:schemeClr val="lt1"/>
+          </a:fontRef>
+        </p:style>
+        <p:txBody>
+          <a:bodyPr rtlCol="0" anchor="ctr" wrap="none" lIns="0" rIns="0" tIns="0" bIns="0"/>
+          <a:lstStyle/>
+          <a:p>
+            <a:pPr algn="ctr">
+              <a:defRPr sz="850" b="1">
+                <a:solidFill>
+                  <a:srgbClr val="FFFFFF"/>
+                </a:solidFill>
+                <a:latin typeface="Arial"/>
+              </a:defRPr>
+            </a:pPr>
+            <a:r>
+              <a:t>DAFFA NAZRIEL ZAIDAN</a:t>
+            </a:r>
+          </a:p>
+        </p:txBody>
+      </p:sp>
+      <p:sp>
+        <p:nvSpPr>
+          <p:cNvPr id="26" name="TextBox 25"/>
+          <p:cNvSpPr txBox="1"/>
+          <p:nvPr/>
+        </p:nvSpPr>
+        <p:spPr>
+          <a:xfrm>
+            <a:off x="4462272" y="5376672"/>
+            <a:ext cx="3246120" cy="685800"/>
+          </a:xfrm>
+          <a:prstGeom prst="rect">
+            <a:avLst/>
+          </a:prstGeom>
+          <a:noFill/>
+        </p:spPr>
+        <p:txBody>
+          <a:bodyPr wrap="square" lIns="0" rIns="0" tIns="0" bIns="0">
+            <a:spAutoFit/>
+          </a:bodyPr>
+          <a:lstStyle/>
+          <a:p>
+            <a:pPr algn="ctr">
+              <a:spcAft>
+                <a:spcPts val="200"/>
+              </a:spcAft>
+              <a:defRPr sz="1000" b="1">
+                <a:solidFill>
+                  <a:srgbClr val="0F172A"/>
+                </a:solidFill>
+                <a:latin typeface="Arial"/>
+              </a:defRPr>
+            </a:pPr>
+            <a:r>
+              <a:t>UI/UX Designer</a:t>
+            </a:r>
+          </a:p>
+          <a:p>
+            <a:pPr algn="ctr">
+              <a:defRPr sz="850">
+                <a:solidFill>
+                  <a:srgbClr val="64748B"/>
+                </a:solidFill>
+                <a:latin typeface="Calibri"/>
+              </a:defRPr>
+            </a:pPr>
+            <a:r>
+              <a:t>Neo-Brutalist Design • Student Flow • Usability Test</a:t>
+            </a:r>
+          </a:p>
+        </p:txBody>
+      </p:sp>
+      <p:sp>
+        <p:nvSpPr>
+          <p:cNvPr id="27" name="Rounded Rectangle 26"/>
+          <p:cNvSpPr/>
+          <p:nvPr/>
+        </p:nvSpPr>
+        <p:spPr>
+          <a:xfrm>
+            <a:off x="8010144" y="3886200"/>
+            <a:ext cx="3429000" cy="2286000"/>
+          </a:xfrm>
+          <a:prstGeom prst="roundRect">
+            <a:avLst/>
+          </a:prstGeom>
+          <a:solidFill>
+            <a:srgbClr val="F8FAFC"/>
+          </a:solidFill>
+          <a:ln w="19050">
+            <a:solidFill>
+              <a:srgbClr val="E2E8F0"/>
+            </a:solidFill>
+          </a:ln>
+        </p:spPr>
+        <p:style>
+          <a:lnRef idx="1">
+            <a:schemeClr val="accent1"/>
+          </a:lnRef>
+          <a:fillRef idx="3">
+            <a:schemeClr val="accent1"/>
+          </a:fillRef>
+          <a:effectRef idx="2">
+            <a:schemeClr val="accent1"/>
+          </a:effectRef>
+          <a:fontRef idx="minor">
+            <a:schemeClr val="lt1"/>
+          </a:fontRef>
+        </p:style>
+        <p:txBody>
+          <a:bodyPr rtlCol="0" anchor="ctr"/>
+          <a:lstStyle/>
+          <a:p>
+            <a:pPr algn="ctr"/>
+          </a:p>
+        </p:txBody>
+      </p:sp>
+      <p:pic>
+        <p:nvPicPr>
+          <p:cNvPr id="28" name="Picture 27" descr="acep.png"/>
+          <p:cNvPicPr>
+            <a:picLocks noChangeAspect="1"/>
+          </p:cNvPicPr>
+          <p:nvPr/>
+        </p:nvPicPr>
+        <p:blipFill>
+          <a:blip r:embed="rId7"/>
+          <a:stretch>
+            <a:fillRect/>
+          </a:stretch>
+        </p:blipFill>
+        <p:spPr>
+          <a:xfrm>
+            <a:off x="9244584" y="4023360"/>
+            <a:ext cx="960120" cy="960120"/>
+          </a:xfrm>
+          <a:prstGeom prst="rect">
+            <a:avLst/>
+          </a:prstGeom>
+        </p:spPr>
+      </p:pic>
+      <p:sp>
+        <p:nvSpPr>
+          <p:cNvPr id="29" name="Rounded Rectangle 28"/>
+          <p:cNvSpPr/>
+          <p:nvPr/>
+        </p:nvSpPr>
+        <p:spPr>
+          <a:xfrm>
+            <a:off x="8261604" y="5056632"/>
+            <a:ext cx="2926080" cy="292608"/>
+          </a:xfrm>
+          <a:prstGeom prst="roundRect">
+            <a:avLst/>
+          </a:prstGeom>
+          <a:solidFill>
+            <a:srgbClr val="980517"/>
+          </a:solidFill>
+          <a:ln w="12700">
+            <a:solidFill>
+              <a:srgbClr val="E2E8F0"/>
+            </a:solidFill>
+          </a:ln>
+        </p:spPr>
+        <p:style>
+          <a:lnRef idx="1">
+            <a:schemeClr val="accent1"/>
+          </a:lnRef>
+          <a:fillRef idx="3">
+            <a:schemeClr val="accent1"/>
+          </a:fillRef>
+          <a:effectRef idx="2">
+            <a:schemeClr val="accent1"/>
+          </a:effectRef>
+          <a:fontRef idx="minor">
+            <a:schemeClr val="lt1"/>
+          </a:fontRef>
+        </p:style>
+        <p:txBody>
+          <a:bodyPr rtlCol="0" anchor="ctr" wrap="none" lIns="0" rIns="0" tIns="0" bIns="0"/>
+          <a:lstStyle/>
+          <a:p>
+            <a:pPr algn="ctr">
+              <a:defRPr sz="850" b="1">
+                <a:solidFill>
+                  <a:srgbClr val="FFFFFF"/>
+                </a:solidFill>
+                <a:latin typeface="Arial"/>
+              </a:defRPr>
+            </a:pPr>
+            <a:r>
+              <a:t>ACEP UGAN SAPUTRA</a:t>
+            </a:r>
+          </a:p>
+        </p:txBody>
+      </p:sp>
+      <p:sp>
+        <p:nvSpPr>
+          <p:cNvPr id="30" name="TextBox 29"/>
+          <p:cNvSpPr txBox="1"/>
+          <p:nvPr/>
+        </p:nvSpPr>
+        <p:spPr>
+          <a:xfrm>
+            <a:off x="8101583" y="5376672"/>
+            <a:ext cx="3246120" cy="685800"/>
+          </a:xfrm>
+          <a:prstGeom prst="rect">
+            <a:avLst/>
+          </a:prstGeom>
+          <a:noFill/>
+        </p:spPr>
+        <p:txBody>
+          <a:bodyPr wrap="square" lIns="0" rIns="0" tIns="0" bIns="0">
+            <a:spAutoFit/>
+          </a:bodyPr>
+          <a:lstStyle/>
+          <a:p>
+            <a:pPr algn="ctr">
+              <a:spcAft>
+                <a:spcPts val="200"/>
+              </a:spcAft>
+              <a:defRPr sz="1000" b="1">
+                <a:solidFill>
+                  <a:srgbClr val="0F172A"/>
+                </a:solidFill>
+                <a:latin typeface="Arial"/>
+              </a:defRPr>
+            </a:pPr>
+            <a:r>
+              <a:t>System Analyst</a:t>
+            </a:r>
+          </a:p>
+          <a:p>
+            <a:pPr algn="ctr">
+              <a:defRPr sz="850">
+                <a:solidFill>
+                  <a:srgbClr val="64748B"/>
+                </a:solidFill>
+                <a:latin typeface="Calibri"/>
+              </a:defRPr>
+            </a:pPr>
+            <a:r>
+              <a:t>BPMN Process • Relational Database • SCM Audit Trail</a:t>
+            </a:r>
+          </a:p>
+        </p:txBody>
+      </p:sp>
+    </p:spTree>
+  </p:cSld>
+  <p:clrMapOvr>
+    <a:masterClrMapping/>
+  </p:clrMapOvr>
+</p:sld>
+</file>
+
+<file path=ppt/slides/slide3.xml><?xml version="1.0" encoding="utf-8"?>
+<p:sld xmlns:a="http://schemas.openxmlformats.org/drawingml/2006/main" xmlns:p="http://schemas.openxmlformats.org/presentationml/2006/main" xmlns:r="http://schemas.openxmlformats.org/officeDocument/2006/relationships">
+  <p:cSld>
+    <p:bg>
+      <p:bgPr>
+        <a:solidFill>
+          <a:srgbClr val="FFFFFF"/>
+        </a:solidFill>
+        <a:effectLst/>
+      </p:bgPr>
+    </p:bg>
+    <p:spTree>
+      <p:nvGrpSpPr>
+        <p:cNvPr id="1" name=""/>
+        <p:cNvGrpSpPr/>
+        <p:nvPr/>
+      </p:nvGrpSpPr>
+      <p:grpSpPr/>
+      <p:sp>
+        <p:nvSpPr>
+          <p:cNvPr id="2" name="Rectangle 1"/>
+          <p:cNvSpPr/>
+          <p:nvPr/>
+        </p:nvSpPr>
+        <p:spPr>
+          <a:xfrm>
+            <a:off x="731520" y="384048"/>
+            <a:ext cx="54864" cy="713232"/>
+          </a:xfrm>
+          <a:prstGeom prst="rect">
+            <a:avLst/>
+          </a:prstGeom>
+          <a:solidFill>
+            <a:srgbClr val="980517"/>
+          </a:solidFill>
+          <a:ln>
+            <a:noFill/>
+          </a:ln>
+        </p:spPr>
+        <p:style>
+          <a:lnRef idx="1">
+            <a:schemeClr val="accent1"/>
+          </a:lnRef>
+          <a:fillRef idx="3">
+            <a:schemeClr val="accent1"/>
+          </a:fillRef>
+          <a:effectRef idx="2">
+            <a:schemeClr val="accent1"/>
+          </a:effectRef>
+          <a:fontRef idx="minor">
+            <a:schemeClr val="lt1"/>
+          </a:fontRef>
+        </p:style>
+        <p:txBody>
+          <a:bodyPr rtlCol="0" anchor="ctr"/>
+          <a:lstStyle/>
+          <a:p>
+            <a:pPr algn="ctr"/>
+          </a:p>
+        </p:txBody>
+      </p:sp>
+      <p:sp>
+        <p:nvSpPr>
+          <p:cNvPr id="3" name="TextBox 2"/>
+          <p:cNvSpPr txBox="1"/>
+          <p:nvPr/>
+        </p:nvSpPr>
+        <p:spPr>
+          <a:xfrm>
+            <a:off x="868680" y="347472"/>
+            <a:ext cx="10515600" cy="219456"/>
+          </a:xfrm>
+          <a:prstGeom prst="rect">
+            <a:avLst/>
+          </a:prstGeom>
+          <a:noFill/>
+        </p:spPr>
+        <p:txBody>
+          <a:bodyPr wrap="square">
+            <a:spAutoFit/>
+          </a:bodyPr>
+          <a:lstStyle/>
+          <a:p>
+            <a:pPr>
+              <a:defRPr sz="950" b="1">
+                <a:solidFill>
+                  <a:srgbClr val="980517"/>
+                </a:solidFill>
+                <a:latin typeface="Arial"/>
+              </a:defRPr>
+            </a:pPr>
+            <a:r>
               <a:t>STRUKTUR RANTAI PASOK</a:t>
             </a:r>
           </a:p>
@@ -5569,7 +6958,7 @@
 </p:sld>
 </file>
 
-<file path=ppt/slides/slide3.xml><?xml version="1.0" encoding="utf-8"?>
+<file path=ppt/slides/slide4.xml><?xml version="1.0" encoding="utf-8"?>
 <p:sld xmlns:a="http://schemas.openxmlformats.org/drawingml/2006/main" xmlns:p="http://schemas.openxmlformats.org/presentationml/2006/main" xmlns:r="http://schemas.openxmlformats.org/officeDocument/2006/relationships">
   <p:cSld>
     <p:bg>
@@ -6186,7 +7575,7 @@
 </p:sld>
 </file>
 
-<file path=ppt/slides/slide4.xml><?xml version="1.0" encoding="utf-8"?>
+<file path=ppt/slides/slide5.xml><?xml version="1.0" encoding="utf-8"?>
 <p:sld xmlns:a="http://schemas.openxmlformats.org/drawingml/2006/main" xmlns:p="http://schemas.openxmlformats.org/presentationml/2006/main" xmlns:r="http://schemas.openxmlformats.org/officeDocument/2006/relationships">
   <p:cSld>
     <p:bg>
@@ -6882,7 +8271,7 @@
 </p:sld>
 </file>
 
-<file path=ppt/slides/slide5.xml><?xml version="1.0" encoding="utf-8"?>
+<file path=ppt/slides/slide6.xml><?xml version="1.0" encoding="utf-8"?>
 <p:sld xmlns:a="http://schemas.openxmlformats.org/drawingml/2006/main" xmlns:p="http://schemas.openxmlformats.org/presentationml/2006/main" xmlns:r="http://schemas.openxmlformats.org/officeDocument/2006/relationships">
   <p:cSld>
     <p:bg>
@@ -7620,7 +9009,7 @@
 </p:sld>
 </file>
 
-<file path=ppt/slides/slide6.xml><?xml version="1.0" encoding="utf-8"?>
+<file path=ppt/slides/slide7.xml><?xml version="1.0" encoding="utf-8"?>
 <p:sld xmlns:a="http://schemas.openxmlformats.org/drawingml/2006/main" xmlns:p="http://schemas.openxmlformats.org/presentationml/2006/main" xmlns:r="http://schemas.openxmlformats.org/officeDocument/2006/relationships">
   <p:cSld>
     <p:bg>
@@ -8380,7 +9769,7 @@
 </p:sld>
 </file>
 
-<file path=ppt/slides/slide7.xml><?xml version="1.0" encoding="utf-8"?>
+<file path=ppt/slides/slide8.xml><?xml version="1.0" encoding="utf-8"?>
 <p:sld xmlns:a="http://schemas.openxmlformats.org/drawingml/2006/main" xmlns:p="http://schemas.openxmlformats.org/presentationml/2006/main" xmlns:r="http://schemas.openxmlformats.org/officeDocument/2006/relationships">
   <p:cSld>
     <p:bg>
@@ -8870,7 +10259,7 @@
 </p:sld>
 </file>
 
-<file path=ppt/slides/slide8.xml><?xml version="1.0" encoding="utf-8"?>
+<file path=ppt/slides/slide9.xml><?xml version="1.0" encoding="utf-8"?>
 <p:sld xmlns:a="http://schemas.openxmlformats.org/drawingml/2006/main" xmlns:p="http://schemas.openxmlformats.org/presentationml/2006/main" xmlns:r="http://schemas.openxmlformats.org/officeDocument/2006/relationships">
   <p:cSld>
     <p:bg>

</xml_diff>